<commit_message>
feat: add non-web evidence scripts (cURL CLI, SQL Server direct query) and updated slides
</commit_message>
<xml_diff>
--- a/Slide_OWASP_SQL_Injection.pptx
+++ b/Slide_OWASP_SQL_Injection.pptx
@@ -11,6 +11,8 @@
     <p:sldId id="259" r:id="rId10"/>
     <p:sldId id="260" r:id="rId11"/>
     <p:sldId id="261" r:id="rId12"/>
+    <p:sldId id="262" r:id="rId13"/>
+    <p:sldId id="263" r:id="rId14"/>
   </p:sldIdLst>
   <p:sldSz cx="12191695" cy="6858000" type="screen4x3"/>
   <p:notesSz cx="6858000" cy="9144000"/>
@@ -3108,7 +3110,7 @@
             <a:avLst/>
           </a:prstGeom>
           <a:solidFill>
-            <a:srgbClr val="1A202C"/>
+            <a:srgbClr val="0F172A"/>
           </a:solidFill>
           <a:ln>
             <a:noFill/>
@@ -3189,7 +3191,7 @@
               <a:spcBef>
                 <a:spcPts val="800"/>
               </a:spcBef>
-              <a:defRPr sz="2800" b="1">
+              <a:defRPr sz="2600" b="1">
                 <a:solidFill>
                   <a:srgbClr val="FFFFFF"/>
                 </a:solidFill>
@@ -3200,7 +3202,7 @@
             </a:r>
             <a:br/>
             <a:r>
-              <a:t>Kịch Bản Tấn Công &amp; Cơ Chế Phòng Thủ Trực Quan Trên ASP.NET Core</a:t>
+              <a:t>Kịch Bản Tấn Công &amp; Phòng Thủ Đa Tầng (Web UI, API CLI &amp; CSDL SQL Server 2025)</a:t>
             </a:r>
           </a:p>
           <a:p>
@@ -3278,13 +3280,13 @@
         <p:spPr>
           <a:xfrm>
             <a:off x="0" y="0"/>
-            <a:ext cx="12191695" cy="1097280"/>
+            <a:ext cx="12191695" cy="1005840"/>
           </a:xfrm>
           <a:prstGeom prst="rect">
             <a:avLst/>
           </a:prstGeom>
           <a:solidFill>
-            <a:srgbClr val="1A202C"/>
+            <a:srgbClr val="0F172A"/>
           </a:solidFill>
           <a:ln>
             <a:noFill/>
@@ -3320,7 +3322,7 @@
         </p:nvSpPr>
         <p:spPr>
           <a:xfrm>
-            <a:off x="731520" y="137160"/>
+            <a:off x="731520" y="109728"/>
             <a:ext cx="10698480" cy="320040"/>
           </a:xfrm>
           <a:prstGeom prst="rect">
@@ -3347,7 +3349,7 @@
           </a:p>
           <a:p>
             <a:pPr>
-              <a:defRPr sz="2000" b="1">
+              <a:defRPr sz="1900" b="1">
                 <a:solidFill>
                   <a:srgbClr val="FFFFFF"/>
                 </a:solidFill>
@@ -3367,8 +3369,8 @@
         </p:nvSpPr>
         <p:spPr>
           <a:xfrm>
-            <a:off x="731520" y="6446520"/>
-            <a:ext cx="10698480" cy="320040"/>
+            <a:off x="731520" y="6492240"/>
+            <a:ext cx="10698480" cy="274320"/>
           </a:xfrm>
           <a:prstGeom prst="rect">
             <a:avLst/>
@@ -3382,7 +3384,7 @@
           <a:lstStyle/>
           <a:p>
             <a:pPr>
-              <a:defRPr sz="1000">
+              <a:defRPr sz="950">
                 <a:solidFill>
                   <a:srgbClr val="64748B"/>
                 </a:solidFill>
@@ -3402,8 +3404,8 @@
         </p:nvSpPr>
         <p:spPr>
           <a:xfrm>
-            <a:off x="731520" y="1371600"/>
-            <a:ext cx="5120640" cy="4754880"/>
+            <a:off x="731520" y="1188720"/>
+            <a:ext cx="5120640" cy="4937760"/>
           </a:xfrm>
           <a:prstGeom prst="rect">
             <a:avLst/>
@@ -3443,17 +3445,17 @@
             </a:r>
             <a:br/>
             <a:r>
-              <a:t>• Lập trình viên ghép chuỗi đầu vào của người dùng trực tiếp vào câu lệnh SQL.</a:t>
+              <a:t>• Ghép chuỗi trực tiếp từ Request vào câu lệnh SQL khiến hệ CSDL không phân biệt được đâu là dữ liệu của user và đâu là cấu trúc lệnh của lập trình viên.</a:t>
             </a:r>
             <a:br/>
             <a:r>
-              <a:t>• Kẻ tấn công lợi dụng các ký tự điều khiển (', --, /*, ;) để 'thoát' khỏi ngữ cảnh dữ liệu và ép SQL Server thực thi logic do hacker chỉ định.</a:t>
+              <a:t>• Kẻ tấn công lợi dụng các ký tự điều khiển (', --, /*, ;) để 'thoát' khỏi ngữ cảnh dữ liệu và ép SQL Server thực thi logic của hacker.</a:t>
             </a:r>
           </a:p>
           <a:p>
             <a:pPr>
               <a:spcBef>
-                <a:spcPts val="1600"/>
+                <a:spcPts val="1400"/>
               </a:spcBef>
               <a:defRPr sz="1600" b="1">
                 <a:solidFill>
@@ -3462,7 +3464,7 @@
               </a:defRPr>
             </a:pPr>
             <a:r>
-              <a:t>Phân Loại Theo Tiêu Chuẩn OWASP WSTG</a:t>
+              <a:t>Phân Loại Theo Chuẩn OWASP WSTG</a:t>
             </a:r>
           </a:p>
           <a:p>
@@ -3477,27 +3479,11 @@
               </a:defRPr>
             </a:pPr>
             <a:r>
-              <a:t>1. In-band SQLi (Khai thác trực diện):</a:t>
+              <a:t>1. In-band SQLi (Khai thác trực diện): Error-based, Union-based.</a:t>
             </a:r>
             <a:br/>
             <a:r>
-              <a:t>   - Error-based: Ép CSDL sinh lỗi để đọc dữ liệu.</a:t>
-            </a:r>
-            <a:br/>
-            <a:r>
-              <a:t>   - Union-based: Dùng UNION trích xuất các bảng khác.</a:t>
-            </a:r>
-            <a:br/>
-            <a:r>
-              <a:t>2. Inferential SQLi (Blind SQLi / Mù):</a:t>
-            </a:r>
-            <a:br/>
-            <a:r>
-              <a:t>   - Boolean-based: Đoán dữ liệu qua phản hồi Đúng/Sai.</a:t>
-            </a:r>
-            <a:br/>
-            <a:r>
-              <a:t>   - Time-based: Dùng WAITFOR DELAY đo thời gian.</a:t>
+              <a:t>2. Inferential SQLi (Blind SQLi / Mù): Boolean-based, Time-based.</a:t>
             </a:r>
             <a:br/>
             <a:r>
@@ -3514,8 +3500,8 @@
         </p:nvSpPr>
         <p:spPr>
           <a:xfrm>
-            <a:off x="6217920" y="1371600"/>
-            <a:ext cx="5212080" cy="4754880"/>
+            <a:off x="6217920" y="1188720"/>
+            <a:ext cx="5212080" cy="4937760"/>
           </a:xfrm>
           <a:prstGeom prst="roundRect">
             <a:avLst/>
@@ -3559,8 +3545,8 @@
         </p:nvSpPr>
         <p:spPr>
           <a:xfrm>
-            <a:off x="6400800" y="1463040"/>
-            <a:ext cx="4846320" cy="4572000"/>
+            <a:off x="6400800" y="1280160"/>
+            <a:ext cx="4846320" cy="4663440"/>
           </a:xfrm>
           <a:prstGeom prst="rect">
             <a:avLst/>
@@ -3652,7 +3638,7 @@
               </a:defRPr>
             </a:pPr>
             <a:r>
-              <a:t>Lập trình viên tin tưởng rằng '{user}' chỉ chứa chữ cái thường. Khi hacker truyền vào ký tự nháy đơn ('), cấu trúc cú pháp của cả câu lệnh bị bẻ gãy hoàn toàn.</a:t>
+              <a:t>Lập trình viên mặc định tin rằng '{user}' chỉ là chuỗi thông thường. Khi hacker truyền vào ký tự nháy đơn ('), toàn bộ cấu trúc cú pháp của câu lệnh bị bẻ gãy.</a:t>
             </a:r>
           </a:p>
         </p:txBody>
@@ -3684,13 +3670,13 @@
         <p:spPr>
           <a:xfrm>
             <a:off x="0" y="0"/>
-            <a:ext cx="12191695" cy="1097280"/>
+            <a:ext cx="12191695" cy="1005840"/>
           </a:xfrm>
           <a:prstGeom prst="rect">
             <a:avLst/>
           </a:prstGeom>
           <a:solidFill>
-            <a:srgbClr val="1A202C"/>
+            <a:srgbClr val="0F172A"/>
           </a:solidFill>
           <a:ln>
             <a:noFill/>
@@ -3726,7 +3712,7 @@
         </p:nvSpPr>
         <p:spPr>
           <a:xfrm>
-            <a:off x="731520" y="137160"/>
+            <a:off x="731520" y="109728"/>
             <a:ext cx="10698480" cy="320040"/>
           </a:xfrm>
           <a:prstGeom prst="rect">
@@ -3753,7 +3739,7 @@
           </a:p>
           <a:p>
             <a:pPr>
-              <a:defRPr sz="2000" b="1">
+              <a:defRPr sz="1900" b="1">
                 <a:solidFill>
                   <a:srgbClr val="FFFFFF"/>
                 </a:solidFill>
@@ -3773,8 +3759,8 @@
         </p:nvSpPr>
         <p:spPr>
           <a:xfrm>
-            <a:off x="731520" y="6446520"/>
-            <a:ext cx="10698480" cy="320040"/>
+            <a:off x="731520" y="6492240"/>
+            <a:ext cx="10698480" cy="274320"/>
           </a:xfrm>
           <a:prstGeom prst="rect">
             <a:avLst/>
@@ -3788,7 +3774,7 @@
           <a:lstStyle/>
           <a:p>
             <a:pPr>
-              <a:defRPr sz="1000">
+              <a:defRPr sz="950">
                 <a:solidFill>
                   <a:srgbClr val="64748B"/>
                 </a:solidFill>
@@ -3808,8 +3794,8 @@
         </p:nvSpPr>
         <p:spPr>
           <a:xfrm>
-            <a:off x="731520" y="1463040"/>
-            <a:ext cx="3291840" cy="4572000"/>
+            <a:off x="731520" y="1280160"/>
+            <a:ext cx="3291840" cy="4937760"/>
           </a:xfrm>
           <a:prstGeom prst="roundRect">
             <a:avLst/>
@@ -3853,8 +3839,8 @@
         </p:nvSpPr>
         <p:spPr>
           <a:xfrm>
-            <a:off x="868680" y="1645920"/>
-            <a:ext cx="3017520" cy="4206240"/>
+            <a:off x="868680" y="1463040"/>
+            <a:ext cx="3017520" cy="4572000"/>
           </a:xfrm>
           <a:prstGeom prst="rect">
             <a:avLst/>
@@ -3898,7 +3884,7 @@
             </a:r>
             <a:br/>
             <a:r>
-              <a:t>• Chỉ với 1 chuỗi payload ngắn gọn, kẻ tấn công đăng nhập thẳng vào tài khoản Quản trị viên (Admin).</a:t>
+              <a:t>• Chỉ với 1 chuỗi payload ngắn, kẻ tấn công đăng nhập thẳng vào tài khoản Quản trị viên (Admin).</a:t>
             </a:r>
             <a:br/>
             <a:r>
@@ -3915,8 +3901,8 @@
         </p:nvSpPr>
         <p:spPr>
           <a:xfrm>
-            <a:off x="4389120" y="1463040"/>
-            <a:ext cx="3291840" cy="4572000"/>
+            <a:off x="4389120" y="1280160"/>
+            <a:ext cx="3291840" cy="4937760"/>
           </a:xfrm>
           <a:prstGeom prst="roundRect">
             <a:avLst/>
@@ -3960,8 +3946,8 @@
         </p:nvSpPr>
         <p:spPr>
           <a:xfrm>
-            <a:off x="4526280" y="1645920"/>
-            <a:ext cx="3017520" cy="4206240"/>
+            <a:off x="4526280" y="1463040"/>
+            <a:ext cx="3017520" cy="4572000"/>
           </a:xfrm>
           <a:prstGeom prst="rect">
             <a:avLst/>
@@ -4009,7 +3995,7 @@
             </a:r>
             <a:br/>
             <a:r>
-              <a:t>• Vi phạm nghiêm trọng luật bảo vệ dữ liệu cá nhân, làm sụp đổ uy tín của nền tảng tư vấn trực tuyến.</a:t>
+              <a:t>• Vi phạm nghiêm trọng luật bảo vệ dữ liệu cá nhân, làm sụp đổ uy tín của hệ thống tư vấn trực tuyến.</a:t>
             </a:r>
           </a:p>
         </p:txBody>
@@ -4022,8 +4008,8 @@
         </p:nvSpPr>
         <p:spPr>
           <a:xfrm>
-            <a:off x="8046720" y="1463040"/>
-            <a:ext cx="3291840" cy="4572000"/>
+            <a:off x="8046720" y="1280160"/>
+            <a:ext cx="3291840" cy="4937760"/>
           </a:xfrm>
           <a:prstGeom prst="roundRect">
             <a:avLst/>
@@ -4033,7 +4019,7 @@
           </a:solidFill>
           <a:ln>
             <a:solidFill>
-              <a:srgbClr val="1A202C"/>
+              <a:srgbClr val="0F172A"/>
             </a:solidFill>
           </a:ln>
         </p:spPr>
@@ -4067,8 +4053,8 @@
         </p:nvSpPr>
         <p:spPr>
           <a:xfrm>
-            <a:off x="8183880" y="1645920"/>
-            <a:ext cx="3017520" cy="4206240"/>
+            <a:off x="8183880" y="1463040"/>
+            <a:ext cx="3017520" cy="4572000"/>
           </a:xfrm>
           <a:prstGeom prst="rect">
             <a:avLst/>
@@ -4084,7 +4070,7 @@
             <a:pPr>
               <a:defRPr sz="1400" b="1">
                 <a:solidFill>
-                  <a:srgbClr val="1A202C"/>
+                  <a:srgbClr val="0F172A"/>
                 </a:solidFill>
               </a:defRPr>
             </a:pPr>
@@ -4148,13 +4134,13 @@
         <p:spPr>
           <a:xfrm>
             <a:off x="0" y="0"/>
-            <a:ext cx="12191695" cy="1097280"/>
+            <a:ext cx="12191695" cy="1005840"/>
           </a:xfrm>
           <a:prstGeom prst="rect">
             <a:avLst/>
           </a:prstGeom>
           <a:solidFill>
-            <a:srgbClr val="1A202C"/>
+            <a:srgbClr val="0F172A"/>
           </a:solidFill>
           <a:ln>
             <a:noFill/>
@@ -4190,7 +4176,7 @@
         </p:nvSpPr>
         <p:spPr>
           <a:xfrm>
-            <a:off x="731520" y="137160"/>
+            <a:off x="731520" y="109728"/>
             <a:ext cx="10698480" cy="320040"/>
           </a:xfrm>
           <a:prstGeom prst="rect">
@@ -4217,7 +4203,7 @@
           </a:p>
           <a:p>
             <a:pPr>
-              <a:defRPr sz="2000" b="1">
+              <a:defRPr sz="1900" b="1">
                 <a:solidFill>
                   <a:srgbClr val="FFFFFF"/>
                 </a:solidFill>
@@ -4237,8 +4223,8 @@
         </p:nvSpPr>
         <p:spPr>
           <a:xfrm>
-            <a:off x="731520" y="6446520"/>
-            <a:ext cx="10698480" cy="320040"/>
+            <a:off x="731520" y="6492240"/>
+            <a:ext cx="10698480" cy="274320"/>
           </a:xfrm>
           <a:prstGeom prst="rect">
             <a:avLst/>
@@ -4252,7 +4238,7 @@
           <a:lstStyle/>
           <a:p>
             <a:pPr>
-              <a:defRPr sz="1000">
+              <a:defRPr sz="950">
                 <a:solidFill>
                   <a:srgbClr val="64748B"/>
                 </a:solidFill>
@@ -4272,8 +4258,8 @@
         </p:nvSpPr>
         <p:spPr>
           <a:xfrm>
-            <a:off x="731520" y="1371600"/>
-            <a:ext cx="10698480" cy="4846320"/>
+            <a:off x="731520" y="1188720"/>
+            <a:ext cx="10698480" cy="4937760"/>
           </a:xfrm>
           <a:prstGeom prst="rect">
             <a:avLst/>
@@ -4302,7 +4288,7 @@
               <a:spcBef>
                 <a:spcPts val="800"/>
               </a:spcBef>
-              <a:defRPr sz="1400" b="1">
+              <a:defRPr sz="1350" b="1">
                 <a:solidFill>
                   <a:srgbClr val="2563EB"/>
                 </a:solidFill>
@@ -4320,7 +4306,7 @@
           <a:p>
             <a:pPr>
               <a:spcBef>
-                <a:spcPts val="1600"/>
+                <a:spcPts val="1400"/>
               </a:spcBef>
               <a:defRPr sz="1500" b="1">
                 <a:solidFill>
@@ -4351,7 +4337,7 @@
           <a:p>
             <a:pPr>
               <a:spcBef>
-                <a:spcPts val="1600"/>
+                <a:spcPts val="1400"/>
               </a:spcBef>
               <a:defRPr sz="1500" b="1">
                 <a:solidFill>
@@ -4368,7 +4354,7 @@
               <a:spcBef>
                 <a:spcPts val="600"/>
               </a:spcBef>
-              <a:defRPr sz="1300">
+              <a:defRPr sz="1250">
                 <a:solidFill>
                   <a:srgbClr val="1E293B"/>
                 </a:solidFill>
@@ -4383,7 +4369,7 @@
             </a:r>
             <a:br/>
             <a:r>
-              <a:t>3. Ký tự chú thích (--) : Trong SQL Server/SQLite, '--' biến toàn bộ đoạn mã phía sau thành ghi chú vô hiệu, triệt tiêu hoàn toàn bước kiểm tra mật khẩu (AND Password = '...').</a:t>
+              <a:t>3. Ký tự chú thích (--) : Trong SQL Server, '--' biến toàn bộ đoạn mã phía sau thành ghi chú vô hiệu, triệt tiêu hoàn toàn bước kiểm tra mật khẩu (AND Password = '...').</a:t>
             </a:r>
           </a:p>
         </p:txBody>
@@ -4415,13 +4401,13 @@
         <p:spPr>
           <a:xfrm>
             <a:off x="0" y="0"/>
-            <a:ext cx="12191695" cy="1097280"/>
+            <a:ext cx="12191695" cy="1005840"/>
           </a:xfrm>
           <a:prstGeom prst="rect">
             <a:avLst/>
           </a:prstGeom>
           <a:solidFill>
-            <a:srgbClr val="1A202C"/>
+            <a:srgbClr val="0F172A"/>
           </a:solidFill>
           <a:ln>
             <a:noFill/>
@@ -4457,7 +4443,7 @@
         </p:nvSpPr>
         <p:spPr>
           <a:xfrm>
-            <a:off x="731520" y="137160"/>
+            <a:off x="731520" y="109728"/>
             <a:ext cx="10698480" cy="320040"/>
           </a:xfrm>
           <a:prstGeom prst="rect">
@@ -4484,14 +4470,14 @@
           </a:p>
           <a:p>
             <a:pPr>
-              <a:defRPr sz="2000" b="1">
+              <a:defRPr sz="1900" b="1">
                 <a:solidFill>
                   <a:srgbClr val="FFFFFF"/>
                 </a:solidFill>
               </a:defRPr>
             </a:pPr>
             <a:r>
-              <a:t>4. Minh Chứng Thực Nghiệm Demo Đối Chứng Trực Tiếp</a:t>
+              <a:t>4. Minh Chứng Thực Nghiệm 1: Giao Diện Trình Duyệt Web (Đối Chứng)</a:t>
             </a:r>
           </a:p>
         </p:txBody>
@@ -4504,8 +4490,8 @@
         </p:nvSpPr>
         <p:spPr>
           <a:xfrm>
-            <a:off x="731520" y="6446520"/>
-            <a:ext cx="10698480" cy="320040"/>
+            <a:off x="731520" y="6492240"/>
+            <a:ext cx="10698480" cy="274320"/>
           </a:xfrm>
           <a:prstGeom prst="rect">
             <a:avLst/>
@@ -4519,7 +4505,7 @@
           <a:lstStyle/>
           <a:p>
             <a:pPr>
-              <a:defRPr sz="1000">
+              <a:defRPr sz="950">
                 <a:solidFill>
                   <a:srgbClr val="64748B"/>
                 </a:solidFill>
@@ -4547,7 +4533,7 @@
         </p:blipFill>
         <p:spPr>
           <a:xfrm>
-            <a:off x="731520" y="1371600"/>
+            <a:off x="731520" y="1188720"/>
             <a:ext cx="5120640" cy="4114800"/>
           </a:xfrm>
           <a:prstGeom prst="rect">
@@ -4563,8 +4549,8 @@
         </p:nvSpPr>
         <p:spPr>
           <a:xfrm>
-            <a:off x="731520" y="5577840"/>
-            <a:ext cx="5120640" cy="731520"/>
+            <a:off x="731520" y="5394960"/>
+            <a:ext cx="5120640" cy="914400"/>
           </a:xfrm>
           <a:prstGeom prst="rect">
             <a:avLst/>
@@ -4606,7 +4592,7 @@
         </p:blipFill>
         <p:spPr>
           <a:xfrm>
-            <a:off x="6217920" y="1371600"/>
+            <a:off x="6217920" y="1188720"/>
             <a:ext cx="5212080" cy="4114800"/>
           </a:xfrm>
           <a:prstGeom prst="rect">
@@ -4622,8 +4608,8 @@
         </p:nvSpPr>
         <p:spPr>
           <a:xfrm>
-            <a:off x="6217920" y="5577840"/>
-            <a:ext cx="5212080" cy="731520"/>
+            <a:off x="6217920" y="5394960"/>
+            <a:ext cx="5212080" cy="914400"/>
           </a:xfrm>
           <a:prstGeom prst="rect">
             <a:avLst/>
@@ -4676,13 +4662,13 @@
         <p:spPr>
           <a:xfrm>
             <a:off x="0" y="0"/>
-            <a:ext cx="12191695" cy="1097280"/>
+            <a:ext cx="12191695" cy="1005840"/>
           </a:xfrm>
           <a:prstGeom prst="rect">
             <a:avLst/>
           </a:prstGeom>
           <a:solidFill>
-            <a:srgbClr val="1A202C"/>
+            <a:srgbClr val="0F172A"/>
           </a:solidFill>
           <a:ln>
             <a:noFill/>
@@ -4718,7 +4704,7 @@
         </p:nvSpPr>
         <p:spPr>
           <a:xfrm>
-            <a:off x="731520" y="137160"/>
+            <a:off x="731520" y="109728"/>
             <a:ext cx="10698480" cy="320040"/>
           </a:xfrm>
           <a:prstGeom prst="rect">
@@ -4745,14 +4731,14 @@
           </a:p>
           <a:p>
             <a:pPr>
-              <a:defRPr sz="2000" b="1">
+              <a:defRPr sz="1900" b="1">
                 <a:solidFill>
                   <a:srgbClr val="FFFFFF"/>
                 </a:solidFill>
               </a:defRPr>
             </a:pPr>
             <a:r>
-              <a:t>5. Biện Pháp Phòng Thủ Chuẩn Trong ASP.NET Core MVC</a:t>
+              <a:t>5. Minh Chứng Thực Nghiệm 2: Tầng API (cURL) &amp; CSDL SQL Server 2025 (Không Dùng Web UI)</a:t>
             </a:r>
           </a:p>
         </p:txBody>
@@ -4765,8 +4751,8 @@
         </p:nvSpPr>
         <p:spPr>
           <a:xfrm>
-            <a:off x="731520" y="6446520"/>
-            <a:ext cx="10698480" cy="320040"/>
+            <a:off x="731520" y="6492240"/>
+            <a:ext cx="10698480" cy="274320"/>
           </a:xfrm>
           <a:prstGeom prst="rect">
             <a:avLst/>
@@ -4780,7 +4766,7 @@
           <a:lstStyle/>
           <a:p>
             <a:pPr>
-              <a:defRPr sz="1000">
+              <a:defRPr sz="950">
                 <a:solidFill>
                   <a:srgbClr val="64748B"/>
                 </a:solidFill>
@@ -4792,27 +4778,169 @@
           </a:p>
         </p:txBody>
       </p:sp>
-      <p:sp>
-        <p:nvSpPr>
-          <p:cNvPr id="5" name="Rounded Rectangle 4"/>
+      <p:pic>
+        <p:nvPicPr>
+          <p:cNvPr id="5" name="Picture 4" descr="04_Terminal_cURL_Exploit.png"/>
+          <p:cNvPicPr>
+            <a:picLocks noChangeAspect="1"/>
+          </p:cNvPicPr>
+          <p:nvPr/>
+        </p:nvPicPr>
+        <p:blipFill>
+          <a:blip r:embed="rId2"/>
+          <a:stretch>
+            <a:fillRect/>
+          </a:stretch>
+        </p:blipFill>
+        <p:spPr>
+          <a:xfrm>
+            <a:off x="731520" y="1188720"/>
+            <a:ext cx="5120640" cy="4114800"/>
+          </a:xfrm>
+          <a:prstGeom prst="rect">
+            <a:avLst/>
+          </a:prstGeom>
+        </p:spPr>
+      </p:pic>
+      <p:sp>
+        <p:nvSpPr>
+          <p:cNvPr id="6" name="TextBox 5"/>
+          <p:cNvSpPr txBox="1"/>
+          <p:nvPr/>
+        </p:nvSpPr>
+        <p:spPr>
+          <a:xfrm>
+            <a:off x="731520" y="5394960"/>
+            <a:ext cx="5120640" cy="914400"/>
+          </a:xfrm>
+          <a:prstGeom prst="rect">
+            <a:avLst/>
+          </a:prstGeom>
+          <a:noFill/>
+        </p:spPr>
+        <p:txBody>
+          <a:bodyPr wrap="square">
+            <a:spAutoFit/>
+          </a:bodyPr>
+          <a:lstStyle/>
+          <a:p>
+            <a:pPr>
+              <a:defRPr sz="1050" b="1">
+                <a:solidFill>
+                  <a:srgbClr val="2563EB"/>
+                </a:solidFill>
+              </a:defRPr>
+            </a:pPr>
+            <a:r>
+              <a:t>💻 MINH CHỨNG 1 (API / cURL CLI):</a:t>
+            </a:r>
+            <a:br/>
+            <a:r>
+              <a:t>Bắn HTTP POST trực tiếp từ Terminal → Nhận JSON rò rỉ dữ liệu, chứng minh lỗ hổng ở tầng Backend C#.</a:t>
+            </a:r>
+          </a:p>
+        </p:txBody>
+      </p:sp>
+      <p:pic>
+        <p:nvPicPr>
+          <p:cNvPr id="7" name="Picture 6" descr="05_SQLServer_Direct_Query.png"/>
+          <p:cNvPicPr>
+            <a:picLocks noChangeAspect="1"/>
+          </p:cNvPicPr>
+          <p:nvPr/>
+        </p:nvPicPr>
+        <p:blipFill>
+          <a:blip r:embed="rId3"/>
+          <a:stretch>
+            <a:fillRect/>
+          </a:stretch>
+        </p:blipFill>
+        <p:spPr>
+          <a:xfrm>
+            <a:off x="6217920" y="1188720"/>
+            <a:ext cx="5212080" cy="4114800"/>
+          </a:xfrm>
+          <a:prstGeom prst="rect">
+            <a:avLst/>
+          </a:prstGeom>
+        </p:spPr>
+      </p:pic>
+      <p:sp>
+        <p:nvSpPr>
+          <p:cNvPr id="8" name="TextBox 7"/>
+          <p:cNvSpPr txBox="1"/>
+          <p:nvPr/>
+        </p:nvSpPr>
+        <p:spPr>
+          <a:xfrm>
+            <a:off x="6217920" y="5394960"/>
+            <a:ext cx="5212080" cy="914400"/>
+          </a:xfrm>
+          <a:prstGeom prst="rect">
+            <a:avLst/>
+          </a:prstGeom>
+          <a:noFill/>
+        </p:spPr>
+        <p:txBody>
+          <a:bodyPr wrap="square">
+            <a:spAutoFit/>
+          </a:bodyPr>
+          <a:lstStyle/>
+          <a:p>
+            <a:pPr>
+              <a:defRPr sz="1050" b="1">
+                <a:solidFill>
+                  <a:srgbClr val="16A34A"/>
+                </a:solidFill>
+              </a:defRPr>
+            </a:pPr>
+            <a:r>
+              <a:t>🗄️ MINH CHỨNG 2 (SQL Server 2025 Thật):</a:t>
+            </a:r>
+            <a:br/>
+            <a:r>
+              <a:t>Thực thi đối chứng trong SQL Server (OwaspDemoDB). Câu lệnh bị inject trả về 4 rows, câu có tham số trả về 0 row.</a:t>
+            </a:r>
+          </a:p>
+        </p:txBody>
+      </p:sp>
+    </p:spTree>
+  </p:cSld>
+  <p:clrMapOvr>
+    <a:masterClrMapping/>
+  </p:clrMapOvr>
+</p:sld>
+</file>
+
+<file path=ppt/slides/slide7.xml><?xml version="1.0" encoding="utf-8"?>
+<p:sld xmlns:a="http://schemas.openxmlformats.org/drawingml/2006/main" xmlns:p="http://schemas.openxmlformats.org/presentationml/2006/main" xmlns:r="http://schemas.openxmlformats.org/officeDocument/2006/relationships">
+  <p:cSld>
+    <p:spTree>
+      <p:nvGrpSpPr>
+        <p:cNvPr id="1" name=""/>
+        <p:cNvGrpSpPr/>
+        <p:nvPr/>
+      </p:nvGrpSpPr>
+      <p:grpSpPr/>
+      <p:sp>
+        <p:nvSpPr>
+          <p:cNvPr id="2" name="Rectangle 1"/>
           <p:cNvSpPr/>
           <p:nvPr/>
         </p:nvSpPr>
         <p:spPr>
           <a:xfrm>
-            <a:off x="731520" y="1371600"/>
-            <a:ext cx="5212080" cy="4754880"/>
-          </a:xfrm>
-          <a:prstGeom prst="roundRect">
+            <a:off x="0" y="0"/>
+            <a:ext cx="12191695" cy="1005840"/>
+          </a:xfrm>
+          <a:prstGeom prst="rect">
             <a:avLst/>
           </a:prstGeom>
           <a:solidFill>
-            <a:srgbClr val="F8FAFC"/>
+            <a:srgbClr val="0F172A"/>
           </a:solidFill>
           <a:ln>
-            <a:solidFill>
-              <a:srgbClr val="16A34A"/>
-            </a:solidFill>
+            <a:noFill/>
           </a:ln>
         </p:spPr>
         <p:style>
@@ -4839,14 +4967,14 @@
       </p:sp>
       <p:sp>
         <p:nvSpPr>
-          <p:cNvPr id="6" name="TextBox 5"/>
+          <p:cNvPr id="3" name="TextBox 2"/>
           <p:cNvSpPr txBox="1"/>
           <p:nvPr/>
         </p:nvSpPr>
         <p:spPr>
           <a:xfrm>
-            <a:off x="914400" y="1463040"/>
-            <a:ext cx="4846320" cy="4572000"/>
+            <a:off x="731520" y="109728"/>
+            <a:ext cx="10698480" cy="320040"/>
           </a:xfrm>
           <a:prstGeom prst="rect">
             <a:avLst/>
@@ -4860,6 +4988,133 @@
           <a:lstStyle/>
           <a:p>
             <a:pPr>
+              <a:defRPr sz="1100" b="1">
+                <a:solidFill>
+                  <a:srgbClr val="DC2626"/>
+                </a:solidFill>
+              </a:defRPr>
+            </a:pPr>
+            <a:r>
+              <a:t>OWASP TOP 10 - A03:2021 (INJECTION)</a:t>
+            </a:r>
+          </a:p>
+          <a:p>
+            <a:pPr>
+              <a:defRPr sz="1900" b="1">
+                <a:solidFill>
+                  <a:srgbClr val="FFFFFF"/>
+                </a:solidFill>
+              </a:defRPr>
+            </a:pPr>
+            <a:r>
+              <a:t>6. Biện Pháp Phòng Thủ Chuẩn Trong ASP.NET Core MVC</a:t>
+            </a:r>
+          </a:p>
+        </p:txBody>
+      </p:sp>
+      <p:sp>
+        <p:nvSpPr>
+          <p:cNvPr id="4" name="TextBox 3"/>
+          <p:cNvSpPr txBox="1"/>
+          <p:nvPr/>
+        </p:nvSpPr>
+        <p:spPr>
+          <a:xfrm>
+            <a:off x="731520" y="6492240"/>
+            <a:ext cx="10698480" cy="274320"/>
+          </a:xfrm>
+          <a:prstGeom prst="rect">
+            <a:avLst/>
+          </a:prstGeom>
+          <a:noFill/>
+        </p:spPr>
+        <p:txBody>
+          <a:bodyPr wrap="none">
+            <a:spAutoFit/>
+          </a:bodyPr>
+          <a:lstStyle/>
+          <a:p>
+            <a:pPr>
+              <a:defRPr sz="950">
+                <a:solidFill>
+                  <a:srgbClr val="64748B"/>
+                </a:solidFill>
+              </a:defRPr>
+            </a:pPr>
+            <a:r>
+              <a:t>Nhóm WNC.G01 (HOU) • Môn Lập Trình Web Nâng Cao • ThS. Lê Hữu Dũng</a:t>
+            </a:r>
+          </a:p>
+        </p:txBody>
+      </p:sp>
+      <p:sp>
+        <p:nvSpPr>
+          <p:cNvPr id="5" name="Rounded Rectangle 4"/>
+          <p:cNvSpPr/>
+          <p:nvPr/>
+        </p:nvSpPr>
+        <p:spPr>
+          <a:xfrm>
+            <a:off x="731520" y="1188720"/>
+            <a:ext cx="5212080" cy="4937760"/>
+          </a:xfrm>
+          <a:prstGeom prst="roundRect">
+            <a:avLst/>
+          </a:prstGeom>
+          <a:solidFill>
+            <a:srgbClr val="F8FAFC"/>
+          </a:solidFill>
+          <a:ln>
+            <a:solidFill>
+              <a:srgbClr val="16A34A"/>
+            </a:solidFill>
+          </a:ln>
+        </p:spPr>
+        <p:style>
+          <a:lnRef idx="1">
+            <a:schemeClr val="accent1"/>
+          </a:lnRef>
+          <a:fillRef idx="3">
+            <a:schemeClr val="accent1"/>
+          </a:fillRef>
+          <a:effectRef idx="2">
+            <a:schemeClr val="accent1"/>
+          </a:effectRef>
+          <a:fontRef idx="minor">
+            <a:schemeClr val="lt1"/>
+          </a:fontRef>
+        </p:style>
+        <p:txBody>
+          <a:bodyPr rtlCol="0" anchor="ctr"/>
+          <a:lstStyle/>
+          <a:p>
+            <a:pPr algn="ctr"/>
+          </a:p>
+        </p:txBody>
+      </p:sp>
+      <p:sp>
+        <p:nvSpPr>
+          <p:cNvPr id="6" name="TextBox 5"/>
+          <p:cNvSpPr txBox="1"/>
+          <p:nvPr/>
+        </p:nvSpPr>
+        <p:spPr>
+          <a:xfrm>
+            <a:off x="914400" y="1280160"/>
+            <a:ext cx="4846320" cy="4663440"/>
+          </a:xfrm>
+          <a:prstGeom prst="rect">
+            <a:avLst/>
+          </a:prstGeom>
+          <a:noFill/>
+        </p:spPr>
+        <p:txBody>
+          <a:bodyPr wrap="square">
+            <a:spAutoFit/>
+          </a:bodyPr>
+          <a:lstStyle/>
+          <a:p>
+            <a:pPr>
               <a:defRPr sz="1400" b="1">
                 <a:solidFill>
                   <a:srgbClr val="16A34A"/>
@@ -4875,7 +5130,7 @@
               <a:spcBef>
                 <a:spcPts val="800"/>
               </a:spcBef>
-              <a:defRPr sz="1050">
+              <a:defRPr sz="1000">
                 <a:solidFill>
                   <a:srgbClr val="166534"/>
                 </a:solidFill>
@@ -4955,8 +5210,8 @@
         </p:nvSpPr>
         <p:spPr>
           <a:xfrm>
-            <a:off x="6309360" y="1371600"/>
-            <a:ext cx="5120640" cy="4754880"/>
+            <a:off x="6309360" y="1188720"/>
+            <a:ext cx="5120640" cy="4937760"/>
           </a:xfrm>
           <a:prstGeom prst="rect">
             <a:avLst/>
@@ -5054,6 +5309,228 @@
             <a:br/>
             <a:r>
               <a:t>Sử dụng ASP.NET Core Identity (PBKDF2/BCrypt) để nếu CSDL có bị lộ, mật khẩu vẫn được bảo vệ an toàn.</a:t>
+            </a:r>
+          </a:p>
+        </p:txBody>
+      </p:sp>
+    </p:spTree>
+  </p:cSld>
+  <p:clrMapOvr>
+    <a:masterClrMapping/>
+  </p:clrMapOvr>
+</p:sld>
+</file>
+
+<file path=ppt/slides/slide8.xml><?xml version="1.0" encoding="utf-8"?>
+<p:sld xmlns:a="http://schemas.openxmlformats.org/drawingml/2006/main" xmlns:p="http://schemas.openxmlformats.org/presentationml/2006/main" xmlns:r="http://schemas.openxmlformats.org/officeDocument/2006/relationships">
+  <p:cSld>
+    <p:spTree>
+      <p:nvGrpSpPr>
+        <p:cNvPr id="1" name=""/>
+        <p:cNvGrpSpPr/>
+        <p:nvPr/>
+      </p:nvGrpSpPr>
+      <p:grpSpPr/>
+      <p:sp>
+        <p:nvSpPr>
+          <p:cNvPr id="2" name="Rectangle 1"/>
+          <p:cNvSpPr/>
+          <p:nvPr/>
+        </p:nvSpPr>
+        <p:spPr>
+          <a:xfrm>
+            <a:off x="0" y="0"/>
+            <a:ext cx="12191695" cy="1005840"/>
+          </a:xfrm>
+          <a:prstGeom prst="rect">
+            <a:avLst/>
+          </a:prstGeom>
+          <a:solidFill>
+            <a:srgbClr val="0F172A"/>
+          </a:solidFill>
+          <a:ln>
+            <a:noFill/>
+          </a:ln>
+        </p:spPr>
+        <p:style>
+          <a:lnRef idx="1">
+            <a:schemeClr val="accent1"/>
+          </a:lnRef>
+          <a:fillRef idx="3">
+            <a:schemeClr val="accent1"/>
+          </a:fillRef>
+          <a:effectRef idx="2">
+            <a:schemeClr val="accent1"/>
+          </a:effectRef>
+          <a:fontRef idx="minor">
+            <a:schemeClr val="lt1"/>
+          </a:fontRef>
+        </p:style>
+        <p:txBody>
+          <a:bodyPr rtlCol="0" anchor="ctr"/>
+          <a:lstStyle/>
+          <a:p>
+            <a:pPr algn="ctr"/>
+          </a:p>
+        </p:txBody>
+      </p:sp>
+      <p:sp>
+        <p:nvSpPr>
+          <p:cNvPr id="3" name="TextBox 2"/>
+          <p:cNvSpPr txBox="1"/>
+          <p:nvPr/>
+        </p:nvSpPr>
+        <p:spPr>
+          <a:xfrm>
+            <a:off x="731520" y="109728"/>
+            <a:ext cx="10698480" cy="320040"/>
+          </a:xfrm>
+          <a:prstGeom prst="rect">
+            <a:avLst/>
+          </a:prstGeom>
+          <a:noFill/>
+        </p:spPr>
+        <p:txBody>
+          <a:bodyPr wrap="square">
+            <a:spAutoFit/>
+          </a:bodyPr>
+          <a:lstStyle/>
+          <a:p>
+            <a:pPr>
+              <a:defRPr sz="1100" b="1">
+                <a:solidFill>
+                  <a:srgbClr val="DC2626"/>
+                </a:solidFill>
+              </a:defRPr>
+            </a:pPr>
+            <a:r>
+              <a:t>OWASP TOP 10 - A03:2021 (INJECTION)</a:t>
+            </a:r>
+          </a:p>
+          <a:p>
+            <a:pPr>
+              <a:defRPr sz="1900" b="1">
+                <a:solidFill>
+                  <a:srgbClr val="FFFFFF"/>
+                </a:solidFill>
+              </a:defRPr>
+            </a:pPr>
+            <a:r>
+              <a:t>7. Tổng Kết &amp; Bài Học Rút Ra Cho Dự Án Website Tư Vấn Trực Tuyến</a:t>
+            </a:r>
+          </a:p>
+        </p:txBody>
+      </p:sp>
+      <p:sp>
+        <p:nvSpPr>
+          <p:cNvPr id="4" name="TextBox 3"/>
+          <p:cNvSpPr txBox="1"/>
+          <p:nvPr/>
+        </p:nvSpPr>
+        <p:spPr>
+          <a:xfrm>
+            <a:off x="731520" y="6492240"/>
+            <a:ext cx="10698480" cy="274320"/>
+          </a:xfrm>
+          <a:prstGeom prst="rect">
+            <a:avLst/>
+          </a:prstGeom>
+          <a:noFill/>
+        </p:spPr>
+        <p:txBody>
+          <a:bodyPr wrap="none">
+            <a:spAutoFit/>
+          </a:bodyPr>
+          <a:lstStyle/>
+          <a:p>
+            <a:pPr>
+              <a:defRPr sz="950">
+                <a:solidFill>
+                  <a:srgbClr val="64748B"/>
+                </a:solidFill>
+              </a:defRPr>
+            </a:pPr>
+            <a:r>
+              <a:t>Nhóm WNC.G01 (HOU) • Môn Lập Trình Web Nâng Cao • ThS. Lê Hữu Dũng</a:t>
+            </a:r>
+          </a:p>
+        </p:txBody>
+      </p:sp>
+      <p:sp>
+        <p:nvSpPr>
+          <p:cNvPr id="5" name="TextBox 4"/>
+          <p:cNvSpPr txBox="1"/>
+          <p:nvPr/>
+        </p:nvSpPr>
+        <p:spPr>
+          <a:xfrm>
+            <a:off x="914400" y="1463040"/>
+            <a:ext cx="10362895" cy="4389120"/>
+          </a:xfrm>
+          <a:prstGeom prst="rect">
+            <a:avLst/>
+          </a:prstGeom>
+          <a:noFill/>
+        </p:spPr>
+        <p:txBody>
+          <a:bodyPr wrap="square">
+            <a:spAutoFit/>
+          </a:bodyPr>
+          <a:lstStyle/>
+          <a:p>
+            <a:pPr>
+              <a:defRPr sz="1800" b="1">
+                <a:solidFill>
+                  <a:srgbClr val="DC2626"/>
+                </a:solidFill>
+              </a:defRPr>
+            </a:pPr>
+            <a:r>
+              <a:t>KẾT LUẬN THỰC NGHIỆM:</a:t>
+            </a:r>
+          </a:p>
+          <a:p>
+            <a:pPr>
+              <a:spcBef>
+                <a:spcPts val="1000"/>
+              </a:spcBef>
+              <a:defRPr sz="1400">
+                <a:solidFill>
+                  <a:srgbClr val="1E293B"/>
+                </a:solidFill>
+              </a:defRPr>
+            </a:pPr>
+            <a:r>
+              <a:t>1. Minh chứng thực nghiệm đã chứng minh rõ ràng: SQL Injection có thể bị khai thác qua cả Giao diện Web (Form) lẫn qua Lệnh gọi API trực tiếp (cURL/Postman). Độ nguy hiểm là mức CRITICAL (9.8/10 theo CVSS v3.1).</a:t>
+            </a:r>
+            <a:br/>
+            <a:br/>
+            <a:r>
+              <a:t>2. Lỗ hổng hoàn toàn có thể được loại trừ 100% bằng cách tuân thủ đúng chuẩn công nghệ của môn học: Sử dụng Entity Framework Core với Parameterized Query thay vì ghép chuỗi thủ công.</a:t>
+            </a:r>
+            <a:br/>
+            <a:br/>
+            <a:r>
+              <a:t>3. Trong dự án BTL (Website Tư vấn trực tuyến WNC.G01), nhóm cam kết áp dụng triệt để: EF Core DbContext, Data Annotations Validation và ASP.NET Core Identity để bảo vệ an toàn tuyệt đối cho người dùng.</a:t>
+            </a:r>
+          </a:p>
+          <a:p>
+            <a:pPr>
+              <a:spcBef>
+                <a:spcPts val="2400"/>
+              </a:spcBef>
+              <a:defRPr sz="1600" b="1">
+                <a:solidFill>
+                  <a:srgbClr val="2563EB"/>
+                </a:solidFill>
+              </a:defRPr>
+            </a:pPr>
+            <a:r>
+              <a:t>XIN TRÂN TRỌNG CẢM ƠN THẦY VÀ CÁC BẠN ĐÃ THEO DÕI!</a:t>
+            </a:r>
+            <a:br/>
+            <a:r>
+              <a:t>Nhóm WNC.G01 sẵn sàng lắng nghe câu hỏi và nhận xét từ giảng viên.</a:t>
             </a:r>
           </a:p>
         </p:txBody>

</xml_diff>

<commit_message>
fix: perfectly align and format slide images for web and terminal proofs
</commit_message>
<xml_diff>
--- a/Slide_OWASP_SQL_Injection.pptx
+++ b/Slide_OWASP_SQL_Injection.pptx
@@ -3369,8 +3369,8 @@
         </p:nvSpPr>
         <p:spPr>
           <a:xfrm>
-            <a:off x="731520" y="6492240"/>
-            <a:ext cx="10698480" cy="274320"/>
+            <a:off x="731520" y="6537960"/>
+            <a:ext cx="10698480" cy="228600"/>
           </a:xfrm>
           <a:prstGeom prst="rect">
             <a:avLst/>
@@ -3759,8 +3759,8 @@
         </p:nvSpPr>
         <p:spPr>
           <a:xfrm>
-            <a:off x="731520" y="6492240"/>
-            <a:ext cx="10698480" cy="274320"/>
+            <a:off x="731520" y="6537960"/>
+            <a:ext cx="10698480" cy="228600"/>
           </a:xfrm>
           <a:prstGeom prst="rect">
             <a:avLst/>
@@ -4223,8 +4223,8 @@
         </p:nvSpPr>
         <p:spPr>
           <a:xfrm>
-            <a:off x="731520" y="6492240"/>
-            <a:ext cx="10698480" cy="274320"/>
+            <a:off x="731520" y="6537960"/>
+            <a:ext cx="10698480" cy="228600"/>
           </a:xfrm>
           <a:prstGeom prst="rect">
             <a:avLst/>
@@ -4477,7 +4477,7 @@
               </a:defRPr>
             </a:pPr>
             <a:r>
-              <a:t>4. Minh Chứng Thực Nghiệm 1: Giao Diện Trình Duyệt Web (Đối Chứng)</a:t>
+              <a:t>4. Minh Chứng Thực Nghiệm 1: Giao Diện Trình Duyệt Web (Đối Chứng Song Song)</a:t>
             </a:r>
           </a:p>
         </p:txBody>
@@ -4490,8 +4490,8 @@
         </p:nvSpPr>
         <p:spPr>
           <a:xfrm>
-            <a:off x="731520" y="6492240"/>
-            <a:ext cx="10698480" cy="274320"/>
+            <a:off x="731520" y="6537960"/>
+            <a:ext cx="10698480" cy="228600"/>
           </a:xfrm>
           <a:prstGeom prst="rect">
             <a:avLst/>
@@ -4519,7 +4519,7 @@
       </p:sp>
       <p:pic>
         <p:nvPicPr>
-          <p:cNvPr id="5" name="Picture 4" descr="02_Tan_Cong_Bypass_Thanh_Cong.png"/>
+          <p:cNvPr id="5" name="Picture 4" descr="only_cards.png"/>
           <p:cNvPicPr>
             <a:picLocks noChangeAspect="1"/>
           </p:cNvPicPr>
@@ -4533,108 +4533,14 @@
         </p:blipFill>
         <p:spPr>
           <a:xfrm>
-            <a:off x="731520" y="1188720"/>
-            <a:ext cx="5120640" cy="4114800"/>
+            <a:off x="1517904" y="1280160"/>
+            <a:ext cx="9144000" cy="4885603"/>
           </a:xfrm>
           <a:prstGeom prst="rect">
             <a:avLst/>
           </a:prstGeom>
         </p:spPr>
       </p:pic>
-      <p:sp>
-        <p:nvSpPr>
-          <p:cNvPr id="6" name="TextBox 5"/>
-          <p:cNvSpPr txBox="1"/>
-          <p:nvPr/>
-        </p:nvSpPr>
-        <p:spPr>
-          <a:xfrm>
-            <a:off x="731520" y="5394960"/>
-            <a:ext cx="5120640" cy="914400"/>
-          </a:xfrm>
-          <a:prstGeom prst="rect">
-            <a:avLst/>
-          </a:prstGeom>
-          <a:noFill/>
-        </p:spPr>
-        <p:txBody>
-          <a:bodyPr wrap="square">
-            <a:spAutoFit/>
-          </a:bodyPr>
-          <a:lstStyle/>
-          <a:p>
-            <a:pPr>
-              <a:defRPr sz="1100" b="1">
-                <a:solidFill>
-                  <a:srgbClr val="DC2626"/>
-                </a:solidFill>
-              </a:defRPr>
-            </a:pPr>
-            <a:r>
-              <a:t>❌ BỊ LỖI: Nhập payload → Vượt mặt đăng nhập thành công, lộ toàn bộ CSDL và mật khẩu.</a:t>
-            </a:r>
-          </a:p>
-        </p:txBody>
-      </p:sp>
-      <p:pic>
-        <p:nvPicPr>
-          <p:cNvPr id="7" name="Picture 6" descr="03_So_Sanh_Phong_Thu_Thanh_Cong.png"/>
-          <p:cNvPicPr>
-            <a:picLocks noChangeAspect="1"/>
-          </p:cNvPicPr>
-          <p:nvPr/>
-        </p:nvPicPr>
-        <p:blipFill>
-          <a:blip r:embed="rId3"/>
-          <a:stretch>
-            <a:fillRect/>
-          </a:stretch>
-        </p:blipFill>
-        <p:spPr>
-          <a:xfrm>
-            <a:off x="6217920" y="1188720"/>
-            <a:ext cx="5212080" cy="4114800"/>
-          </a:xfrm>
-          <a:prstGeom prst="rect">
-            <a:avLst/>
-          </a:prstGeom>
-        </p:spPr>
-      </p:pic>
-      <p:sp>
-        <p:nvSpPr>
-          <p:cNvPr id="8" name="TextBox 7"/>
-          <p:cNvSpPr txBox="1"/>
-          <p:nvPr/>
-        </p:nvSpPr>
-        <p:spPr>
-          <a:xfrm>
-            <a:off x="6217920" y="5394960"/>
-            <a:ext cx="5212080" cy="914400"/>
-          </a:xfrm>
-          <a:prstGeom prst="rect">
-            <a:avLst/>
-          </a:prstGeom>
-          <a:noFill/>
-        </p:spPr>
-        <p:txBody>
-          <a:bodyPr wrap="square">
-            <a:spAutoFit/>
-          </a:bodyPr>
-          <a:lstStyle/>
-          <a:p>
-            <a:pPr>
-              <a:defRPr sz="1100" b="1">
-                <a:solidFill>
-                  <a:srgbClr val="16A34A"/>
-                </a:solidFill>
-              </a:defRPr>
-            </a:pPr>
-            <a:r>
-              <a:t>✅ ĐÃ VÁ: Cùng payload sang nhánh EF Core → Bị chặn đứng, bảo vệ dữ liệu an toàn 100%.</a:t>
-            </a:r>
-          </a:p>
-        </p:txBody>
-      </p:sp>
     </p:spTree>
   </p:cSld>
   <p:clrMapOvr>
@@ -4751,8 +4657,8 @@
         </p:nvSpPr>
         <p:spPr>
           <a:xfrm>
-            <a:off x="731520" y="6492240"/>
-            <a:ext cx="10698480" cy="274320"/>
+            <a:off x="731520" y="6537960"/>
+            <a:ext cx="10698480" cy="228600"/>
           </a:xfrm>
           <a:prstGeom prst="rect">
             <a:avLst/>
@@ -4795,55 +4701,16 @@
         <p:spPr>
           <a:xfrm>
             <a:off x="731520" y="1188720"/>
-            <a:ext cx="5120640" cy="4114800"/>
+            <a:ext cx="5212080" cy="3950208"/>
           </a:xfrm>
           <a:prstGeom prst="rect">
             <a:avLst/>
           </a:prstGeom>
         </p:spPr>
       </p:pic>
-      <p:sp>
-        <p:nvSpPr>
-          <p:cNvPr id="6" name="TextBox 5"/>
-          <p:cNvSpPr txBox="1"/>
-          <p:nvPr/>
-        </p:nvSpPr>
-        <p:spPr>
-          <a:xfrm>
-            <a:off x="731520" y="5394960"/>
-            <a:ext cx="5120640" cy="914400"/>
-          </a:xfrm>
-          <a:prstGeom prst="rect">
-            <a:avLst/>
-          </a:prstGeom>
-          <a:noFill/>
-        </p:spPr>
-        <p:txBody>
-          <a:bodyPr wrap="square">
-            <a:spAutoFit/>
-          </a:bodyPr>
-          <a:lstStyle/>
-          <a:p>
-            <a:pPr>
-              <a:defRPr sz="1050" b="1">
-                <a:solidFill>
-                  <a:srgbClr val="2563EB"/>
-                </a:solidFill>
-              </a:defRPr>
-            </a:pPr>
-            <a:r>
-              <a:t>💻 MINH CHỨNG 1 (API / cURL CLI):</a:t>
-            </a:r>
-            <a:br/>
-            <a:r>
-              <a:t>Bắn HTTP POST trực tiếp từ Terminal → Nhận JSON rò rỉ dữ liệu, chứng minh lỗ hổng ở tầng Backend C#.</a:t>
-            </a:r>
-          </a:p>
-        </p:txBody>
-      </p:sp>
       <p:pic>
         <p:nvPicPr>
-          <p:cNvPr id="7" name="Picture 6" descr="05_SQLServer_Direct_Query.png"/>
+          <p:cNvPr id="6" name="Picture 5" descr="05_SQLServer_Direct_Query.png"/>
           <p:cNvPicPr>
             <a:picLocks noChangeAspect="1"/>
           </p:cNvPicPr>
@@ -4858,7 +4725,7 @@
         <p:spPr>
           <a:xfrm>
             <a:off x="6217920" y="1188720"/>
-            <a:ext cx="5212080" cy="4114800"/>
+            <a:ext cx="5212080" cy="3950208"/>
           </a:xfrm>
           <a:prstGeom prst="rect">
             <a:avLst/>
@@ -4867,14 +4734,14 @@
       </p:pic>
       <p:sp>
         <p:nvSpPr>
-          <p:cNvPr id="8" name="TextBox 7"/>
+          <p:cNvPr id="7" name="TextBox 6"/>
           <p:cNvSpPr txBox="1"/>
           <p:nvPr/>
         </p:nvSpPr>
         <p:spPr>
           <a:xfrm>
-            <a:off x="6217920" y="5394960"/>
-            <a:ext cx="5212080" cy="914400"/>
+            <a:off x="731520" y="5303520"/>
+            <a:ext cx="10698480" cy="1005840"/>
           </a:xfrm>
           <a:prstGeom prst="rect">
             <a:avLst/>
@@ -4888,18 +4755,18 @@
           <a:lstStyle/>
           <a:p>
             <a:pPr>
-              <a:defRPr sz="1050" b="1">
-                <a:solidFill>
-                  <a:srgbClr val="16A34A"/>
-                </a:solidFill>
-              </a:defRPr>
-            </a:pPr>
-            <a:r>
-              <a:t>🗄️ MINH CHỨNG 2 (SQL Server 2025 Thật):</a:t>
+              <a:defRPr sz="1200" b="1">
+                <a:solidFill>
+                  <a:srgbClr val="1E293B"/>
+                </a:solidFill>
+              </a:defRPr>
+            </a:pPr>
+            <a:r>
+              <a:t>• Bên trái: Gọi HTTP POST bằng cURL từ dòng lệnh Terminal → Nhận JSON rò rỉ CSDL, chứng minh lỗi ở tầng Backend C#.</a:t>
             </a:r>
             <a:br/>
             <a:r>
-              <a:t>Thực thi đối chứng trong SQL Server (OwaspDemoDB). Câu lệnh bị inject trả về 4 rows, câu có tham số trả về 0 row.</a:t>
+              <a:t>• Bên phải: Thực thi câu lệnh trực tiếp trong CSDL SQL Server 2025 (OwaspDemoDB) chứng minh cơ chế bẻ gãy cú pháp.</a:t>
             </a:r>
           </a:p>
         </p:txBody>
@@ -5020,8 +4887,8 @@
         </p:nvSpPr>
         <p:spPr>
           <a:xfrm>
-            <a:off x="731520" y="6492240"/>
-            <a:ext cx="10698480" cy="274320"/>
+            <a:off x="731520" y="6537960"/>
+            <a:ext cx="10698480" cy="228600"/>
           </a:xfrm>
           <a:prstGeom prst="rect">
             <a:avLst/>
@@ -5429,8 +5296,8 @@
         </p:nvSpPr>
         <p:spPr>
           <a:xfrm>
-            <a:off x="731520" y="6492240"/>
-            <a:ext cx="10698480" cy="274320"/>
+            <a:off x="731520" y="6537960"/>
+            <a:ext cx="10698480" cy="228600"/>
           </a:xfrm>
           <a:prstGeom prst="rect">
             <a:avLst/>

</xml_diff>

<commit_message>
feat: embed student real VS Code SQL Server screenshot into Slide 7
</commit_message>
<xml_diff>
--- a/Slide_OWASP_SQL_Injection.pptx
+++ b/Slide_OWASP_SQL_Injection.pptx
@@ -13,6 +13,7 @@
     <p:sldId id="261" r:id="rId12"/>
     <p:sldId id="262" r:id="rId13"/>
     <p:sldId id="263" r:id="rId14"/>
+    <p:sldId id="264" r:id="rId15"/>
   </p:sldIdLst>
   <p:sldSz cx="12191695" cy="6858000" type="screen4x3"/>
   <p:notesSz cx="6858000" cy="9144000"/>
@@ -4874,7 +4875,7 @@
               </a:defRPr>
             </a:pPr>
             <a:r>
-              <a:t>6. Biện Pháp Phòng Thủ Chuẩn Trong ASP.NET Core MVC</a:t>
+              <a:t>6. Minh Chứng Thực Nghiệm 3: Thao Tác Trực Tiếp Trên VS Code &amp; Extension SQL Server</a:t>
             </a:r>
           </a:p>
         </p:txBody>
@@ -4914,51 +4915,30 @@
           </a:p>
         </p:txBody>
       </p:sp>
-      <p:sp>
-        <p:nvSpPr>
-          <p:cNvPr id="5" name="Rounded Rectangle 4"/>
-          <p:cNvSpPr/>
+      <p:pic>
+        <p:nvPicPr>
+          <p:cNvPr id="5" name="Picture 4" descr="my_vscode_sql_real.png"/>
+          <p:cNvPicPr>
+            <a:picLocks noChangeAspect="1"/>
+          </p:cNvPicPr>
           <p:nvPr/>
-        </p:nvSpPr>
-        <p:spPr>
-          <a:xfrm>
-            <a:off x="731520" y="1188720"/>
-            <a:ext cx="5212080" cy="4937760"/>
-          </a:xfrm>
-          <a:prstGeom prst="roundRect">
+        </p:nvPicPr>
+        <p:blipFill>
+          <a:blip r:embed="rId2"/>
+          <a:stretch>
+            <a:fillRect/>
+          </a:stretch>
+        </p:blipFill>
+        <p:spPr>
+          <a:xfrm>
+            <a:off x="731520" y="1371600"/>
+            <a:ext cx="10698480" cy="2402867"/>
+          </a:xfrm>
+          <a:prstGeom prst="rect">
             <a:avLst/>
           </a:prstGeom>
-          <a:solidFill>
-            <a:srgbClr val="F8FAFC"/>
-          </a:solidFill>
-          <a:ln>
-            <a:solidFill>
-              <a:srgbClr val="16A34A"/>
-            </a:solidFill>
-          </a:ln>
-        </p:spPr>
-        <p:style>
-          <a:lnRef idx="1">
-            <a:schemeClr val="accent1"/>
-          </a:lnRef>
-          <a:fillRef idx="3">
-            <a:schemeClr val="accent1"/>
-          </a:fillRef>
-          <a:effectRef idx="2">
-            <a:schemeClr val="accent1"/>
-          </a:effectRef>
-          <a:fontRef idx="minor">
-            <a:schemeClr val="lt1"/>
-          </a:fontRef>
-        </p:style>
-        <p:txBody>
-          <a:bodyPr rtlCol="0" anchor="ctr"/>
-          <a:lstStyle/>
-          <a:p>
-            <a:pPr algn="ctr"/>
-          </a:p>
-        </p:txBody>
-      </p:sp>
+        </p:spPr>
+      </p:pic>
       <p:sp>
         <p:nvSpPr>
           <p:cNvPr id="6" name="TextBox 5"/>
@@ -4967,8 +4947,8 @@
         </p:nvSpPr>
         <p:spPr>
           <a:xfrm>
-            <a:off x="914400" y="1280160"/>
-            <a:ext cx="4846320" cy="4663440"/>
+            <a:off x="731520" y="4114800"/>
+            <a:ext cx="10698480" cy="2194560"/>
           </a:xfrm>
           <a:prstGeom prst="rect">
             <a:avLst/>
@@ -4982,14 +4962,14 @@
           <a:lstStyle/>
           <a:p>
             <a:pPr>
-              <a:defRPr sz="1400" b="1">
-                <a:solidFill>
-                  <a:srgbClr val="16A34A"/>
-                </a:solidFill>
-              </a:defRPr>
-            </a:pPr>
-            <a:r>
-              <a:t>Cách Viết Code Chuẩn Hóa Với EF Core</a:t>
+              <a:defRPr sz="1500" b="1">
+                <a:solidFill>
+                  <a:srgbClr val="2563EB"/>
+                </a:solidFill>
+              </a:defRPr>
+            </a:pPr>
+            <a:r>
+              <a:t>Xác nhận môi trường thực nghiệm thực tế của sinh viên:</a:t>
             </a:r>
           </a:p>
           <a:p>
@@ -4997,185 +4977,26 @@
               <a:spcBef>
                 <a:spcPts val="800"/>
               </a:spcBef>
-              <a:defRPr sz="1000">
-                <a:solidFill>
-                  <a:srgbClr val="166534"/>
-                </a:solidFill>
-                <a:latin typeface="Courier New"/>
-              </a:defRPr>
-            </a:pPr>
-            <a:r>
-              <a:t>// Dùng LINQ Parameterized (KHUYÊN DÙNG):</a:t>
+              <a:defRPr sz="1300">
+                <a:solidFill>
+                  <a:srgbClr val="1E293B"/>
+                </a:solidFill>
+              </a:defRPr>
+            </a:pPr>
+            <a:r>
+              <a:t>• Công cụ: Visual Studio Code kết hợp Extension Microsoft MSSQL.</a:t>
             </a:r>
             <a:br/>
             <a:r>
-              <a:t>var account = _context.Accounts</a:t>
+              <a:t>• Máy chủ CSDL: Microsoft SQL Server 2025 Developer chạy trực tiếp trên Localhost (Port 1433).</a:t>
             </a:r>
             <a:br/>
             <a:r>
-              <a:t>    .FirstOrDefault(a =&gt; a.Username == user </a:t>
+              <a:t>• Cơ sở dữ liệu: OwaspDemoDB, bảng Accounts chứa dữ liệu thực nghiệm (Admin, Chuyên gia, Khách hàng).</a:t>
             </a:r>
             <a:br/>
             <a:r>
-              <a:t>                      &amp;&amp; a.Password == pass);</a:t>
-            </a:r>
-            <a:br/>
-            <a:br/>
-            <a:r>
-              <a:t>// Hoặc dùng FromSqlInterpolated nếu viết SQL thuần:</a:t>
-            </a:r>
-            <a:br/>
-            <a:r>
-              <a:t>var account = _context.Accounts</a:t>
-            </a:r>
-            <a:br/>
-            <a:r>
-              <a:t>    .FromSqlInterpolated($"SELECT * FROM Accounts WHERE Username={user} AND Password={pass}")</a:t>
-            </a:r>
-            <a:br/>
-            <a:r>
-              <a:t>    .FirstOrDefault();</a:t>
-            </a:r>
-          </a:p>
-          <a:p>
-            <a:pPr>
-              <a:spcBef>
-                <a:spcPts val="1200"/>
-              </a:spcBef>
-              <a:defRPr sz="1200" b="1">
-                <a:solidFill>
-                  <a:srgbClr val="1E293B"/>
-                </a:solidFill>
-              </a:defRPr>
-            </a:pPr>
-            <a:r>
-              <a:t>Tại sao cách này an toàn tuyệt đối?</a:t>
-            </a:r>
-          </a:p>
-          <a:p>
-            <a:pPr>
-              <a:spcBef>
-                <a:spcPts val="400"/>
-              </a:spcBef>
-              <a:defRPr sz="1100">
-                <a:solidFill>
-                  <a:srgbClr val="64748B"/>
-                </a:solidFill>
-              </a:defRPr>
-            </a:pPr>
-            <a:r>
-              <a:t>SQL Server biên dịch cấu trúc lệnh TRƯỚC khi gán dữ liệu. Biến @p0 nhận toàn bộ payload như một chuỗi chữ bình thường, vô hiệu hóa hoàn toàn ý đồ chèn lệnh.</a:t>
-            </a:r>
-          </a:p>
-        </p:txBody>
-      </p:sp>
-      <p:sp>
-        <p:nvSpPr>
-          <p:cNvPr id="7" name="TextBox 6"/>
-          <p:cNvSpPr txBox="1"/>
-          <p:nvPr/>
-        </p:nvSpPr>
-        <p:spPr>
-          <a:xfrm>
-            <a:off x="6309360" y="1188720"/>
-            <a:ext cx="5120640" cy="4937760"/>
-          </a:xfrm>
-          <a:prstGeom prst="rect">
-            <a:avLst/>
-          </a:prstGeom>
-          <a:noFill/>
-        </p:spPr>
-        <p:txBody>
-          <a:bodyPr wrap="square">
-            <a:spAutoFit/>
-          </a:bodyPr>
-          <a:lstStyle/>
-          <a:p>
-            <a:pPr>
-              <a:defRPr sz="1500" b="1">
-                <a:solidFill>
-                  <a:srgbClr val="2563EB"/>
-                </a:solidFill>
-              </a:defRPr>
-            </a:pPr>
-            <a:r>
-              <a:t>Bộ Quy Tắc Phòng Thủ Toàn Diện (Defense in Depth)</a:t>
-            </a:r>
-          </a:p>
-          <a:p>
-            <a:pPr>
-              <a:spcBef>
-                <a:spcPts val="1000"/>
-              </a:spcBef>
-              <a:defRPr sz="1200">
-                <a:solidFill>
-                  <a:srgbClr val="1E293B"/>
-                </a:solidFill>
-              </a:defRPr>
-            </a:pPr>
-            <a:r>
-              <a:t>1. Luôn sử dụng Parameterized Query / ORM:</a:t>
-            </a:r>
-            <a:br/>
-            <a:r>
-              <a:t>Tuyệt đối không ghép chuỗi SQL thủ công dưới bất kỳ hình thức nào.</a:t>
-            </a:r>
-          </a:p>
-          <a:p>
-            <a:pPr>
-              <a:spcBef>
-                <a:spcPts val="800"/>
-              </a:spcBef>
-              <a:defRPr sz="1200">
-                <a:solidFill>
-                  <a:srgbClr val="1E293B"/>
-                </a:solidFill>
-              </a:defRPr>
-            </a:pPr>
-            <a:r>
-              <a:t>2. Nguyên tắc đặc quyền tối thiểu (Least Privilege):</a:t>
-            </a:r>
-            <a:br/>
-            <a:r>
-              <a:t>Tài khoản kết nối CSDL của ứng dụng chỉ có quyền SELECT/INSERT/UPDATE trên các bảng cần thiết, không bao giờ dùng tài khoản 'sa' hay quyền DDL (DROP, ALTER).</a:t>
-            </a:r>
-          </a:p>
-          <a:p>
-            <a:pPr>
-              <a:spcBef>
-                <a:spcPts val="800"/>
-              </a:spcBef>
-              <a:defRPr sz="1200">
-                <a:solidFill>
-                  <a:srgbClr val="1E293B"/>
-                </a:solidFill>
-              </a:defRPr>
-            </a:pPr>
-            <a:r>
-              <a:t>3. Xác thực dữ liệu đầu vào (Input Validation):</a:t>
-            </a:r>
-            <a:br/>
-            <a:r>
-              <a:t>Sử dụng Data Annotations ([RegularExpression], [StringLength]) kiểm tra chặt chẽ khuôn dạng dữ liệu.</a:t>
-            </a:r>
-          </a:p>
-          <a:p>
-            <a:pPr>
-              <a:spcBef>
-                <a:spcPts val="800"/>
-              </a:spcBef>
-              <a:defRPr sz="1200">
-                <a:solidFill>
-                  <a:srgbClr val="1E293B"/>
-                </a:solidFill>
-              </a:defRPr>
-            </a:pPr>
-            <a:r>
-              <a:t>4. Mã hóa mật khẩu một chiều (Password Hashing):</a:t>
-            </a:r>
-            <a:br/>
-            <a:r>
-              <a:t>Sử dụng ASP.NET Core Identity (PBKDF2/BCrypt) để nếu CSDL có bị lộ, mật khẩu vẫn được bảo vệ an toàn.</a:t>
+              <a:t>• Kết quả: Bảng dữ liệu được truy vấn và hiển thị trực tiếp trong trình soạn thảo, hoàn toàn đồng bộ với kết quả trích xuất trên ứng dụng web.</a:t>
             </a:r>
           </a:p>
         </p:txBody>
@@ -5283,7 +5104,416 @@
               </a:defRPr>
             </a:pPr>
             <a:r>
-              <a:t>7. Tổng Kết &amp; Bài Học Rút Ra Cho Dự Án Website Tư Vấn Trực Tuyến</a:t>
+              <a:t>7. Biện Pháp Phòng Thủ Chuẩn Trong ASP.NET Core MVC</a:t>
+            </a:r>
+          </a:p>
+        </p:txBody>
+      </p:sp>
+      <p:sp>
+        <p:nvSpPr>
+          <p:cNvPr id="4" name="TextBox 3"/>
+          <p:cNvSpPr txBox="1"/>
+          <p:nvPr/>
+        </p:nvSpPr>
+        <p:spPr>
+          <a:xfrm>
+            <a:off x="731520" y="6537960"/>
+            <a:ext cx="10698480" cy="228600"/>
+          </a:xfrm>
+          <a:prstGeom prst="rect">
+            <a:avLst/>
+          </a:prstGeom>
+          <a:noFill/>
+        </p:spPr>
+        <p:txBody>
+          <a:bodyPr wrap="none">
+            <a:spAutoFit/>
+          </a:bodyPr>
+          <a:lstStyle/>
+          <a:p>
+            <a:pPr>
+              <a:defRPr sz="950">
+                <a:solidFill>
+                  <a:srgbClr val="64748B"/>
+                </a:solidFill>
+              </a:defRPr>
+            </a:pPr>
+            <a:r>
+              <a:t>Nhóm WNC.G01 (HOU) • Môn Lập Trình Web Nâng Cao • ThS. Lê Hữu Dũng</a:t>
+            </a:r>
+          </a:p>
+        </p:txBody>
+      </p:sp>
+      <p:sp>
+        <p:nvSpPr>
+          <p:cNvPr id="5" name="Rounded Rectangle 4"/>
+          <p:cNvSpPr/>
+          <p:nvPr/>
+        </p:nvSpPr>
+        <p:spPr>
+          <a:xfrm>
+            <a:off x="731520" y="1188720"/>
+            <a:ext cx="5212080" cy="4937760"/>
+          </a:xfrm>
+          <a:prstGeom prst="roundRect">
+            <a:avLst/>
+          </a:prstGeom>
+          <a:solidFill>
+            <a:srgbClr val="F8FAFC"/>
+          </a:solidFill>
+          <a:ln>
+            <a:solidFill>
+              <a:srgbClr val="16A34A"/>
+            </a:solidFill>
+          </a:ln>
+        </p:spPr>
+        <p:style>
+          <a:lnRef idx="1">
+            <a:schemeClr val="accent1"/>
+          </a:lnRef>
+          <a:fillRef idx="3">
+            <a:schemeClr val="accent1"/>
+          </a:fillRef>
+          <a:effectRef idx="2">
+            <a:schemeClr val="accent1"/>
+          </a:effectRef>
+          <a:fontRef idx="minor">
+            <a:schemeClr val="lt1"/>
+          </a:fontRef>
+        </p:style>
+        <p:txBody>
+          <a:bodyPr rtlCol="0" anchor="ctr"/>
+          <a:lstStyle/>
+          <a:p>
+            <a:pPr algn="ctr"/>
+          </a:p>
+        </p:txBody>
+      </p:sp>
+      <p:sp>
+        <p:nvSpPr>
+          <p:cNvPr id="6" name="TextBox 5"/>
+          <p:cNvSpPr txBox="1"/>
+          <p:nvPr/>
+        </p:nvSpPr>
+        <p:spPr>
+          <a:xfrm>
+            <a:off x="914400" y="1280160"/>
+            <a:ext cx="4846320" cy="4663440"/>
+          </a:xfrm>
+          <a:prstGeom prst="rect">
+            <a:avLst/>
+          </a:prstGeom>
+          <a:noFill/>
+        </p:spPr>
+        <p:txBody>
+          <a:bodyPr wrap="square">
+            <a:spAutoFit/>
+          </a:bodyPr>
+          <a:lstStyle/>
+          <a:p>
+            <a:pPr>
+              <a:defRPr sz="1400" b="1">
+                <a:solidFill>
+                  <a:srgbClr val="16A34A"/>
+                </a:solidFill>
+              </a:defRPr>
+            </a:pPr>
+            <a:r>
+              <a:t>Cách Viết Code Chuẩn Hóa Với EF Core</a:t>
+            </a:r>
+          </a:p>
+          <a:p>
+            <a:pPr>
+              <a:spcBef>
+                <a:spcPts val="800"/>
+              </a:spcBef>
+              <a:defRPr sz="1000">
+                <a:solidFill>
+                  <a:srgbClr val="166534"/>
+                </a:solidFill>
+                <a:latin typeface="Courier New"/>
+              </a:defRPr>
+            </a:pPr>
+            <a:r>
+              <a:t>// Dùng LINQ Parameterized (KHUYÊN DÙNG):</a:t>
+            </a:r>
+            <a:br/>
+            <a:r>
+              <a:t>var account = _context.Accounts</a:t>
+            </a:r>
+            <a:br/>
+            <a:r>
+              <a:t>    .FirstOrDefault(a =&gt; a.Username == user </a:t>
+            </a:r>
+            <a:br/>
+            <a:r>
+              <a:t>                      &amp;&amp; a.Password == pass);</a:t>
+            </a:r>
+            <a:br/>
+            <a:br/>
+            <a:r>
+              <a:t>// Hoặc dùng FromSqlInterpolated nếu viết SQL thuần:</a:t>
+            </a:r>
+            <a:br/>
+            <a:r>
+              <a:t>var account = _context.Accounts</a:t>
+            </a:r>
+            <a:br/>
+            <a:r>
+              <a:t>    .FromSqlInterpolated($"SELECT * FROM Accounts WHERE Username={user} AND Password={pass}")</a:t>
+            </a:r>
+            <a:br/>
+            <a:r>
+              <a:t>    .FirstOrDefault();</a:t>
+            </a:r>
+          </a:p>
+          <a:p>
+            <a:pPr>
+              <a:spcBef>
+                <a:spcPts val="1200"/>
+              </a:spcBef>
+              <a:defRPr sz="1200" b="1">
+                <a:solidFill>
+                  <a:srgbClr val="1E293B"/>
+                </a:solidFill>
+              </a:defRPr>
+            </a:pPr>
+            <a:r>
+              <a:t>Tại sao cách này an toàn tuyệt đối?</a:t>
+            </a:r>
+          </a:p>
+          <a:p>
+            <a:pPr>
+              <a:spcBef>
+                <a:spcPts val="400"/>
+              </a:spcBef>
+              <a:defRPr sz="1100">
+                <a:solidFill>
+                  <a:srgbClr val="64748B"/>
+                </a:solidFill>
+              </a:defRPr>
+            </a:pPr>
+            <a:r>
+              <a:t>SQL Server biên dịch cấu trúc lệnh TRƯỚC khi gán dữ liệu. Biến @p0 nhận toàn bộ payload như một chuỗi chữ bình thường, vô hiệu hóa hoàn toàn ý đồ chèn lệnh.</a:t>
+            </a:r>
+          </a:p>
+        </p:txBody>
+      </p:sp>
+      <p:sp>
+        <p:nvSpPr>
+          <p:cNvPr id="7" name="TextBox 6"/>
+          <p:cNvSpPr txBox="1"/>
+          <p:nvPr/>
+        </p:nvSpPr>
+        <p:spPr>
+          <a:xfrm>
+            <a:off x="6309360" y="1188720"/>
+            <a:ext cx="5120640" cy="4937760"/>
+          </a:xfrm>
+          <a:prstGeom prst="rect">
+            <a:avLst/>
+          </a:prstGeom>
+          <a:noFill/>
+        </p:spPr>
+        <p:txBody>
+          <a:bodyPr wrap="square">
+            <a:spAutoFit/>
+          </a:bodyPr>
+          <a:lstStyle/>
+          <a:p>
+            <a:pPr>
+              <a:defRPr sz="1500" b="1">
+                <a:solidFill>
+                  <a:srgbClr val="2563EB"/>
+                </a:solidFill>
+              </a:defRPr>
+            </a:pPr>
+            <a:r>
+              <a:t>Bộ Quy Tắc Phòng Thủ Toàn Diện (Defense in Depth)</a:t>
+            </a:r>
+          </a:p>
+          <a:p>
+            <a:pPr>
+              <a:spcBef>
+                <a:spcPts val="1000"/>
+              </a:spcBef>
+              <a:defRPr sz="1200">
+                <a:solidFill>
+                  <a:srgbClr val="1E293B"/>
+                </a:solidFill>
+              </a:defRPr>
+            </a:pPr>
+            <a:r>
+              <a:t>1. Luôn sử dụng Parameterized Query / ORM:</a:t>
+            </a:r>
+            <a:br/>
+            <a:r>
+              <a:t>Tuyệt đối không ghép chuỗi SQL thủ công dưới bất kỳ hình thức nào.</a:t>
+            </a:r>
+          </a:p>
+          <a:p>
+            <a:pPr>
+              <a:spcBef>
+                <a:spcPts val="800"/>
+              </a:spcBef>
+              <a:defRPr sz="1200">
+                <a:solidFill>
+                  <a:srgbClr val="1E293B"/>
+                </a:solidFill>
+              </a:defRPr>
+            </a:pPr>
+            <a:r>
+              <a:t>2. Nguyên tắc đặc quyền tối thiểu (Least Privilege):</a:t>
+            </a:r>
+            <a:br/>
+            <a:r>
+              <a:t>Tài khoản kết nối CSDL của ứng dụng chỉ có quyền SELECT/INSERT/UPDATE trên các bảng cần thiết, không bao giờ dùng tài khoản 'sa' hay quyền DDL (DROP, ALTER).</a:t>
+            </a:r>
+          </a:p>
+          <a:p>
+            <a:pPr>
+              <a:spcBef>
+                <a:spcPts val="800"/>
+              </a:spcBef>
+              <a:defRPr sz="1200">
+                <a:solidFill>
+                  <a:srgbClr val="1E293B"/>
+                </a:solidFill>
+              </a:defRPr>
+            </a:pPr>
+            <a:r>
+              <a:t>3. Xác thực dữ liệu đầu vào (Input Validation):</a:t>
+            </a:r>
+            <a:br/>
+            <a:r>
+              <a:t>Sử dụng Data Annotations ([RegularExpression], [StringLength]) kiểm tra chặt chẽ khuôn dạng dữ liệu.</a:t>
+            </a:r>
+          </a:p>
+          <a:p>
+            <a:pPr>
+              <a:spcBef>
+                <a:spcPts val="800"/>
+              </a:spcBef>
+              <a:defRPr sz="1200">
+                <a:solidFill>
+                  <a:srgbClr val="1E293B"/>
+                </a:solidFill>
+              </a:defRPr>
+            </a:pPr>
+            <a:r>
+              <a:t>4. Mã hóa mật khẩu một chiều (Password Hashing):</a:t>
+            </a:r>
+            <a:br/>
+            <a:r>
+              <a:t>Sử dụng ASP.NET Core Identity (PBKDF2/BCrypt) để nếu CSDL có bị lộ, mật khẩu vẫn được bảo vệ an toàn.</a:t>
+            </a:r>
+          </a:p>
+        </p:txBody>
+      </p:sp>
+    </p:spTree>
+  </p:cSld>
+  <p:clrMapOvr>
+    <a:masterClrMapping/>
+  </p:clrMapOvr>
+</p:sld>
+</file>
+
+<file path=ppt/slides/slide9.xml><?xml version="1.0" encoding="utf-8"?>
+<p:sld xmlns:a="http://schemas.openxmlformats.org/drawingml/2006/main" xmlns:p="http://schemas.openxmlformats.org/presentationml/2006/main" xmlns:r="http://schemas.openxmlformats.org/officeDocument/2006/relationships">
+  <p:cSld>
+    <p:spTree>
+      <p:nvGrpSpPr>
+        <p:cNvPr id="1" name=""/>
+        <p:cNvGrpSpPr/>
+        <p:nvPr/>
+      </p:nvGrpSpPr>
+      <p:grpSpPr/>
+      <p:sp>
+        <p:nvSpPr>
+          <p:cNvPr id="2" name="Rectangle 1"/>
+          <p:cNvSpPr/>
+          <p:nvPr/>
+        </p:nvSpPr>
+        <p:spPr>
+          <a:xfrm>
+            <a:off x="0" y="0"/>
+            <a:ext cx="12191695" cy="1005840"/>
+          </a:xfrm>
+          <a:prstGeom prst="rect">
+            <a:avLst/>
+          </a:prstGeom>
+          <a:solidFill>
+            <a:srgbClr val="0F172A"/>
+          </a:solidFill>
+          <a:ln>
+            <a:noFill/>
+          </a:ln>
+        </p:spPr>
+        <p:style>
+          <a:lnRef idx="1">
+            <a:schemeClr val="accent1"/>
+          </a:lnRef>
+          <a:fillRef idx="3">
+            <a:schemeClr val="accent1"/>
+          </a:fillRef>
+          <a:effectRef idx="2">
+            <a:schemeClr val="accent1"/>
+          </a:effectRef>
+          <a:fontRef idx="minor">
+            <a:schemeClr val="lt1"/>
+          </a:fontRef>
+        </p:style>
+        <p:txBody>
+          <a:bodyPr rtlCol="0" anchor="ctr"/>
+          <a:lstStyle/>
+          <a:p>
+            <a:pPr algn="ctr"/>
+          </a:p>
+        </p:txBody>
+      </p:sp>
+      <p:sp>
+        <p:nvSpPr>
+          <p:cNvPr id="3" name="TextBox 2"/>
+          <p:cNvSpPr txBox="1"/>
+          <p:nvPr/>
+        </p:nvSpPr>
+        <p:spPr>
+          <a:xfrm>
+            <a:off x="731520" y="109728"/>
+            <a:ext cx="10698480" cy="320040"/>
+          </a:xfrm>
+          <a:prstGeom prst="rect">
+            <a:avLst/>
+          </a:prstGeom>
+          <a:noFill/>
+        </p:spPr>
+        <p:txBody>
+          <a:bodyPr wrap="square">
+            <a:spAutoFit/>
+          </a:bodyPr>
+          <a:lstStyle/>
+          <a:p>
+            <a:pPr>
+              <a:defRPr sz="1100" b="1">
+                <a:solidFill>
+                  <a:srgbClr val="DC2626"/>
+                </a:solidFill>
+              </a:defRPr>
+            </a:pPr>
+            <a:r>
+              <a:t>OWASP TOP 10 - A03:2021 (INJECTION)</a:t>
+            </a:r>
+          </a:p>
+          <a:p>
+            <a:pPr>
+              <a:defRPr sz="1900" b="1">
+                <a:solidFill>
+                  <a:srgbClr val="FFFFFF"/>
+                </a:solidFill>
+              </a:defRPr>
+            </a:pPr>
+            <a:r>
+              <a:t>8. Tổng Kết &amp; Bài Học Rút Ra Cho Dự Án Website Tư Vấn Trực Tuyến</a:t>
             </a:r>
           </a:p>
         </p:txBody>

</xml_diff>

<commit_message>
feat: complete professional presentation deck without messy screenshots, with dedicated Live Demo callouts
</commit_message>
<xml_diff>
--- a/Slide_OWASP_SQL_Injection.pptx
+++ b/Slide_OWASP_SQL_Injection.pptx
@@ -13,7 +13,6 @@
     <p:sldId id="261" r:id="rId12"/>
     <p:sldId id="262" r:id="rId13"/>
     <p:sldId id="263" r:id="rId14"/>
-    <p:sldId id="264" r:id="rId15"/>
   </p:sldIdLst>
   <p:sldSz cx="12191695" cy="6858000" type="screen4x3"/>
   <p:notesSz cx="6858000" cy="9144000"/>
@@ -3147,8 +3146,8 @@
         </p:nvSpPr>
         <p:spPr>
           <a:xfrm>
-            <a:off x="914400" y="1097280"/>
-            <a:ext cx="10362895" cy="4572000"/>
+            <a:off x="914400" y="1005840"/>
+            <a:ext cx="10362895" cy="4754880"/>
           </a:xfrm>
           <a:prstGeom prst="rect">
             <a:avLst/>
@@ -3177,14 +3176,14 @@
               <a:spcBef>
                 <a:spcPts val="1400"/>
               </a:spcBef>
-              <a:defRPr sz="1800" b="1">
-                <a:solidFill>
-                  <a:srgbClr val="DC2626"/>
-                </a:solidFill>
-              </a:defRPr>
-            </a:pPr>
-            <a:r>
-              <a:t>BÁO CÁO THỰC NGHIỆM LỖ HỔNG AN TOÀN WEB</a:t>
+              <a:defRPr sz="1700" b="1">
+                <a:solidFill>
+                  <a:srgbClr val="E11D48"/>
+                </a:solidFill>
+              </a:defRPr>
+            </a:pPr>
+            <a:r>
+              <a:t>BÁO CÁO THỰC NGHIỆM AN TOÀN WEB &amp; BẢO MẬT HỆ THỐNG</a:t>
             </a:r>
           </a:p>
           <a:p>
@@ -3199,17 +3198,17 @@
               </a:defRPr>
             </a:pPr>
             <a:r>
-              <a:t>SQL INJECTION (OWASP A03:2021)</a:t>
-            </a:r>
-            <a:br/>
-            <a:r>
-              <a:t>Kịch Bản Tấn Công &amp; Phòng Thủ Đa Tầng (Web UI, API CLI &amp; CSDL SQL Server 2025)</a:t>
+              <a:t>LỖ HỔNG SQL INJECTION (OWASP A03:2021)</a:t>
+            </a:r>
+            <a:br/>
+            <a:r>
+              <a:t>Kịch Bản Khai Thác Thực Tế &amp; Cơ Chế Phòng Thủ Trong ASP.NET Core</a:t>
             </a:r>
           </a:p>
           <a:p>
             <a:pPr>
               <a:spcBef>
-                <a:spcPts val="2000"/>
+                <a:spcPts val="1800"/>
               </a:spcBef>
               <a:defRPr sz="1400">
                 <a:solidFill>
@@ -3218,17 +3217,13 @@
               </a:defRPr>
             </a:pPr>
             <a:r>
-              <a:t>Giảng viên hướng dẫn: ThS. Lê Hữu Dũng</a:t>
-            </a:r>
-            <a:br/>
-            <a:r>
-              <a:t>Môn học: Lập trình Web nâng cao</a:t>
+              <a:t>Giảng viên hướng dẫn: ThS. Lê Hữu Dũng | Học phần: Lập trình Web nâng cao</a:t>
             </a:r>
           </a:p>
           <a:p>
             <a:pPr>
               <a:spcBef>
-                <a:spcPts val="1600"/>
+                <a:spcPts val="1400"/>
               </a:spcBef>
               <a:defRPr sz="1300">
                 <a:solidFill>
@@ -3237,19 +3232,19 @@
               </a:defRPr>
             </a:pPr>
             <a:r>
-              <a:t>Nhóm thực hiện: WNC.G01</a:t>
-            </a:r>
-            <a:br/>
-            <a:r>
-              <a:t>1. Nguyễn Danh Học (MSV: 23A1001D0158) — Báo cáo &amp; Thực nghiệm chính</a:t>
-            </a:r>
-            <a:br/>
-            <a:r>
-              <a:t>2. Nguyễn Thanh Bình (MSV: 23A1001D0041)</a:t>
-            </a:r>
-            <a:br/>
-            <a:r>
-              <a:t>3. Nguyễn Minh Cường (MSV: 23A1001D0058)</a:t>
+              <a:t>Nhóm sinh viên thực hiện (WNC.G01):</a:t>
+            </a:r>
+            <a:br/>
+            <a:r>
+              <a:t>1. Nguyễn Danh Học  — MSV: 23A1001D0158 (Báo cáo &amp; Phụ trách demo chính)</a:t>
+            </a:r>
+            <a:br/>
+            <a:r>
+              <a:t>2. Nguyễn Thanh Bình — MSV: 23A1001D0041</a:t>
+            </a:r>
+            <a:br/>
+            <a:r>
+              <a:t>3. Nguyễn Minh Cường — MSV: 23A1001D0058</a:t>
             </a:r>
           </a:p>
         </p:txBody>
@@ -3281,7 +3276,7 @@
         <p:spPr>
           <a:xfrm>
             <a:off x="0" y="0"/>
-            <a:ext cx="12191695" cy="1005840"/>
+            <a:ext cx="12191695" cy="1051560"/>
           </a:xfrm>
           <a:prstGeom prst="rect">
             <a:avLst/>
@@ -3324,7 +3319,7 @@
         <p:spPr>
           <a:xfrm>
             <a:off x="731520" y="109728"/>
-            <a:ext cx="10698480" cy="320040"/>
+            <a:ext cx="10698480" cy="274320"/>
           </a:xfrm>
           <a:prstGeom prst="rect">
             <a:avLst/>
@@ -3340,7 +3335,7 @@
             <a:pPr>
               <a:defRPr sz="1100" b="1">
                 <a:solidFill>
-                  <a:srgbClr val="DC2626"/>
+                  <a:srgbClr val="E11D48"/>
                 </a:solidFill>
               </a:defRPr>
             </a:pPr>
@@ -3370,8 +3365,8 @@
         </p:nvSpPr>
         <p:spPr>
           <a:xfrm>
-            <a:off x="731520" y="6537960"/>
-            <a:ext cx="10698480" cy="228600"/>
+            <a:off x="731520" y="6492240"/>
+            <a:ext cx="10698480" cy="274320"/>
           </a:xfrm>
           <a:prstGeom prst="rect">
             <a:avLst/>
@@ -3405,7 +3400,7 @@
         </p:nvSpPr>
         <p:spPr>
           <a:xfrm>
-            <a:off x="731520" y="1188720"/>
+            <a:off x="731520" y="1234440"/>
             <a:ext cx="5120640" cy="4937760"/>
           </a:xfrm>
           <a:prstGeom prst="rect">
@@ -3422,7 +3417,7 @@
             <a:pPr>
               <a:defRPr sz="1600" b="1">
                 <a:solidFill>
-                  <a:srgbClr val="DC2626"/>
+                  <a:srgbClr val="E11D48"/>
                 </a:solidFill>
               </a:defRPr>
             </a:pPr>
@@ -3456,7 +3451,7 @@
           <a:p>
             <a:pPr>
               <a:spcBef>
-                <a:spcPts val="1400"/>
+                <a:spcPts val="1600"/>
               </a:spcBef>
               <a:defRPr sz="1600" b="1">
                 <a:solidFill>
@@ -3473,7 +3468,7 @@
               <a:spcBef>
                 <a:spcPts val="600"/>
               </a:spcBef>
-              <a:defRPr sz="1200">
+              <a:defRPr sz="1250">
                 <a:solidFill>
                   <a:srgbClr val="1E293B"/>
                 </a:solidFill>
@@ -3501,7 +3496,7 @@
         </p:nvSpPr>
         <p:spPr>
           <a:xfrm>
-            <a:off x="6217920" y="1188720"/>
+            <a:off x="6217920" y="1234440"/>
             <a:ext cx="5212080" cy="4937760"/>
           </a:xfrm>
           <a:prstGeom prst="roundRect">
@@ -3546,8 +3541,8 @@
         </p:nvSpPr>
         <p:spPr>
           <a:xfrm>
-            <a:off x="6400800" y="1280160"/>
-            <a:ext cx="4846320" cy="4663440"/>
+            <a:off x="6400800" y="1371600"/>
+            <a:ext cx="4846320" cy="4572000"/>
           </a:xfrm>
           <a:prstGeom prst="rect">
             <a:avLst/>
@@ -3563,7 +3558,7 @@
             <a:pPr>
               <a:defRPr sz="1400" b="1">
                 <a:solidFill>
-                  <a:srgbClr val="DC2626"/>
+                  <a:srgbClr val="E11D48"/>
                 </a:solidFill>
               </a:defRPr>
             </a:pPr>
@@ -3671,7 +3666,7 @@
         <p:spPr>
           <a:xfrm>
             <a:off x="0" y="0"/>
-            <a:ext cx="12191695" cy="1005840"/>
+            <a:ext cx="12191695" cy="1051560"/>
           </a:xfrm>
           <a:prstGeom prst="rect">
             <a:avLst/>
@@ -3714,7 +3709,7 @@
         <p:spPr>
           <a:xfrm>
             <a:off x="731520" y="109728"/>
-            <a:ext cx="10698480" cy="320040"/>
+            <a:ext cx="10698480" cy="274320"/>
           </a:xfrm>
           <a:prstGeom prst="rect">
             <a:avLst/>
@@ -3730,7 +3725,7 @@
             <a:pPr>
               <a:defRPr sz="1100" b="1">
                 <a:solidFill>
-                  <a:srgbClr val="DC2626"/>
+                  <a:srgbClr val="E11D48"/>
                 </a:solidFill>
               </a:defRPr>
             </a:pPr>
@@ -3760,8 +3755,8 @@
         </p:nvSpPr>
         <p:spPr>
           <a:xfrm>
-            <a:off x="731520" y="6537960"/>
-            <a:ext cx="10698480" cy="228600"/>
+            <a:off x="731520" y="6492240"/>
+            <a:ext cx="10698480" cy="274320"/>
           </a:xfrm>
           <a:prstGeom prst="rect">
             <a:avLst/>
@@ -3796,17 +3791,17 @@
         <p:spPr>
           <a:xfrm>
             <a:off x="731520" y="1280160"/>
-            <a:ext cx="3291840" cy="4937760"/>
+            <a:ext cx="3291840" cy="4846320"/>
           </a:xfrm>
           <a:prstGeom prst="roundRect">
             <a:avLst/>
           </a:prstGeom>
           <a:solidFill>
-            <a:srgbClr val="FEF2F2"/>
+            <a:srgbClr val="FFF1F2"/>
           </a:solidFill>
           <a:ln>
             <a:solidFill>
-              <a:srgbClr val="DC2626"/>
+              <a:srgbClr val="E11D48"/>
             </a:solidFill>
           </a:ln>
         </p:spPr>
@@ -3841,7 +3836,7 @@
         <p:spPr>
           <a:xfrm>
             <a:off x="868680" y="1463040"/>
-            <a:ext cx="3017520" cy="4572000"/>
+            <a:ext cx="3017520" cy="4480560"/>
           </a:xfrm>
           <a:prstGeom prst="rect">
             <a:avLst/>
@@ -3857,7 +3852,7 @@
             <a:pPr>
               <a:defRPr sz="1400" b="1">
                 <a:solidFill>
-                  <a:srgbClr val="DC2626"/>
+                  <a:srgbClr val="E11D48"/>
                 </a:solidFill>
               </a:defRPr>
             </a:pPr>
@@ -3903,7 +3898,7 @@
         <p:spPr>
           <a:xfrm>
             <a:off x="4389120" y="1280160"/>
-            <a:ext cx="3291840" cy="4937760"/>
+            <a:ext cx="3291840" cy="4846320"/>
           </a:xfrm>
           <a:prstGeom prst="roundRect">
             <a:avLst/>
@@ -3948,7 +3943,7 @@
         <p:spPr>
           <a:xfrm>
             <a:off x="4526280" y="1463040"/>
-            <a:ext cx="3017520" cy="4572000"/>
+            <a:ext cx="3017520" cy="4480560"/>
           </a:xfrm>
           <a:prstGeom prst="rect">
             <a:avLst/>
@@ -3964,7 +3959,7 @@
             <a:pPr>
               <a:defRPr sz="1400" b="1">
                 <a:solidFill>
-                  <a:srgbClr val="B45309"/>
+                  <a:srgbClr val="D97706"/>
                 </a:solidFill>
               </a:defRPr>
             </a:pPr>
@@ -3996,7 +3991,7 @@
             </a:r>
             <a:br/>
             <a:r>
-              <a:t>• Vi phạm nghiêm trọng luật bảo vệ dữ liệu cá nhân, làm sụp đổ uy tín của hệ thống tư vấn trực tuyến.</a:t>
+              <a:t>• Vi phạm nghiêm trọng luật an ninh mạng, làm sụp đổ hoàn toàn uy tín nền tảng.</a:t>
             </a:r>
           </a:p>
         </p:txBody>
@@ -4010,13 +4005,13 @@
         <p:spPr>
           <a:xfrm>
             <a:off x="8046720" y="1280160"/>
-            <a:ext cx="3291840" cy="4937760"/>
+            <a:ext cx="3291840" cy="4846320"/>
           </a:xfrm>
           <a:prstGeom prst="roundRect">
             <a:avLst/>
           </a:prstGeom>
           <a:solidFill>
-            <a:srgbClr val="F1F5F9"/>
+            <a:srgbClr val="EFF6FF"/>
           </a:solidFill>
           <a:ln>
             <a:solidFill>
@@ -4055,7 +4050,7 @@
         <p:spPr>
           <a:xfrm>
             <a:off x="8183880" y="1463040"/>
-            <a:ext cx="3017520" cy="4572000"/>
+            <a:ext cx="3017520" cy="4480560"/>
           </a:xfrm>
           <a:prstGeom prst="rect">
             <a:avLst/>
@@ -4095,15 +4090,15 @@
               </a:defRPr>
             </a:pPr>
             <a:r>
-              <a:t>• Xóa sổ toàn bộ cơ sở dữ liệu với lệnh DROP TABLE hoặc TRUNCATE.</a:t>
-            </a:r>
-            <a:br/>
-            <a:r>
-              <a:t>• Thay đổi số dư tiền trong tài khoản trái phép.</a:t>
-            </a:r>
-            <a:br/>
-            <a:r>
-              <a:t>• Trong các CSDL cấu hình lỏng lẻo, hacker có thể bật xp_cmdshell để chiếm quyền điều khiển toàn bộ máy chủ hệ điều hành.</a:t>
+              <a:t>• Xóa sổ dữ liệu với lệnh DROP TABLE hoặc TRUNCATE.</a:t>
+            </a:r>
+            <a:br/>
+            <a:r>
+              <a:t>• Sửa đổi dữ liệu, giả mạo giao dịch tài chính.</a:t>
+            </a:r>
+            <a:br/>
+            <a:r>
+              <a:t>• Có thể kích hoạt quyền thực thi lệnh hệ điều hành (xp_cmdshell) nếu CSDL cấu hình lỏng lẻo.</a:t>
             </a:r>
           </a:p>
         </p:txBody>
@@ -4135,7 +4130,7 @@
         <p:spPr>
           <a:xfrm>
             <a:off x="0" y="0"/>
-            <a:ext cx="12191695" cy="1005840"/>
+            <a:ext cx="12191695" cy="1051560"/>
           </a:xfrm>
           <a:prstGeom prst="rect">
             <a:avLst/>
@@ -4178,7 +4173,7 @@
         <p:spPr>
           <a:xfrm>
             <a:off x="731520" y="109728"/>
-            <a:ext cx="10698480" cy="320040"/>
+            <a:ext cx="10698480" cy="274320"/>
           </a:xfrm>
           <a:prstGeom prst="rect">
             <a:avLst/>
@@ -4194,7 +4189,7 @@
             <a:pPr>
               <a:defRPr sz="1100" b="1">
                 <a:solidFill>
-                  <a:srgbClr val="DC2626"/>
+                  <a:srgbClr val="E11D48"/>
                 </a:solidFill>
               </a:defRPr>
             </a:pPr>
@@ -4211,7 +4206,7 @@
               </a:defRPr>
             </a:pPr>
             <a:r>
-              <a:t>3. Kịch Bản Tấn Công: Phân Tích Cơ Chế Bẻ Gãy Cú Pháp</a:t>
+              <a:t>3. Kịch Bản Tấn Công: Phân Tích Cơ Chế Bẻ Gãy Cú Pháp SQL</a:t>
             </a:r>
           </a:p>
         </p:txBody>
@@ -4224,8 +4219,8 @@
         </p:nvSpPr>
         <p:spPr>
           <a:xfrm>
-            <a:off x="731520" y="6537960"/>
-            <a:ext cx="10698480" cy="228600"/>
+            <a:off x="731520" y="6492240"/>
+            <a:ext cx="10698480" cy="274320"/>
           </a:xfrm>
           <a:prstGeom prst="rect">
             <a:avLst/>
@@ -4259,7 +4254,7 @@
         </p:nvSpPr>
         <p:spPr>
           <a:xfrm>
-            <a:off x="731520" y="1188720"/>
+            <a:off x="731520" y="1234440"/>
             <a:ext cx="10698480" cy="4937760"/>
           </a:xfrm>
           <a:prstGeom prst="rect">
@@ -4276,12 +4271,12 @@
             <a:pPr>
               <a:defRPr sz="1600" b="1">
                 <a:solidFill>
-                  <a:srgbClr val="DC2626"/>
-                </a:solidFill>
-              </a:defRPr>
-            </a:pPr>
-            <a:r>
-              <a:t>Kịch bản: Bypass xác thực đăng nhập Quản Trị Viên</a:t>
+                  <a:srgbClr val="E11D48"/>
+                </a:solidFill>
+              </a:defRPr>
+            </a:pPr>
+            <a:r>
+              <a:t>Kịch bản: Vượt qua xác thực đăng nhập (Authentication Bypass)</a:t>
             </a:r>
           </a:p>
           <a:p>
@@ -4289,7 +4284,7 @@
               <a:spcBef>
                 <a:spcPts val="800"/>
               </a:spcBef>
-              <a:defRPr sz="1350" b="1">
+              <a:defRPr sz="1300" b="1">
                 <a:solidFill>
                   <a:srgbClr val="2563EB"/>
                 </a:solidFill>
@@ -4297,11 +4292,11 @@
               </a:defRPr>
             </a:pPr>
             <a:r>
-              <a:t>Input đưa vào ô Username:   ' OR '1'='1' --</a:t>
-            </a:r>
-            <a:br/>
-            <a:r>
-              <a:t>Input đưa vào ô Password:   (Nhập chuỗi bất kỳ hoặc bỏ trống)</a:t>
+              <a:t>Payload đưa vào Username:   ' OR '1'='1' --</a:t>
+            </a:r>
+            <a:br/>
+            <a:r>
+              <a:t>Mật khẩu đưa vào Password: (Nhập bất kỳ hoặc để trống)</a:t>
             </a:r>
           </a:p>
           <a:p>
@@ -4316,7 +4311,7 @@
               </a:defRPr>
             </a:pPr>
             <a:r>
-              <a:t>Cấu trúc câu truy vấn được SQL Server thông dịch:</a:t>
+              <a:t>Cấu trúc câu truy vấn được SQL Server phân tích cú pháp:</a:t>
             </a:r>
           </a:p>
           <a:p>
@@ -4324,9 +4319,9 @@
               <a:spcBef>
                 <a:spcPts val="600"/>
               </a:spcBef>
-              <a:defRPr sz="1400" b="1">
-                <a:solidFill>
-                  <a:srgbClr val="DC2626"/>
+              <a:defRPr sz="1350" b="1">
+                <a:solidFill>
+                  <a:srgbClr val="E11D48"/>
                 </a:solidFill>
                 <a:latin typeface="Courier New"/>
               </a:defRPr>
@@ -4347,7 +4342,7 @@
               </a:defRPr>
             </a:pPr>
             <a:r>
-              <a:t>3 Thành Phần Của Payload Khai Thác:</a:t>
+              <a:t>3 Thành Phần Cốt Lõi Của Chuỗi Khai Thác:</a:t>
             </a:r>
           </a:p>
           <a:p>
@@ -4366,11 +4361,11 @@
             </a:r>
             <a:br/>
             <a:r>
-              <a:t>2. Mệnh đề OR '1'='1' : Mệnh đề luận lý chân lý. Vì '1'='1' luôn đúng, toàn bộ mệnh đề WHERE trả về TRUE cho TẤT CẢ các dòng trong bảng.</a:t>
-            </a:r>
-            <a:br/>
-            <a:r>
-              <a:t>3. Ký tự chú thích (--) : Trong SQL Server, '--' biến toàn bộ đoạn mã phía sau thành ghi chú vô hiệu, triệt tiêu hoàn toàn bước kiểm tra mật khẩu (AND Password = '...').</a:t>
+              <a:t>2. Mệnh đề OR '1'='1' : Mệnh đề chân lý logic. Vì '1'='1' luôn đúng, mệnh đề WHERE trả về TRUE cho toàn bộ bản ghi trong bảng.</a:t>
+            </a:r>
+            <a:br/>
+            <a:r>
+              <a:t>3. Ký tự chú thích (--) : Biến toàn bộ đoạn kiểm tra mật khẩu phía sau thành chú thích vô hiệu lực.</a:t>
             </a:r>
           </a:p>
         </p:txBody>
@@ -4402,7 +4397,7 @@
         <p:spPr>
           <a:xfrm>
             <a:off x="0" y="0"/>
-            <a:ext cx="12191695" cy="1005840"/>
+            <a:ext cx="12191695" cy="1051560"/>
           </a:xfrm>
           <a:prstGeom prst="rect">
             <a:avLst/>
@@ -4445,7 +4440,7 @@
         <p:spPr>
           <a:xfrm>
             <a:off x="731520" y="109728"/>
-            <a:ext cx="10698480" cy="320040"/>
+            <a:ext cx="10698480" cy="274320"/>
           </a:xfrm>
           <a:prstGeom prst="rect">
             <a:avLst/>
@@ -4461,7 +4456,7 @@
             <a:pPr>
               <a:defRPr sz="1100" b="1">
                 <a:solidFill>
-                  <a:srgbClr val="DC2626"/>
+                  <a:srgbClr val="E11D48"/>
                 </a:solidFill>
               </a:defRPr>
             </a:pPr>
@@ -4478,7 +4473,7 @@
               </a:defRPr>
             </a:pPr>
             <a:r>
-              <a:t>4. Minh Chứng Thực Nghiệm 1: Giao Diện Trình Duyệt Web (Đối Chứng Song Song)</a:t>
+              <a:t>4. Đối Chứng Thực Nghiệm: Nhánh Dính Lỗi vs Nhánh Đã Phòng Thủ</a:t>
             </a:r>
           </a:p>
         </p:txBody>
@@ -4491,8 +4486,8 @@
         </p:nvSpPr>
         <p:spPr>
           <a:xfrm>
-            <a:off x="731520" y="6537960"/>
-            <a:ext cx="10698480" cy="228600"/>
+            <a:off x="731520" y="6492240"/>
+            <a:ext cx="10698480" cy="274320"/>
           </a:xfrm>
           <a:prstGeom prst="rect">
             <a:avLst/>
@@ -4518,30 +4513,351 @@
           </a:p>
         </p:txBody>
       </p:sp>
-      <p:pic>
-        <p:nvPicPr>
-          <p:cNvPr id="5" name="Picture 4" descr="only_cards.png"/>
-          <p:cNvPicPr>
-            <a:picLocks noChangeAspect="1"/>
-          </p:cNvPicPr>
+      <p:sp>
+        <p:nvSpPr>
+          <p:cNvPr id="5" name="Rounded Rectangle 4"/>
+          <p:cNvSpPr/>
           <p:nvPr/>
-        </p:nvPicPr>
-        <p:blipFill>
-          <a:blip r:embed="rId2"/>
-          <a:stretch>
-            <a:fillRect/>
-          </a:stretch>
-        </p:blipFill>
-        <p:spPr>
-          <a:xfrm>
-            <a:off x="1517904" y="1280160"/>
-            <a:ext cx="9144000" cy="4885603"/>
+        </p:nvSpPr>
+        <p:spPr>
+          <a:xfrm>
+            <a:off x="731520" y="1234440"/>
+            <a:ext cx="5166360" cy="3931920"/>
+          </a:xfrm>
+          <a:prstGeom prst="roundRect">
+            <a:avLst/>
+          </a:prstGeom>
+          <a:solidFill>
+            <a:srgbClr val="FFF1F2"/>
+          </a:solidFill>
+          <a:ln>
+            <a:solidFill>
+              <a:srgbClr val="E11D48"/>
+            </a:solidFill>
+          </a:ln>
+        </p:spPr>
+        <p:style>
+          <a:lnRef idx="1">
+            <a:schemeClr val="accent1"/>
+          </a:lnRef>
+          <a:fillRef idx="3">
+            <a:schemeClr val="accent1"/>
+          </a:fillRef>
+          <a:effectRef idx="2">
+            <a:schemeClr val="accent1"/>
+          </a:effectRef>
+          <a:fontRef idx="minor">
+            <a:schemeClr val="lt1"/>
+          </a:fontRef>
+        </p:style>
+        <p:txBody>
+          <a:bodyPr rtlCol="0" anchor="ctr"/>
+          <a:lstStyle/>
+          <a:p>
+            <a:pPr algn="ctr"/>
+          </a:p>
+        </p:txBody>
+      </p:sp>
+      <p:sp>
+        <p:nvSpPr>
+          <p:cNvPr id="6" name="TextBox 5"/>
+          <p:cNvSpPr txBox="1"/>
+          <p:nvPr/>
+        </p:nvSpPr>
+        <p:spPr>
+          <a:xfrm>
+            <a:off x="868680" y="1325880"/>
+            <a:ext cx="4892040" cy="3657600"/>
           </a:xfrm>
           <a:prstGeom prst="rect">
             <a:avLst/>
           </a:prstGeom>
-        </p:spPr>
-      </p:pic>
+          <a:noFill/>
+        </p:spPr>
+        <p:txBody>
+          <a:bodyPr wrap="square">
+            <a:spAutoFit/>
+          </a:bodyPr>
+          <a:lstStyle/>
+          <a:p>
+            <a:pPr>
+              <a:defRPr sz="1400" b="1">
+                <a:solidFill>
+                  <a:srgbClr val="E11D48"/>
+                </a:solidFill>
+              </a:defRPr>
+            </a:pPr>
+            <a:r>
+              <a:t>❌ 1. NHÁNH BỊ LỖI (Nối Chuỗi SQL Thuần)</a:t>
+            </a:r>
+          </a:p>
+          <a:p>
+            <a:pPr>
+              <a:spcBef>
+                <a:spcPts val="800"/>
+              </a:spcBef>
+              <a:defRPr sz="1200">
+                <a:solidFill>
+                  <a:srgbClr val="1E293B"/>
+                </a:solidFill>
+              </a:defRPr>
+            </a:pPr>
+            <a:r>
+              <a:t>• Payload thử nghiệm: ' OR '1'='1' --</a:t>
+            </a:r>
+            <a:br/>
+            <a:r>
+              <a:t>• Câu lệnh thực thi:</a:t>
+            </a:r>
+            <a:br/>
+            <a:r>
+              <a:t>  SELECT * FROM Accounts WHERE Username = '' OR '1'='1' --'</a:t>
+            </a:r>
+            <a:br/>
+            <a:r>
+              <a:t>• Cơ chế thông dịch: Điều kiện WHERE luôn TRUE.</a:t>
+            </a:r>
+            <a:br/>
+            <a:r>
+              <a:t>• Hậu quả thực tế:</a:t>
+            </a:r>
+            <a:br/>
+            <a:r>
+              <a:t>  - Đăng nhập thành công mà KHÔNG CẦN mật khẩu.</a:t>
+            </a:r>
+            <a:br/>
+            <a:r>
+              <a:t>  - Rò rỉ toàn bộ 4 tài khoản trong CSDL (Admin, Specialist, Customer).</a:t>
+            </a:r>
+            <a:br/>
+            <a:r>
+              <a:t>  - Lộ mật khẩu gốc và số dư tài khoản ngân hàng.</a:t>
+            </a:r>
+          </a:p>
+        </p:txBody>
+      </p:sp>
+      <p:sp>
+        <p:nvSpPr>
+          <p:cNvPr id="7" name="Rounded Rectangle 6"/>
+          <p:cNvSpPr/>
+          <p:nvPr/>
+        </p:nvSpPr>
+        <p:spPr>
+          <a:xfrm>
+            <a:off x="6263640" y="1234440"/>
+            <a:ext cx="5166360" cy="3931920"/>
+          </a:xfrm>
+          <a:prstGeom prst="roundRect">
+            <a:avLst/>
+          </a:prstGeom>
+          <a:solidFill>
+            <a:srgbClr val="ECFDF5"/>
+          </a:solidFill>
+          <a:ln>
+            <a:solidFill>
+              <a:srgbClr val="10B981"/>
+            </a:solidFill>
+          </a:ln>
+        </p:spPr>
+        <p:style>
+          <a:lnRef idx="1">
+            <a:schemeClr val="accent1"/>
+          </a:lnRef>
+          <a:fillRef idx="3">
+            <a:schemeClr val="accent1"/>
+          </a:fillRef>
+          <a:effectRef idx="2">
+            <a:schemeClr val="accent1"/>
+          </a:effectRef>
+          <a:fontRef idx="minor">
+            <a:schemeClr val="lt1"/>
+          </a:fontRef>
+        </p:style>
+        <p:txBody>
+          <a:bodyPr rtlCol="0" anchor="ctr"/>
+          <a:lstStyle/>
+          <a:p>
+            <a:pPr algn="ctr"/>
+          </a:p>
+        </p:txBody>
+      </p:sp>
+      <p:sp>
+        <p:nvSpPr>
+          <p:cNvPr id="8" name="TextBox 7"/>
+          <p:cNvSpPr txBox="1"/>
+          <p:nvPr/>
+        </p:nvSpPr>
+        <p:spPr>
+          <a:xfrm>
+            <a:off x="6400800" y="1325880"/>
+            <a:ext cx="4892040" cy="3657600"/>
+          </a:xfrm>
+          <a:prstGeom prst="rect">
+            <a:avLst/>
+          </a:prstGeom>
+          <a:noFill/>
+        </p:spPr>
+        <p:txBody>
+          <a:bodyPr wrap="square">
+            <a:spAutoFit/>
+          </a:bodyPr>
+          <a:lstStyle/>
+          <a:p>
+            <a:pPr>
+              <a:defRPr sz="1400" b="1">
+                <a:solidFill>
+                  <a:srgbClr val="10B981"/>
+                </a:solidFill>
+              </a:defRPr>
+            </a:pPr>
+            <a:r>
+              <a:t>✅ 2. NHÁNH AN TOÀN (EF Core Parameterized)</a:t>
+            </a:r>
+          </a:p>
+          <a:p>
+            <a:pPr>
+              <a:spcBef>
+                <a:spcPts val="800"/>
+              </a:spcBef>
+              <a:defRPr sz="1200">
+                <a:solidFill>
+                  <a:srgbClr val="1E293B"/>
+                </a:solidFill>
+              </a:defRPr>
+            </a:pPr>
+            <a:r>
+              <a:t>• Cùng Payload thử nghiệm: ' OR '1'='1' --</a:t>
+            </a:r>
+            <a:br/>
+            <a:r>
+              <a:t>• Câu lệnh thực thi:</a:t>
+            </a:r>
+            <a:br/>
+            <a:r>
+              <a:t>  SELECT * FROM Accounts WHERE Username = @p0 AND Pass = @p1</a:t>
+            </a:r>
+            <a:br/>
+            <a:r>
+              <a:t>• Cơ chế thông dịch:</a:t>
+            </a:r>
+            <a:br/>
+            <a:r>
+              <a:t>  - CSDL biên dịch cây truy vấn (Execution Plan) TRƯỚC.</a:t>
+            </a:r>
+            <a:br/>
+            <a:r>
+              <a:t>  - Toàn bộ chuỗi payload được coi là String Literal thuần túy.</a:t>
+            </a:r>
+            <a:br/>
+            <a:r>
+              <a:t>• Kết quả phòng thủ:</a:t>
+            </a:r>
+            <a:br/>
+            <a:r>
+              <a:t>  - Hệ thống chặn đứng, trả về 0 bản ghi.</a:t>
+            </a:r>
+            <a:br/>
+            <a:r>
+              <a:t>  - Báo lỗi 'Sai tài khoản/mật khẩu', bảo vệ an toàn 100%.</a:t>
+            </a:r>
+          </a:p>
+        </p:txBody>
+      </p:sp>
+      <p:sp>
+        <p:nvSpPr>
+          <p:cNvPr id="9" name="Rounded Rectangle 8"/>
+          <p:cNvSpPr/>
+          <p:nvPr/>
+        </p:nvSpPr>
+        <p:spPr>
+          <a:xfrm>
+            <a:off x="731520" y="5303520"/>
+            <a:ext cx="10698480" cy="914400"/>
+          </a:xfrm>
+          <a:prstGeom prst="roundRect">
+            <a:avLst/>
+          </a:prstGeom>
+          <a:solidFill>
+            <a:srgbClr val="1E293B"/>
+          </a:solidFill>
+          <a:ln>
+            <a:solidFill>
+              <a:srgbClr val="2563EB"/>
+            </a:solidFill>
+          </a:ln>
+        </p:spPr>
+        <p:style>
+          <a:lnRef idx="1">
+            <a:schemeClr val="accent1"/>
+          </a:lnRef>
+          <a:fillRef idx="3">
+            <a:schemeClr val="accent1"/>
+          </a:fillRef>
+          <a:effectRef idx="2">
+            <a:schemeClr val="accent1"/>
+          </a:effectRef>
+          <a:fontRef idx="minor">
+            <a:schemeClr val="lt1"/>
+          </a:fontRef>
+        </p:style>
+        <p:txBody>
+          <a:bodyPr rtlCol="0" anchor="ctr"/>
+          <a:lstStyle/>
+          <a:p>
+            <a:pPr algn="ctr"/>
+          </a:p>
+        </p:txBody>
+      </p:sp>
+      <p:sp>
+        <p:nvSpPr>
+          <p:cNvPr id="10" name="TextBox 9"/>
+          <p:cNvSpPr txBox="1"/>
+          <p:nvPr/>
+        </p:nvSpPr>
+        <p:spPr>
+          <a:xfrm>
+            <a:off x="914400" y="5349240"/>
+            <a:ext cx="10332720" cy="822960"/>
+          </a:xfrm>
+          <a:prstGeom prst="rect">
+            <a:avLst/>
+          </a:prstGeom>
+          <a:noFill/>
+        </p:spPr>
+        <p:txBody>
+          <a:bodyPr wrap="square">
+            <a:spAutoFit/>
+          </a:bodyPr>
+          <a:lstStyle/>
+          <a:p>
+            <a:pPr>
+              <a:defRPr sz="1300" b="1">
+                <a:solidFill>
+                  <a:srgbClr val="38BDF8"/>
+                </a:solidFill>
+              </a:defRPr>
+            </a:pPr>
+            <a:r>
+              <a:t>💻 [LIVE DEMO TRÊN MÁY]: Chuyển sang Trình duyệt Web (http://localhost:5076) &amp; VS Code</a:t>
+            </a:r>
+          </a:p>
+          <a:p>
+            <a:pPr>
+              <a:spcBef>
+                <a:spcPts val="200"/>
+              </a:spcBef>
+              <a:defRPr sz="1150">
+                <a:solidFill>
+                  <a:srgbClr val="FFFFFF"/>
+                </a:solidFill>
+              </a:defRPr>
+            </a:pPr>
+            <a:r>
+              <a:t>Trình diễn trực tiếp 3 bước: Bấm nạp payload → Kiểm tra kết quả trả về → Đối chiếu Log SQL Server.</a:t>
+            </a:r>
+          </a:p>
+        </p:txBody>
+      </p:sp>
     </p:spTree>
   </p:cSld>
   <p:clrMapOvr>
@@ -4569,7 +4885,7 @@
         <p:spPr>
           <a:xfrm>
             <a:off x="0" y="0"/>
-            <a:ext cx="12191695" cy="1005840"/>
+            <a:ext cx="12191695" cy="1051560"/>
           </a:xfrm>
           <a:prstGeom prst="rect">
             <a:avLst/>
@@ -4612,7 +4928,7 @@
         <p:spPr>
           <a:xfrm>
             <a:off x="731520" y="109728"/>
-            <a:ext cx="10698480" cy="320040"/>
+            <a:ext cx="10698480" cy="274320"/>
           </a:xfrm>
           <a:prstGeom prst="rect">
             <a:avLst/>
@@ -4628,7 +4944,7 @@
             <a:pPr>
               <a:defRPr sz="1100" b="1">
                 <a:solidFill>
-                  <a:srgbClr val="DC2626"/>
+                  <a:srgbClr val="E11D48"/>
                 </a:solidFill>
               </a:defRPr>
             </a:pPr>
@@ -4645,7 +4961,7 @@
               </a:defRPr>
             </a:pPr>
             <a:r>
-              <a:t>5. Minh Chứng Thực Nghiệm 2: Tầng API (cURL) &amp; CSDL SQL Server 2025 (Không Dùng Web UI)</a:t>
+              <a:t>5. Đối Chứng Tầng Sâu: Tầng API (cURL) &amp; Microsoft SQL Server 2025</a:t>
             </a:r>
           </a:p>
         </p:txBody>
@@ -4658,8 +4974,8 @@
         </p:nvSpPr>
         <p:spPr>
           <a:xfrm>
-            <a:off x="731520" y="6537960"/>
-            <a:ext cx="10698480" cy="228600"/>
+            <a:off x="731520" y="6492240"/>
+            <a:ext cx="10698480" cy="274320"/>
           </a:xfrm>
           <a:prstGeom prst="rect">
             <a:avLst/>
@@ -4685,64 +5001,61 @@
           </a:p>
         </p:txBody>
       </p:sp>
-      <p:pic>
-        <p:nvPicPr>
-          <p:cNvPr id="5" name="Picture 4" descr="04_Terminal_cURL_Exploit.png"/>
-          <p:cNvPicPr>
-            <a:picLocks noChangeAspect="1"/>
-          </p:cNvPicPr>
+      <p:sp>
+        <p:nvSpPr>
+          <p:cNvPr id="5" name="Rounded Rectangle 4"/>
+          <p:cNvSpPr/>
           <p:nvPr/>
-        </p:nvPicPr>
-        <p:blipFill>
-          <a:blip r:embed="rId2"/>
-          <a:stretch>
-            <a:fillRect/>
-          </a:stretch>
-        </p:blipFill>
-        <p:spPr>
-          <a:xfrm>
-            <a:off x="731520" y="1188720"/>
-            <a:ext cx="5212080" cy="3950208"/>
-          </a:xfrm>
-          <a:prstGeom prst="rect">
+        </p:nvSpPr>
+        <p:spPr>
+          <a:xfrm>
+            <a:off x="731520" y="1234440"/>
+            <a:ext cx="5166360" cy="3931920"/>
+          </a:xfrm>
+          <a:prstGeom prst="roundRect">
             <a:avLst/>
           </a:prstGeom>
-        </p:spPr>
-      </p:pic>
-      <p:pic>
-        <p:nvPicPr>
-          <p:cNvPr id="6" name="Picture 5" descr="05_SQLServer_Direct_Query.png"/>
-          <p:cNvPicPr>
-            <a:picLocks noChangeAspect="1"/>
-          </p:cNvPicPr>
-          <p:nvPr/>
-        </p:nvPicPr>
-        <p:blipFill>
-          <a:blip r:embed="rId3"/>
-          <a:stretch>
-            <a:fillRect/>
-          </a:stretch>
-        </p:blipFill>
-        <p:spPr>
-          <a:xfrm>
-            <a:off x="6217920" y="1188720"/>
-            <a:ext cx="5212080" cy="3950208"/>
-          </a:xfrm>
-          <a:prstGeom prst="rect">
-            <a:avLst/>
-          </a:prstGeom>
-        </p:spPr>
-      </p:pic>
-      <p:sp>
-        <p:nvSpPr>
-          <p:cNvPr id="7" name="TextBox 6"/>
+          <a:solidFill>
+            <a:srgbClr val="F8FAFC"/>
+          </a:solidFill>
+          <a:ln>
+            <a:solidFill>
+              <a:srgbClr val="E2E8F0"/>
+            </a:solidFill>
+          </a:ln>
+        </p:spPr>
+        <p:style>
+          <a:lnRef idx="1">
+            <a:schemeClr val="accent1"/>
+          </a:lnRef>
+          <a:fillRef idx="3">
+            <a:schemeClr val="accent1"/>
+          </a:fillRef>
+          <a:effectRef idx="2">
+            <a:schemeClr val="accent1"/>
+          </a:effectRef>
+          <a:fontRef idx="minor">
+            <a:schemeClr val="lt1"/>
+          </a:fontRef>
+        </p:style>
+        <p:txBody>
+          <a:bodyPr rtlCol="0" anchor="ctr"/>
+          <a:lstStyle/>
+          <a:p>
+            <a:pPr algn="ctr"/>
+          </a:p>
+        </p:txBody>
+      </p:sp>
+      <p:sp>
+        <p:nvSpPr>
+          <p:cNvPr id="6" name="TextBox 5"/>
           <p:cNvSpPr txBox="1"/>
           <p:nvPr/>
         </p:nvSpPr>
         <p:spPr>
           <a:xfrm>
-            <a:off x="731520" y="5303520"/>
-            <a:ext cx="10698480" cy="1005840"/>
+            <a:off x="914400" y="1371600"/>
+            <a:ext cx="4800600" cy="3657600"/>
           </a:xfrm>
           <a:prstGeom prst="rect">
             <a:avLst/>
@@ -4756,18 +5069,313 @@
           <a:lstStyle/>
           <a:p>
             <a:pPr>
-              <a:defRPr sz="1200" b="1">
+              <a:defRPr sz="1400" b="1">
+                <a:solidFill>
+                  <a:srgbClr val="2563EB"/>
+                </a:solidFill>
+              </a:defRPr>
+            </a:pPr>
+            <a:r>
+              <a:t>Minh Chứng Tầng API / Dòng Lệnh (cURL)</a:t>
+            </a:r>
+          </a:p>
+          <a:p>
+            <a:pPr>
+              <a:spcBef>
+                <a:spcPts val="600"/>
+              </a:spcBef>
+              <a:defRPr sz="1000">
                 <a:solidFill>
                   <a:srgbClr val="1E293B"/>
                 </a:solidFill>
-              </a:defRPr>
-            </a:pPr>
-            <a:r>
-              <a:t>• Bên trái: Gọi HTTP POST bằng cURL từ dòng lệnh Terminal → Nhận JSON rò rỉ CSDL, chứng minh lỗi ở tầng Backend C#.</a:t>
-            </a:r>
-            <a:br/>
-            <a:r>
-              <a:t>• Bên phải: Thực thi câu lệnh trực tiếp trong CSDL SQL Server 2025 (OwaspDemoDB) chứng minh cơ chế bẻ gãy cú pháp.</a:t>
+                <a:latin typeface="Courier New"/>
+              </a:defRPr>
+            </a:pPr>
+            <a:r>
+              <a:t>$ curl -X POST http://localhost:5076/SqlInjection/LoginVulnerable \</a:t>
+            </a:r>
+            <a:br/>
+            <a:r>
+              <a:t>       -F "username=' OR '1'='1' --" -F "password=any"</a:t>
+            </a:r>
+            <a:br/>
+            <a:br/>
+            <a:r>
+              <a:t>Phản hồi JSON từ Server:</a:t>
+            </a:r>
+            <a:br/>
+            <a:r>
+              <a:t>{</a:t>
+            </a:r>
+            <a:br/>
+            <a:r>
+              <a:t>  "success": true,</a:t>
+            </a:r>
+            <a:br/>
+            <a:r>
+              <a:t>  "isExploited": true,</a:t>
+            </a:r>
+            <a:br/>
+            <a:r>
+              <a:t>  "count": 4,</a:t>
+            </a:r>
+            <a:br/>
+            <a:r>
+              <a:t>  "accounts": [ ... 4 tài khoản bị rò rỉ ... ]</a:t>
+            </a:r>
+            <a:br/>
+            <a:r>
+              <a:t>}</a:t>
+            </a:r>
+          </a:p>
+          <a:p>
+            <a:pPr>
+              <a:spcBef>
+                <a:spcPts val="800"/>
+              </a:spcBef>
+              <a:defRPr sz="1150">
+                <a:solidFill>
+                  <a:srgbClr val="64748B"/>
+                </a:solidFill>
+              </a:defRPr>
+            </a:pPr>
+            <a:r>
+              <a:t>📌 Ý nghĩa: Chứng minh lỗ hổng nằm hoàn toàn ở logic C# Backend, kẻ tấn công có thể dùng script tự động quét và khai thác mà không cần mở trình duyệt.</a:t>
+            </a:r>
+          </a:p>
+        </p:txBody>
+      </p:sp>
+      <p:sp>
+        <p:nvSpPr>
+          <p:cNvPr id="7" name="Rounded Rectangle 6"/>
+          <p:cNvSpPr/>
+          <p:nvPr/>
+        </p:nvSpPr>
+        <p:spPr>
+          <a:xfrm>
+            <a:off x="6263640" y="1234440"/>
+            <a:ext cx="5166360" cy="3931920"/>
+          </a:xfrm>
+          <a:prstGeom prst="roundRect">
+            <a:avLst/>
+          </a:prstGeom>
+          <a:solidFill>
+            <a:srgbClr val="F8FAFC"/>
+          </a:solidFill>
+          <a:ln>
+            <a:solidFill>
+              <a:srgbClr val="E2E8F0"/>
+            </a:solidFill>
+          </a:ln>
+        </p:spPr>
+        <p:style>
+          <a:lnRef idx="1">
+            <a:schemeClr val="accent1"/>
+          </a:lnRef>
+          <a:fillRef idx="3">
+            <a:schemeClr val="accent1"/>
+          </a:fillRef>
+          <a:effectRef idx="2">
+            <a:schemeClr val="accent1"/>
+          </a:effectRef>
+          <a:fontRef idx="minor">
+            <a:schemeClr val="lt1"/>
+          </a:fontRef>
+        </p:style>
+        <p:txBody>
+          <a:bodyPr rtlCol="0" anchor="ctr"/>
+          <a:lstStyle/>
+          <a:p>
+            <a:pPr algn="ctr"/>
+          </a:p>
+        </p:txBody>
+      </p:sp>
+      <p:sp>
+        <p:nvSpPr>
+          <p:cNvPr id="8" name="TextBox 7"/>
+          <p:cNvSpPr txBox="1"/>
+          <p:nvPr/>
+        </p:nvSpPr>
+        <p:spPr>
+          <a:xfrm>
+            <a:off x="6400800" y="1371600"/>
+            <a:ext cx="4800600" cy="3657600"/>
+          </a:xfrm>
+          <a:prstGeom prst="rect">
+            <a:avLst/>
+          </a:prstGeom>
+          <a:noFill/>
+        </p:spPr>
+        <p:txBody>
+          <a:bodyPr wrap="square">
+            <a:spAutoFit/>
+          </a:bodyPr>
+          <a:lstStyle/>
+          <a:p>
+            <a:pPr>
+              <a:defRPr sz="1400" b="1">
+                <a:solidFill>
+                  <a:srgbClr val="10B981"/>
+                </a:solidFill>
+              </a:defRPr>
+            </a:pPr>
+            <a:r>
+              <a:t>Minh Chứng Tầng CSDL (SQL Server 2025)</a:t>
+            </a:r>
+          </a:p>
+          <a:p>
+            <a:pPr>
+              <a:spcBef>
+                <a:spcPts val="600"/>
+              </a:spcBef>
+              <a:defRPr sz="1000">
+                <a:solidFill>
+                  <a:srgbClr val="1E293B"/>
+                </a:solidFill>
+                <a:latin typeface="Courier New"/>
+              </a:defRPr>
+            </a:pPr>
+            <a:r>
+              <a:t>-- Database: OwaspDemoDB | Bảng: dbo.Accounts</a:t>
+            </a:r>
+            <a:br/>
+            <a:r>
+              <a:t>-- 1. Câu lệnh dính lỗi:</a:t>
+            </a:r>
+            <a:br/>
+            <a:r>
+              <a:t>SELECT * FROM Accounts WHERE Username='' OR '1'='1' --'</a:t>
+            </a:r>
+            <a:br/>
+            <a:r>
+              <a:t>&gt;&gt; Kết quả: 4 rows returned (Bypass thành công)</a:t>
+            </a:r>
+            <a:br/>
+            <a:br/>
+            <a:r>
+              <a:t>-- 2. Câu lệnh tham số hóa chuẩn:</a:t>
+            </a:r>
+            <a:br/>
+            <a:r>
+              <a:t>EXEC sp_executesql N'SELECT * FROM Accounts WHERE...',</a:t>
+            </a:r>
+            <a:br/>
+            <a:r>
+              <a:t>     N'@p0 nvarchar(50)', @p0 = N''' OR ''1''=''1'' --'</a:t>
+            </a:r>
+            <a:br/>
+            <a:r>
+              <a:t>&gt;&gt; Kết quả: 0 rows returned (An toàn 100%)</a:t>
+            </a:r>
+          </a:p>
+          <a:p>
+            <a:pPr>
+              <a:spcBef>
+                <a:spcPts val="800"/>
+              </a:spcBef>
+              <a:defRPr sz="1150">
+                <a:solidFill>
+                  <a:srgbClr val="64748B"/>
+                </a:solidFill>
+              </a:defRPr>
+            </a:pPr>
+            <a:r>
+              <a:t>📌 Ý nghĩa: Đối chiếu trực tiếp trên máy chủ SQL Server 2025 chứng minh cơ chế phân tách rạch ròi giữa cú pháp lệnh và tham số giá trị.</a:t>
+            </a:r>
+          </a:p>
+        </p:txBody>
+      </p:sp>
+      <p:sp>
+        <p:nvSpPr>
+          <p:cNvPr id="9" name="Rounded Rectangle 8"/>
+          <p:cNvSpPr/>
+          <p:nvPr/>
+        </p:nvSpPr>
+        <p:spPr>
+          <a:xfrm>
+            <a:off x="731520" y="5303520"/>
+            <a:ext cx="10698480" cy="914400"/>
+          </a:xfrm>
+          <a:prstGeom prst="roundRect">
+            <a:avLst/>
+          </a:prstGeom>
+          <a:solidFill>
+            <a:srgbClr val="1E293B"/>
+          </a:solidFill>
+          <a:ln>
+            <a:solidFill>
+              <a:srgbClr val="10B981"/>
+            </a:solidFill>
+          </a:ln>
+        </p:spPr>
+        <p:style>
+          <a:lnRef idx="1">
+            <a:schemeClr val="accent1"/>
+          </a:lnRef>
+          <a:fillRef idx="3">
+            <a:schemeClr val="accent1"/>
+          </a:fillRef>
+          <a:effectRef idx="2">
+            <a:schemeClr val="accent1"/>
+          </a:effectRef>
+          <a:fontRef idx="minor">
+            <a:schemeClr val="lt1"/>
+          </a:fontRef>
+        </p:style>
+        <p:txBody>
+          <a:bodyPr rtlCol="0" anchor="ctr"/>
+          <a:lstStyle/>
+          <a:p>
+            <a:pPr algn="ctr"/>
+          </a:p>
+        </p:txBody>
+      </p:sp>
+      <p:sp>
+        <p:nvSpPr>
+          <p:cNvPr id="10" name="TextBox 9"/>
+          <p:cNvSpPr txBox="1"/>
+          <p:nvPr/>
+        </p:nvSpPr>
+        <p:spPr>
+          <a:xfrm>
+            <a:off x="914400" y="5349240"/>
+            <a:ext cx="10332720" cy="822960"/>
+          </a:xfrm>
+          <a:prstGeom prst="rect">
+            <a:avLst/>
+          </a:prstGeom>
+          <a:noFill/>
+        </p:spPr>
+        <p:txBody>
+          <a:bodyPr wrap="square">
+            <a:spAutoFit/>
+          </a:bodyPr>
+          <a:lstStyle/>
+          <a:p>
+            <a:pPr>
+              <a:defRPr sz="1300" b="1">
+                <a:solidFill>
+                  <a:srgbClr val="4ADE80"/>
+                </a:solidFill>
+              </a:defRPr>
+            </a:pPr>
+            <a:r>
+              <a:t>🗄️ [LIVE DEMO TRÊN MÁY]: Chuyển sang VS Code mở bảng dbo.Accounts &amp; file verify_sql_server.sql</a:t>
+            </a:r>
+          </a:p>
+          <a:p>
+            <a:pPr>
+              <a:spcBef>
+                <a:spcPts val="200"/>
+              </a:spcBef>
+              <a:defRPr sz="1150">
+                <a:solidFill>
+                  <a:srgbClr val="FFFFFF"/>
+                </a:solidFill>
+              </a:defRPr>
+            </a:pPr>
+            <a:r>
+              <a:t>Thao tác trực tiếp: Mở extension MSSQL trên VS Code, đối chiếu bảng dữ liệu gốc và chạy câu query đối chứng.</a:t>
             </a:r>
           </a:p>
         </p:txBody>
@@ -4799,7 +5407,7 @@
         <p:spPr>
           <a:xfrm>
             <a:off x="0" y="0"/>
-            <a:ext cx="12191695" cy="1005840"/>
+            <a:ext cx="12191695" cy="1051560"/>
           </a:xfrm>
           <a:prstGeom prst="rect">
             <a:avLst/>
@@ -4842,7 +5450,7 @@
         <p:spPr>
           <a:xfrm>
             <a:off x="731520" y="109728"/>
-            <a:ext cx="10698480" cy="320040"/>
+            <a:ext cx="10698480" cy="274320"/>
           </a:xfrm>
           <a:prstGeom prst="rect">
             <a:avLst/>
@@ -4858,7 +5466,7 @@
             <a:pPr>
               <a:defRPr sz="1100" b="1">
                 <a:solidFill>
-                  <a:srgbClr val="DC2626"/>
+                  <a:srgbClr val="E11D48"/>
                 </a:solidFill>
               </a:defRPr>
             </a:pPr>
@@ -4875,7 +5483,7 @@
               </a:defRPr>
             </a:pPr>
             <a:r>
-              <a:t>6. Minh Chứng Thực Nghiệm 3: Thao Tác Trực Tiếp Trên VS Code &amp; Extension SQL Server</a:t>
+              <a:t>6. Biện Pháp Phòng Thủ Chuẩn Trong ASP.NET Core MVC</a:t>
             </a:r>
           </a:p>
         </p:txBody>
@@ -4888,8 +5496,8 @@
         </p:nvSpPr>
         <p:spPr>
           <a:xfrm>
-            <a:off x="731520" y="6537960"/>
-            <a:ext cx="10698480" cy="228600"/>
+            <a:off x="731520" y="6492240"/>
+            <a:ext cx="10698480" cy="274320"/>
           </a:xfrm>
           <a:prstGeom prst="rect">
             <a:avLst/>
@@ -4915,30 +5523,51 @@
           </a:p>
         </p:txBody>
       </p:sp>
-      <p:pic>
-        <p:nvPicPr>
-          <p:cNvPr id="5" name="Picture 4" descr="my_vscode_sql_real.png"/>
-          <p:cNvPicPr>
-            <a:picLocks noChangeAspect="1"/>
-          </p:cNvPicPr>
+      <p:sp>
+        <p:nvSpPr>
+          <p:cNvPr id="5" name="Rounded Rectangle 4"/>
+          <p:cNvSpPr/>
           <p:nvPr/>
-        </p:nvPicPr>
-        <p:blipFill>
-          <a:blip r:embed="rId2"/>
-          <a:stretch>
-            <a:fillRect/>
-          </a:stretch>
-        </p:blipFill>
-        <p:spPr>
-          <a:xfrm>
-            <a:off x="731520" y="1371600"/>
-            <a:ext cx="10698480" cy="2402867"/>
-          </a:xfrm>
-          <a:prstGeom prst="rect">
+        </p:nvSpPr>
+        <p:spPr>
+          <a:xfrm>
+            <a:off x="731520" y="1234440"/>
+            <a:ext cx="5212080" cy="4937760"/>
+          </a:xfrm>
+          <a:prstGeom prst="roundRect">
             <a:avLst/>
           </a:prstGeom>
-        </p:spPr>
-      </p:pic>
+          <a:solidFill>
+            <a:srgbClr val="F8FAFC"/>
+          </a:solidFill>
+          <a:ln>
+            <a:solidFill>
+              <a:srgbClr val="10B981"/>
+            </a:solidFill>
+          </a:ln>
+        </p:spPr>
+        <p:style>
+          <a:lnRef idx="1">
+            <a:schemeClr val="accent1"/>
+          </a:lnRef>
+          <a:fillRef idx="3">
+            <a:schemeClr val="accent1"/>
+          </a:fillRef>
+          <a:effectRef idx="2">
+            <a:schemeClr val="accent1"/>
+          </a:effectRef>
+          <a:fontRef idx="minor">
+            <a:schemeClr val="lt1"/>
+          </a:fontRef>
+        </p:style>
+        <p:txBody>
+          <a:bodyPr rtlCol="0" anchor="ctr"/>
+          <a:lstStyle/>
+          <a:p>
+            <a:pPr algn="ctr"/>
+          </a:p>
+        </p:txBody>
+      </p:sp>
       <p:sp>
         <p:nvSpPr>
           <p:cNvPr id="6" name="TextBox 5"/>
@@ -4947,8 +5576,8 @@
         </p:nvSpPr>
         <p:spPr>
           <a:xfrm>
-            <a:off x="731520" y="4114800"/>
-            <a:ext cx="10698480" cy="2194560"/>
+            <a:off x="914400" y="1371600"/>
+            <a:ext cx="4846320" cy="4572000"/>
           </a:xfrm>
           <a:prstGeom prst="rect">
             <a:avLst/>
@@ -4962,14 +5591,14 @@
           <a:lstStyle/>
           <a:p>
             <a:pPr>
-              <a:defRPr sz="1500" b="1">
-                <a:solidFill>
-                  <a:srgbClr val="2563EB"/>
-                </a:solidFill>
-              </a:defRPr>
-            </a:pPr>
-            <a:r>
-              <a:t>Xác nhận môi trường thực nghiệm thực tế của sinh viên:</a:t>
+              <a:defRPr sz="1400" b="1">
+                <a:solidFill>
+                  <a:srgbClr val="10B981"/>
+                </a:solidFill>
+              </a:defRPr>
+            </a:pPr>
+            <a:r>
+              <a:t>Cách Viết Code Chuẩn Hóa Với EF Core</a:t>
             </a:r>
           </a:p>
           <a:p>
@@ -4977,26 +5606,185 @@
               <a:spcBef>
                 <a:spcPts val="800"/>
               </a:spcBef>
-              <a:defRPr sz="1300">
+              <a:defRPr sz="1000">
+                <a:solidFill>
+                  <a:srgbClr val="166534"/>
+                </a:solidFill>
+                <a:latin typeface="Courier New"/>
+              </a:defRPr>
+            </a:pPr>
+            <a:r>
+              <a:t>// Dùng LINQ Parameterized (KHUYÊN DÙNG):</a:t>
+            </a:r>
+            <a:br/>
+            <a:r>
+              <a:t>var account = _context.Accounts</a:t>
+            </a:r>
+            <a:br/>
+            <a:r>
+              <a:t>    .FirstOrDefault(a =&gt; a.Username == user </a:t>
+            </a:r>
+            <a:br/>
+            <a:r>
+              <a:t>                      &amp;&amp; a.Password == pass);</a:t>
+            </a:r>
+            <a:br/>
+            <a:br/>
+            <a:r>
+              <a:t>// Hoặc dùng FromSqlInterpolated nếu viết SQL thuần:</a:t>
+            </a:r>
+            <a:br/>
+            <a:r>
+              <a:t>var account = _context.Accounts</a:t>
+            </a:r>
+            <a:br/>
+            <a:r>
+              <a:t>    .FromSqlInterpolated($"SELECT * FROM Accounts WHERE Username={user} AND Password={pass}")</a:t>
+            </a:r>
+            <a:br/>
+            <a:r>
+              <a:t>    .FirstOrDefault();</a:t>
+            </a:r>
+          </a:p>
+          <a:p>
+            <a:pPr>
+              <a:spcBef>
+                <a:spcPts val="1200"/>
+              </a:spcBef>
+              <a:defRPr sz="1200" b="1">
                 <a:solidFill>
                   <a:srgbClr val="1E293B"/>
                 </a:solidFill>
               </a:defRPr>
             </a:pPr>
             <a:r>
-              <a:t>• Công cụ: Visual Studio Code kết hợp Extension Microsoft MSSQL.</a:t>
-            </a:r>
-            <a:br/>
-            <a:r>
-              <a:t>• Máy chủ CSDL: Microsoft SQL Server 2025 Developer chạy trực tiếp trên Localhost (Port 1433).</a:t>
-            </a:r>
-            <a:br/>
-            <a:r>
-              <a:t>• Cơ sở dữ liệu: OwaspDemoDB, bảng Accounts chứa dữ liệu thực nghiệm (Admin, Chuyên gia, Khách hàng).</a:t>
-            </a:r>
-            <a:br/>
-            <a:r>
-              <a:t>• Kết quả: Bảng dữ liệu được truy vấn và hiển thị trực tiếp trong trình soạn thảo, hoàn toàn đồng bộ với kết quả trích xuất trên ứng dụng web.</a:t>
+              <a:t>Tại sao cách này an toàn tuyệt đối?</a:t>
+            </a:r>
+          </a:p>
+          <a:p>
+            <a:pPr>
+              <a:spcBef>
+                <a:spcPts val="400"/>
+              </a:spcBef>
+              <a:defRPr sz="1150">
+                <a:solidFill>
+                  <a:srgbClr val="64748B"/>
+                </a:solidFill>
+              </a:defRPr>
+            </a:pPr>
+            <a:r>
+              <a:t>SQL Server biên dịch cấu trúc lệnh TRƯỚC khi gán dữ liệu. Biến @p0 nhận toàn bộ payload như một chuỗi chữ bình thường, vô hiệu hóa hoàn toàn ý đồ chèn lệnh.</a:t>
+            </a:r>
+          </a:p>
+        </p:txBody>
+      </p:sp>
+      <p:sp>
+        <p:nvSpPr>
+          <p:cNvPr id="7" name="TextBox 6"/>
+          <p:cNvSpPr txBox="1"/>
+          <p:nvPr/>
+        </p:nvSpPr>
+        <p:spPr>
+          <a:xfrm>
+            <a:off x="6309360" y="1234440"/>
+            <a:ext cx="5120640" cy="4937760"/>
+          </a:xfrm>
+          <a:prstGeom prst="rect">
+            <a:avLst/>
+          </a:prstGeom>
+          <a:noFill/>
+        </p:spPr>
+        <p:txBody>
+          <a:bodyPr wrap="square">
+            <a:spAutoFit/>
+          </a:bodyPr>
+          <a:lstStyle/>
+          <a:p>
+            <a:pPr>
+              <a:defRPr sz="1500" b="1">
+                <a:solidFill>
+                  <a:srgbClr val="2563EB"/>
+                </a:solidFill>
+              </a:defRPr>
+            </a:pPr>
+            <a:r>
+              <a:t>Bộ Quy Tắc Phòng Thủ Toàn Diện (Defense in Depth)</a:t>
+            </a:r>
+          </a:p>
+          <a:p>
+            <a:pPr>
+              <a:spcBef>
+                <a:spcPts val="1000"/>
+              </a:spcBef>
+              <a:defRPr sz="1200">
+                <a:solidFill>
+                  <a:srgbClr val="1E293B"/>
+                </a:solidFill>
+              </a:defRPr>
+            </a:pPr>
+            <a:r>
+              <a:t>1. Luôn sử dụng Parameterized Query / ORM:</a:t>
+            </a:r>
+            <a:br/>
+            <a:r>
+              <a:t>Tuyệt đối không ghép chuỗi SQL thủ công dưới bất kỳ hình thức nào.</a:t>
+            </a:r>
+          </a:p>
+          <a:p>
+            <a:pPr>
+              <a:spcBef>
+                <a:spcPts val="800"/>
+              </a:spcBef>
+              <a:defRPr sz="1200">
+                <a:solidFill>
+                  <a:srgbClr val="1E293B"/>
+                </a:solidFill>
+              </a:defRPr>
+            </a:pPr>
+            <a:r>
+              <a:t>2. Nguyên tắc đặc quyền tối thiểu (Least Privilege):</a:t>
+            </a:r>
+            <a:br/>
+            <a:r>
+              <a:t>Tài khoản kết nối CSDL của ứng dụng chỉ có quyền SELECT/INSERT/UPDATE trên các bảng cần thiết, không bao giờ dùng tài khoản 'sa' hay quyền DDL (DROP, ALTER).</a:t>
+            </a:r>
+          </a:p>
+          <a:p>
+            <a:pPr>
+              <a:spcBef>
+                <a:spcPts val="800"/>
+              </a:spcBef>
+              <a:defRPr sz="1200">
+                <a:solidFill>
+                  <a:srgbClr val="1E293B"/>
+                </a:solidFill>
+              </a:defRPr>
+            </a:pPr>
+            <a:r>
+              <a:t>3. Xác thực dữ liệu đầu vào (Input Validation):</a:t>
+            </a:r>
+            <a:br/>
+            <a:r>
+              <a:t>Sử dụng Data Annotations ([RegularExpression], [StringLength]) kiểm tra chặt chẽ khuôn dạng dữ liệu.</a:t>
+            </a:r>
+          </a:p>
+          <a:p>
+            <a:pPr>
+              <a:spcBef>
+                <a:spcPts val="800"/>
+              </a:spcBef>
+              <a:defRPr sz="1200">
+                <a:solidFill>
+                  <a:srgbClr val="1E293B"/>
+                </a:solidFill>
+              </a:defRPr>
+            </a:pPr>
+            <a:r>
+              <a:t>4. Mã hóa mật khẩu một chiều (Password Hashing):</a:t>
+            </a:r>
+            <a:br/>
+            <a:r>
+              <a:t>Sử dụng ASP.NET Core Identity (PBKDF2/BCrypt) để nếu CSDL có bị lộ, mật khẩu vẫn được bảo vệ an toàn.</a:t>
             </a:r>
           </a:p>
         </p:txBody>
@@ -5028,7 +5816,7 @@
         <p:spPr>
           <a:xfrm>
             <a:off x="0" y="0"/>
-            <a:ext cx="12191695" cy="1005840"/>
+            <a:ext cx="12191695" cy="1051560"/>
           </a:xfrm>
           <a:prstGeom prst="rect">
             <a:avLst/>
@@ -5071,7 +5859,7 @@
         <p:spPr>
           <a:xfrm>
             <a:off x="731520" y="109728"/>
-            <a:ext cx="10698480" cy="320040"/>
+            <a:ext cx="10698480" cy="274320"/>
           </a:xfrm>
           <a:prstGeom prst="rect">
             <a:avLst/>
@@ -5087,7 +5875,7 @@
             <a:pPr>
               <a:defRPr sz="1100" b="1">
                 <a:solidFill>
-                  <a:srgbClr val="DC2626"/>
+                  <a:srgbClr val="E11D48"/>
                 </a:solidFill>
               </a:defRPr>
             </a:pPr>
@@ -5104,7 +5892,7 @@
               </a:defRPr>
             </a:pPr>
             <a:r>
-              <a:t>7. Biện Pháp Phòng Thủ Chuẩn Trong ASP.NET Core MVC</a:t>
+              <a:t>7. Tổng Kết &amp; Bài Học Rút Ra Cho Dự Án Website Tư Vấn Trực Tuyến</a:t>
             </a:r>
           </a:p>
         </p:txBody>
@@ -5117,8 +5905,8 @@
         </p:nvSpPr>
         <p:spPr>
           <a:xfrm>
-            <a:off x="731520" y="6537960"/>
-            <a:ext cx="10698480" cy="228600"/>
+            <a:off x="731520" y="6492240"/>
+            <a:ext cx="10698480" cy="274320"/>
           </a:xfrm>
           <a:prstGeom prst="rect">
             <a:avLst/>
@@ -5146,59 +5934,14 @@
       </p:sp>
       <p:sp>
         <p:nvSpPr>
-          <p:cNvPr id="5" name="Rounded Rectangle 4"/>
-          <p:cNvSpPr/>
-          <p:nvPr/>
-        </p:nvSpPr>
-        <p:spPr>
-          <a:xfrm>
-            <a:off x="731520" y="1188720"/>
-            <a:ext cx="5212080" cy="4937760"/>
-          </a:xfrm>
-          <a:prstGeom prst="roundRect">
-            <a:avLst/>
-          </a:prstGeom>
-          <a:solidFill>
-            <a:srgbClr val="F8FAFC"/>
-          </a:solidFill>
-          <a:ln>
-            <a:solidFill>
-              <a:srgbClr val="16A34A"/>
-            </a:solidFill>
-          </a:ln>
-        </p:spPr>
-        <p:style>
-          <a:lnRef idx="1">
-            <a:schemeClr val="accent1"/>
-          </a:lnRef>
-          <a:fillRef idx="3">
-            <a:schemeClr val="accent1"/>
-          </a:fillRef>
-          <a:effectRef idx="2">
-            <a:schemeClr val="accent1"/>
-          </a:effectRef>
-          <a:fontRef idx="minor">
-            <a:schemeClr val="lt1"/>
-          </a:fontRef>
-        </p:style>
-        <p:txBody>
-          <a:bodyPr rtlCol="0" anchor="ctr"/>
-          <a:lstStyle/>
-          <a:p>
-            <a:pPr algn="ctr"/>
-          </a:p>
-        </p:txBody>
-      </p:sp>
-      <p:sp>
-        <p:nvSpPr>
-          <p:cNvPr id="6" name="TextBox 5"/>
+          <p:cNvPr id="5" name="TextBox 4"/>
           <p:cNvSpPr txBox="1"/>
           <p:nvPr/>
         </p:nvSpPr>
         <p:spPr>
           <a:xfrm>
-            <a:off x="914400" y="1280160"/>
-            <a:ext cx="4846320" cy="4663440"/>
+            <a:off x="914400" y="1371600"/>
+            <a:ext cx="10362895" cy="4572000"/>
           </a:xfrm>
           <a:prstGeom prst="rect">
             <a:avLst/>
@@ -5212,59 +5955,14 @@
           <a:lstStyle/>
           <a:p>
             <a:pPr>
-              <a:defRPr sz="1400" b="1">
-                <a:solidFill>
-                  <a:srgbClr val="16A34A"/>
-                </a:solidFill>
-              </a:defRPr>
-            </a:pPr>
-            <a:r>
-              <a:t>Cách Viết Code Chuẩn Hóa Với EF Core</a:t>
-            </a:r>
-          </a:p>
-          <a:p>
-            <a:pPr>
-              <a:spcBef>
-                <a:spcPts val="800"/>
-              </a:spcBef>
-              <a:defRPr sz="1000">
-                <a:solidFill>
-                  <a:srgbClr val="166534"/>
-                </a:solidFill>
-                <a:latin typeface="Courier New"/>
-              </a:defRPr>
-            </a:pPr>
-            <a:r>
-              <a:t>// Dùng LINQ Parameterized (KHUYÊN DÙNG):</a:t>
-            </a:r>
-            <a:br/>
-            <a:r>
-              <a:t>var account = _context.Accounts</a:t>
-            </a:r>
-            <a:br/>
-            <a:r>
-              <a:t>    .FirstOrDefault(a =&gt; a.Username == user </a:t>
-            </a:r>
-            <a:br/>
-            <a:r>
-              <a:t>                      &amp;&amp; a.Password == pass);</a:t>
-            </a:r>
-            <a:br/>
-            <a:br/>
-            <a:r>
-              <a:t>// Hoặc dùng FromSqlInterpolated nếu viết SQL thuần:</a:t>
-            </a:r>
-            <a:br/>
-            <a:r>
-              <a:t>var account = _context.Accounts</a:t>
-            </a:r>
-            <a:br/>
-            <a:r>
-              <a:t>    .FromSqlInterpolated($"SELECT * FROM Accounts WHERE Username={user} AND Password={pass}")</a:t>
-            </a:r>
-            <a:br/>
-            <a:r>
-              <a:t>    .FirstOrDefault();</a:t>
+              <a:defRPr sz="1700" b="1">
+                <a:solidFill>
+                  <a:srgbClr val="E11D48"/>
+                </a:solidFill>
+              </a:defRPr>
+            </a:pPr>
+            <a:r>
+              <a:t>BÀI HỌC VÀ CAM KẾT CHUẨN AN TOÀN CHO ĐỀ TÀI BTL (WNC.G01):</a:t>
             </a:r>
           </a:p>
           <a:p>
@@ -5272,64 +5970,14 @@
               <a:spcBef>
                 <a:spcPts val="1200"/>
               </a:spcBef>
-              <a:defRPr sz="1200" b="1">
+              <a:defRPr sz="1350">
                 <a:solidFill>
                   <a:srgbClr val="1E293B"/>
                 </a:solidFill>
               </a:defRPr>
             </a:pPr>
             <a:r>
-              <a:t>Tại sao cách này an toàn tuyệt đối?</a:t>
-            </a:r>
-          </a:p>
-          <a:p>
-            <a:pPr>
-              <a:spcBef>
-                <a:spcPts val="400"/>
-              </a:spcBef>
-              <a:defRPr sz="1100">
-                <a:solidFill>
-                  <a:srgbClr val="64748B"/>
-                </a:solidFill>
-              </a:defRPr>
-            </a:pPr>
-            <a:r>
-              <a:t>SQL Server biên dịch cấu trúc lệnh TRƯỚC khi gán dữ liệu. Biến @p0 nhận toàn bộ payload như một chuỗi chữ bình thường, vô hiệu hóa hoàn toàn ý đồ chèn lệnh.</a:t>
-            </a:r>
-          </a:p>
-        </p:txBody>
-      </p:sp>
-      <p:sp>
-        <p:nvSpPr>
-          <p:cNvPr id="7" name="TextBox 6"/>
-          <p:cNvSpPr txBox="1"/>
-          <p:nvPr/>
-        </p:nvSpPr>
-        <p:spPr>
-          <a:xfrm>
-            <a:off x="6309360" y="1188720"/>
-            <a:ext cx="5120640" cy="4937760"/>
-          </a:xfrm>
-          <a:prstGeom prst="rect">
-            <a:avLst/>
-          </a:prstGeom>
-          <a:noFill/>
-        </p:spPr>
-        <p:txBody>
-          <a:bodyPr wrap="square">
-            <a:spAutoFit/>
-          </a:bodyPr>
-          <a:lstStyle/>
-          <a:p>
-            <a:pPr>
-              <a:defRPr sz="1500" b="1">
-                <a:solidFill>
-                  <a:srgbClr val="2563EB"/>
-                </a:solidFill>
-              </a:defRPr>
-            </a:pPr>
-            <a:r>
-              <a:t>Bộ Quy Tắc Phòng Thủ Toàn Diện (Defense in Depth)</a:t>
+              <a:t>1. Nhận thức an toàn: SQL Injection là lỗ hổng nghiêm trọng ở mức độ CRITICAL (9.8/10 theo CVSS v3.1). Lập trình viên phải luôn coi mọi dữ liệu đầu vào từ người dùng là 'không an toàn'.</a:t>
             </a:r>
           </a:p>
           <a:p>
@@ -5337,253 +5985,14 @@
               <a:spcBef>
                 <a:spcPts val="1000"/>
               </a:spcBef>
-              <a:defRPr sz="1200">
+              <a:defRPr sz="1350">
                 <a:solidFill>
                   <a:srgbClr val="1E293B"/>
                 </a:solidFill>
               </a:defRPr>
             </a:pPr>
             <a:r>
-              <a:t>1. Luôn sử dụng Parameterized Query / ORM:</a:t>
-            </a:r>
-            <a:br/>
-            <a:r>
-              <a:t>Tuyệt đối không ghép chuỗi SQL thủ công dưới bất kỳ hình thức nào.</a:t>
-            </a:r>
-          </a:p>
-          <a:p>
-            <a:pPr>
-              <a:spcBef>
-                <a:spcPts val="800"/>
-              </a:spcBef>
-              <a:defRPr sz="1200">
-                <a:solidFill>
-                  <a:srgbClr val="1E293B"/>
-                </a:solidFill>
-              </a:defRPr>
-            </a:pPr>
-            <a:r>
-              <a:t>2. Nguyên tắc đặc quyền tối thiểu (Least Privilege):</a:t>
-            </a:r>
-            <a:br/>
-            <a:r>
-              <a:t>Tài khoản kết nối CSDL của ứng dụng chỉ có quyền SELECT/INSERT/UPDATE trên các bảng cần thiết, không bao giờ dùng tài khoản 'sa' hay quyền DDL (DROP, ALTER).</a:t>
-            </a:r>
-          </a:p>
-          <a:p>
-            <a:pPr>
-              <a:spcBef>
-                <a:spcPts val="800"/>
-              </a:spcBef>
-              <a:defRPr sz="1200">
-                <a:solidFill>
-                  <a:srgbClr val="1E293B"/>
-                </a:solidFill>
-              </a:defRPr>
-            </a:pPr>
-            <a:r>
-              <a:t>3. Xác thực dữ liệu đầu vào (Input Validation):</a:t>
-            </a:r>
-            <a:br/>
-            <a:r>
-              <a:t>Sử dụng Data Annotations ([RegularExpression], [StringLength]) kiểm tra chặt chẽ khuôn dạng dữ liệu.</a:t>
-            </a:r>
-          </a:p>
-          <a:p>
-            <a:pPr>
-              <a:spcBef>
-                <a:spcPts val="800"/>
-              </a:spcBef>
-              <a:defRPr sz="1200">
-                <a:solidFill>
-                  <a:srgbClr val="1E293B"/>
-                </a:solidFill>
-              </a:defRPr>
-            </a:pPr>
-            <a:r>
-              <a:t>4. Mã hóa mật khẩu một chiều (Password Hashing):</a:t>
-            </a:r>
-            <a:br/>
-            <a:r>
-              <a:t>Sử dụng ASP.NET Core Identity (PBKDF2/BCrypt) để nếu CSDL có bị lộ, mật khẩu vẫn được bảo vệ an toàn.</a:t>
-            </a:r>
-          </a:p>
-        </p:txBody>
-      </p:sp>
-    </p:spTree>
-  </p:cSld>
-  <p:clrMapOvr>
-    <a:masterClrMapping/>
-  </p:clrMapOvr>
-</p:sld>
-</file>
-
-<file path=ppt/slides/slide9.xml><?xml version="1.0" encoding="utf-8"?>
-<p:sld xmlns:a="http://schemas.openxmlformats.org/drawingml/2006/main" xmlns:p="http://schemas.openxmlformats.org/presentationml/2006/main" xmlns:r="http://schemas.openxmlformats.org/officeDocument/2006/relationships">
-  <p:cSld>
-    <p:spTree>
-      <p:nvGrpSpPr>
-        <p:cNvPr id="1" name=""/>
-        <p:cNvGrpSpPr/>
-        <p:nvPr/>
-      </p:nvGrpSpPr>
-      <p:grpSpPr/>
-      <p:sp>
-        <p:nvSpPr>
-          <p:cNvPr id="2" name="Rectangle 1"/>
-          <p:cNvSpPr/>
-          <p:nvPr/>
-        </p:nvSpPr>
-        <p:spPr>
-          <a:xfrm>
-            <a:off x="0" y="0"/>
-            <a:ext cx="12191695" cy="1005840"/>
-          </a:xfrm>
-          <a:prstGeom prst="rect">
-            <a:avLst/>
-          </a:prstGeom>
-          <a:solidFill>
-            <a:srgbClr val="0F172A"/>
-          </a:solidFill>
-          <a:ln>
-            <a:noFill/>
-          </a:ln>
-        </p:spPr>
-        <p:style>
-          <a:lnRef idx="1">
-            <a:schemeClr val="accent1"/>
-          </a:lnRef>
-          <a:fillRef idx="3">
-            <a:schemeClr val="accent1"/>
-          </a:fillRef>
-          <a:effectRef idx="2">
-            <a:schemeClr val="accent1"/>
-          </a:effectRef>
-          <a:fontRef idx="minor">
-            <a:schemeClr val="lt1"/>
-          </a:fontRef>
-        </p:style>
-        <p:txBody>
-          <a:bodyPr rtlCol="0" anchor="ctr"/>
-          <a:lstStyle/>
-          <a:p>
-            <a:pPr algn="ctr"/>
-          </a:p>
-        </p:txBody>
-      </p:sp>
-      <p:sp>
-        <p:nvSpPr>
-          <p:cNvPr id="3" name="TextBox 2"/>
-          <p:cNvSpPr txBox="1"/>
-          <p:nvPr/>
-        </p:nvSpPr>
-        <p:spPr>
-          <a:xfrm>
-            <a:off x="731520" y="109728"/>
-            <a:ext cx="10698480" cy="320040"/>
-          </a:xfrm>
-          <a:prstGeom prst="rect">
-            <a:avLst/>
-          </a:prstGeom>
-          <a:noFill/>
-        </p:spPr>
-        <p:txBody>
-          <a:bodyPr wrap="square">
-            <a:spAutoFit/>
-          </a:bodyPr>
-          <a:lstStyle/>
-          <a:p>
-            <a:pPr>
-              <a:defRPr sz="1100" b="1">
-                <a:solidFill>
-                  <a:srgbClr val="DC2626"/>
-                </a:solidFill>
-              </a:defRPr>
-            </a:pPr>
-            <a:r>
-              <a:t>OWASP TOP 10 - A03:2021 (INJECTION)</a:t>
-            </a:r>
-          </a:p>
-          <a:p>
-            <a:pPr>
-              <a:defRPr sz="1900" b="1">
-                <a:solidFill>
-                  <a:srgbClr val="FFFFFF"/>
-                </a:solidFill>
-              </a:defRPr>
-            </a:pPr>
-            <a:r>
-              <a:t>8. Tổng Kết &amp; Bài Học Rút Ra Cho Dự Án Website Tư Vấn Trực Tuyến</a:t>
-            </a:r>
-          </a:p>
-        </p:txBody>
-      </p:sp>
-      <p:sp>
-        <p:nvSpPr>
-          <p:cNvPr id="4" name="TextBox 3"/>
-          <p:cNvSpPr txBox="1"/>
-          <p:nvPr/>
-        </p:nvSpPr>
-        <p:spPr>
-          <a:xfrm>
-            <a:off x="731520" y="6537960"/>
-            <a:ext cx="10698480" cy="228600"/>
-          </a:xfrm>
-          <a:prstGeom prst="rect">
-            <a:avLst/>
-          </a:prstGeom>
-          <a:noFill/>
-        </p:spPr>
-        <p:txBody>
-          <a:bodyPr wrap="none">
-            <a:spAutoFit/>
-          </a:bodyPr>
-          <a:lstStyle/>
-          <a:p>
-            <a:pPr>
-              <a:defRPr sz="950">
-                <a:solidFill>
-                  <a:srgbClr val="64748B"/>
-                </a:solidFill>
-              </a:defRPr>
-            </a:pPr>
-            <a:r>
-              <a:t>Nhóm WNC.G01 (HOU) • Môn Lập Trình Web Nâng Cao • ThS. Lê Hữu Dũng</a:t>
-            </a:r>
-          </a:p>
-        </p:txBody>
-      </p:sp>
-      <p:sp>
-        <p:nvSpPr>
-          <p:cNvPr id="5" name="TextBox 4"/>
-          <p:cNvSpPr txBox="1"/>
-          <p:nvPr/>
-        </p:nvSpPr>
-        <p:spPr>
-          <a:xfrm>
-            <a:off x="914400" y="1463040"/>
-            <a:ext cx="10362895" cy="4389120"/>
-          </a:xfrm>
-          <a:prstGeom prst="rect">
-            <a:avLst/>
-          </a:prstGeom>
-          <a:noFill/>
-        </p:spPr>
-        <p:txBody>
-          <a:bodyPr wrap="square">
-            <a:spAutoFit/>
-          </a:bodyPr>
-          <a:lstStyle/>
-          <a:p>
-            <a:pPr>
-              <a:defRPr sz="1800" b="1">
-                <a:solidFill>
-                  <a:srgbClr val="DC2626"/>
-                </a:solidFill>
-              </a:defRPr>
-            </a:pPr>
-            <a:r>
-              <a:t>KẾT LUẬN THỰC NGHIỆM:</a:t>
+              <a:t>2. Phòng thủ triệt để: Trong đồ án Website cung cấp dịch vụ tư vấn trực tuyến, nhóm cam kết áp dụng 100% Entity Framework Core Code-First với Parameterized LINQ cho toàn bộ các thao tác đặt lịch, quản lý chuyên gia và đánh giá chất lượng.</a:t>
             </a:r>
           </a:p>
           <a:p>
@@ -5591,32 +6000,22 @@
               <a:spcBef>
                 <a:spcPts val="1000"/>
               </a:spcBef>
-              <a:defRPr sz="1400">
+              <a:defRPr sz="1350">
                 <a:solidFill>
                   <a:srgbClr val="1E293B"/>
                 </a:solidFill>
               </a:defRPr>
             </a:pPr>
             <a:r>
-              <a:t>1. Minh chứng thực nghiệm đã chứng minh rõ ràng: SQL Injection có thể bị khai thác qua cả Giao diện Web (Form) lẫn qua Lệnh gọi API trực tiếp (cURL/Postman). Độ nguy hiểm là mức CRITICAL (9.8/10 theo CVSS v3.1).</a:t>
-            </a:r>
-            <a:br/>
-            <a:br/>
-            <a:r>
-              <a:t>2. Lỗ hổng hoàn toàn có thể được loại trừ 100% bằng cách tuân thủ đúng chuẩn công nghệ của môn học: Sử dụng Entity Framework Core với Parameterized Query thay vì ghép chuỗi thủ công.</a:t>
-            </a:r>
-            <a:br/>
-            <a:br/>
-            <a:r>
-              <a:t>3. Trong dự án BTL (Website Tư vấn trực tuyến WNC.G01), nhóm cam kết áp dụng triệt để: EF Core DbContext, Data Annotations Validation và ASP.NET Core Identity để bảo vệ an toàn tuyệt đối cho người dùng.</a:t>
+              <a:t>3. Bảo mật đa tầng (Security View - Buổi 8): Tích hợp chặt chẽ ASP.NET Core Identity để băm mật khẩu, AntiForgeryToken chống CSRF trên toàn bộ form và kiểm soát phân quyền 3 Role (Customer, Specialist, Admin).</a:t>
             </a:r>
           </a:p>
           <a:p>
             <a:pPr>
               <a:spcBef>
-                <a:spcPts val="2400"/>
+                <a:spcPts val="2200"/>
               </a:spcBef>
-              <a:defRPr sz="1600" b="1">
+              <a:defRPr sz="1550" b="1">
                 <a:solidFill>
                   <a:srgbClr val="2563EB"/>
                 </a:solidFill>

</xml_diff>

<commit_message>
feat: redesign entire presentation with modern Gamma/Canva light theme optimized for classroom projectors
</commit_message>
<xml_diff>
--- a/Slide_OWASP_SQL_Injection.pptx
+++ b/Slide_OWASP_SQL_Injection.pptx
@@ -3104,13 +3104,13 @@
         <p:spPr>
           <a:xfrm>
             <a:off x="0" y="0"/>
-            <a:ext cx="12191695" cy="6858000"/>
+            <a:ext cx="12191695" cy="109728"/>
           </a:xfrm>
           <a:prstGeom prst="rect">
             <a:avLst/>
           </a:prstGeom>
           <a:solidFill>
-            <a:srgbClr val="0F172A"/>
+            <a:srgbClr val="1D4ED8"/>
           </a:solidFill>
           <a:ln>
             <a:noFill/>
@@ -3140,14 +3140,68 @@
       </p:sp>
       <p:sp>
         <p:nvSpPr>
-          <p:cNvPr id="3" name="TextBox 2"/>
+          <p:cNvPr id="3" name="Rounded Rectangle 2"/>
+          <p:cNvSpPr/>
+          <p:nvPr/>
+        </p:nvSpPr>
+        <p:spPr>
+          <a:xfrm>
+            <a:off x="914400" y="731520"/>
+            <a:ext cx="5303520" cy="384048"/>
+          </a:xfrm>
+          <a:prstGeom prst="roundRect">
+            <a:avLst/>
+          </a:prstGeom>
+          <a:solidFill>
+            <a:srgbClr val="EFF6FF"/>
+          </a:solidFill>
+          <a:ln>
+            <a:solidFill>
+              <a:srgbClr val="BFDBFE"/>
+            </a:solidFill>
+          </a:ln>
+        </p:spPr>
+        <p:style>
+          <a:lnRef idx="1">
+            <a:schemeClr val="accent1"/>
+          </a:lnRef>
+          <a:fillRef idx="3">
+            <a:schemeClr val="accent1"/>
+          </a:fillRef>
+          <a:effectRef idx="2">
+            <a:schemeClr val="accent1"/>
+          </a:effectRef>
+          <a:fontRef idx="minor">
+            <a:schemeClr val="lt1"/>
+          </a:fontRef>
+        </p:style>
+        <p:txBody>
+          <a:bodyPr rtlCol="0" anchor="ctr"/>
+          <a:lstStyle/>
+          <a:p>
+            <a:pPr algn="ctr">
+              <a:defRPr sz="1050" b="1">
+                <a:solidFill>
+                  <a:srgbClr val="1D4ED8"/>
+                </a:solidFill>
+              </a:defRPr>
+            </a:pPr>
+            <a:r>
+              <a:t>TRƯỜNG ĐẠI HỌC MỞ HÀ NỘI — KHOA CÔNG NGHỆ THÔNG TIN</a:t>
+            </a:r>
+          </a:p>
+        </p:txBody>
+      </p:sp>
+      <p:sp>
+        <p:nvSpPr>
+          <p:cNvPr id="4" name="TextBox 3"/>
           <p:cNvSpPr txBox="1"/>
           <p:nvPr/>
         </p:nvSpPr>
         <p:spPr>
           <a:xfrm>
-            <a:off x="914400" y="1005840"/>
-            <a:ext cx="10362895" cy="4754880"/>
+            <a:off x="914400" y="1234440"/>
+            <a:ext cx="10362895" cy="2926080"/>
           </a:xfrm>
           <a:prstGeom prst="rect">
             <a:avLst/>
@@ -3161,29 +3215,14 @@
           <a:lstStyle/>
           <a:p>
             <a:pPr>
-              <a:defRPr sz="1400" b="1">
-                <a:solidFill>
-                  <a:srgbClr val="94A3B8"/>
-                </a:solidFill>
-              </a:defRPr>
-            </a:pPr>
-            <a:r>
-              <a:t>TRƯỜNG ĐẠI HỌC MỞ HÀ NỘI — KHOA CÔNG NGHỆ THÔNG TIN</a:t>
-            </a:r>
-          </a:p>
-          <a:p>
-            <a:pPr>
-              <a:spcBef>
-                <a:spcPts val="1400"/>
-              </a:spcBef>
-              <a:defRPr sz="1700" b="1">
-                <a:solidFill>
-                  <a:srgbClr val="E11D48"/>
-                </a:solidFill>
-              </a:defRPr>
-            </a:pPr>
-            <a:r>
-              <a:t>BÁO CÁO THỰC NGHIỆM AN TOÀN WEB &amp; BẢO MẬT HỆ THỐNG</a:t>
+              <a:defRPr sz="1600" b="1">
+                <a:solidFill>
+                  <a:srgbClr val="BE123C"/>
+                </a:solidFill>
+              </a:defRPr>
+            </a:pPr>
+            <a:r>
+              <a:t>BÁO CÁO THỰC NGHIỆM AN TOÀN WEB (OWASP TOP 10)</a:t>
             </a:r>
           </a:p>
           <a:p>
@@ -3191,52 +3230,128 @@
               <a:spcBef>
                 <a:spcPts val="800"/>
               </a:spcBef>
-              <a:defRPr sz="2600" b="1">
-                <a:solidFill>
-                  <a:srgbClr val="FFFFFF"/>
-                </a:solidFill>
-              </a:defRPr>
-            </a:pPr>
-            <a:r>
-              <a:t>LỖ HỔNG SQL INJECTION (OWASP A03:2021)</a:t>
-            </a:r>
-            <a:br/>
-            <a:r>
-              <a:t>Kịch Bản Khai Thác Thực Tế &amp; Cơ Chế Phòng Thủ Trong ASP.NET Core</a:t>
+              <a:defRPr sz="3200" b="1">
+                <a:solidFill>
+                  <a:srgbClr val="0F172A"/>
+                </a:solidFill>
+              </a:defRPr>
+            </a:pPr>
+            <a:r>
+              <a:t>Lỗ Hổng SQL Injection (A03:2021)</a:t>
+            </a:r>
+            <a:br/>
+            <a:r>
+              <a:t>Kịch Bản Tấn Công &amp; Phòng Thủ Đa Tầng</a:t>
             </a:r>
           </a:p>
           <a:p>
             <a:pPr>
               <a:spcBef>
-                <a:spcPts val="1800"/>
+                <a:spcPts val="1000"/>
               </a:spcBef>
               <a:defRPr sz="1400">
                 <a:solidFill>
-                  <a:srgbClr val="CBD5E1"/>
-                </a:solidFill>
-              </a:defRPr>
-            </a:pPr>
-            <a:r>
-              <a:t>Giảng viên hướng dẫn: ThS. Lê Hữu Dũng | Học phần: Lập trình Web nâng cao</a:t>
+                  <a:srgbClr val="334155"/>
+                </a:solidFill>
+              </a:defRPr>
+            </a:pPr>
+            <a:r>
+              <a:t>Môn học: Lập trình Web nâng cao  •  Giảng viên hướng dẫn: ThS. Lê Hữu Dũng</a:t>
+            </a:r>
+          </a:p>
+        </p:txBody>
+      </p:sp>
+      <p:sp>
+        <p:nvSpPr>
+          <p:cNvPr id="5" name="Rounded Rectangle 4"/>
+          <p:cNvSpPr/>
+          <p:nvPr/>
+        </p:nvSpPr>
+        <p:spPr>
+          <a:xfrm>
+            <a:off x="914400" y="4389120"/>
+            <a:ext cx="10362895" cy="1737360"/>
+          </a:xfrm>
+          <a:prstGeom prst="roundRect">
+            <a:avLst/>
+          </a:prstGeom>
+          <a:solidFill>
+            <a:srgbClr val="F8FAFC"/>
+          </a:solidFill>
+          <a:ln>
+            <a:solidFill>
+              <a:srgbClr val="E2E8F0"/>
+            </a:solidFill>
+          </a:ln>
+        </p:spPr>
+        <p:style>
+          <a:lnRef idx="1">
+            <a:schemeClr val="accent1"/>
+          </a:lnRef>
+          <a:fillRef idx="3">
+            <a:schemeClr val="accent1"/>
+          </a:fillRef>
+          <a:effectRef idx="2">
+            <a:schemeClr val="accent1"/>
+          </a:effectRef>
+          <a:fontRef idx="minor">
+            <a:schemeClr val="lt1"/>
+          </a:fontRef>
+        </p:style>
+        <p:txBody>
+          <a:bodyPr rtlCol="0" anchor="ctr"/>
+          <a:lstStyle/>
+          <a:p>
+            <a:pPr algn="ctr"/>
+          </a:p>
+        </p:txBody>
+      </p:sp>
+      <p:sp>
+        <p:nvSpPr>
+          <p:cNvPr id="6" name="TextBox 5"/>
+          <p:cNvSpPr txBox="1"/>
+          <p:nvPr/>
+        </p:nvSpPr>
+        <p:spPr>
+          <a:xfrm>
+            <a:off x="1188720" y="4526280"/>
+            <a:ext cx="9784080" cy="1463040"/>
+          </a:xfrm>
+          <a:prstGeom prst="rect">
+            <a:avLst/>
+          </a:prstGeom>
+          <a:noFill/>
+        </p:spPr>
+        <p:txBody>
+          <a:bodyPr wrap="square">
+            <a:spAutoFit/>
+          </a:bodyPr>
+          <a:lstStyle/>
+          <a:p>
+            <a:pPr>
+              <a:defRPr sz="1300" b="1">
+                <a:solidFill>
+                  <a:srgbClr val="1D4ED8"/>
+                </a:solidFill>
+              </a:defRPr>
+            </a:pPr>
+            <a:r>
+              <a:t>NHÓM THỰC HIỆN: WNC.G01</a:t>
             </a:r>
           </a:p>
           <a:p>
             <a:pPr>
               <a:spcBef>
-                <a:spcPts val="1400"/>
+                <a:spcPts val="600"/>
               </a:spcBef>
-              <a:defRPr sz="1300">
-                <a:solidFill>
-                  <a:srgbClr val="94A3B8"/>
-                </a:solidFill>
-              </a:defRPr>
-            </a:pPr>
-            <a:r>
-              <a:t>Nhóm sinh viên thực hiện (WNC.G01):</a:t>
-            </a:r>
-            <a:br/>
-            <a:r>
-              <a:t>1. Nguyễn Danh Học  — MSV: 23A1001D0158 (Báo cáo &amp; Phụ trách demo chính)</a:t>
+              <a:defRPr sz="1250">
+                <a:solidFill>
+                  <a:srgbClr val="0F172A"/>
+                </a:solidFill>
+              </a:defRPr>
+            </a:pPr>
+            <a:r>
+              <a:t>1. Nguyễn Danh Học  — MSV: 23A1001D0158 (Phụ trách báo cáo &amp; demo thực nghiệm chính)</a:t>
             </a:r>
             <a:br/>
             <a:r>
@@ -3276,13 +3391,13 @@
         <p:spPr>
           <a:xfrm>
             <a:off x="0" y="0"/>
-            <a:ext cx="12191695" cy="1051560"/>
+            <a:ext cx="12191695" cy="73152"/>
           </a:xfrm>
           <a:prstGeom prst="rect">
             <a:avLst/>
           </a:prstGeom>
           <a:solidFill>
-            <a:srgbClr val="0F172A"/>
+            <a:srgbClr val="1D4ED8"/>
           </a:solidFill>
           <a:ln>
             <a:noFill/>
@@ -3312,14 +3427,68 @@
       </p:sp>
       <p:sp>
         <p:nvSpPr>
-          <p:cNvPr id="3" name="TextBox 2"/>
+          <p:cNvPr id="3" name="Rounded Rectangle 2"/>
+          <p:cNvSpPr/>
+          <p:nvPr/>
+        </p:nvSpPr>
+        <p:spPr>
+          <a:xfrm>
+            <a:off x="731520" y="320040"/>
+            <a:ext cx="3474720" cy="347472"/>
+          </a:xfrm>
+          <a:prstGeom prst="roundRect">
+            <a:avLst/>
+          </a:prstGeom>
+          <a:solidFill>
+            <a:srgbClr val="EFF6FF"/>
+          </a:solidFill>
+          <a:ln>
+            <a:solidFill>
+              <a:srgbClr val="BFDBFE"/>
+            </a:solidFill>
+          </a:ln>
+        </p:spPr>
+        <p:style>
+          <a:lnRef idx="1">
+            <a:schemeClr val="accent1"/>
+          </a:lnRef>
+          <a:fillRef idx="3">
+            <a:schemeClr val="accent1"/>
+          </a:fillRef>
+          <a:effectRef idx="2">
+            <a:schemeClr val="accent1"/>
+          </a:effectRef>
+          <a:fontRef idx="minor">
+            <a:schemeClr val="lt1"/>
+          </a:fontRef>
+        </p:style>
+        <p:txBody>
+          <a:bodyPr rtlCol="0" anchor="ctr" wrap="none"/>
+          <a:lstStyle/>
+          <a:p>
+            <a:pPr algn="ctr">
+              <a:defRPr sz="1000" b="1">
+                <a:solidFill>
+                  <a:srgbClr val="1D4ED8"/>
+                </a:solidFill>
+              </a:defRPr>
+            </a:pPr>
+            <a:r>
+              <a:t>OWASP TOP 10 • A03:2021 (INJECTION)</a:t>
+            </a:r>
+          </a:p>
+        </p:txBody>
+      </p:sp>
+      <p:sp>
+        <p:nvSpPr>
+          <p:cNvPr id="4" name="TextBox 3"/>
           <p:cNvSpPr txBox="1"/>
           <p:nvPr/>
         </p:nvSpPr>
         <p:spPr>
           <a:xfrm>
-            <a:off x="731520" y="109728"/>
-            <a:ext cx="10698480" cy="274320"/>
+            <a:off x="731520" y="685800"/>
+            <a:ext cx="10698480" cy="548640"/>
           </a:xfrm>
           <a:prstGeom prst="rect">
             <a:avLst/>
@@ -3333,21 +3502,9 @@
           <a:lstStyle/>
           <a:p>
             <a:pPr>
-              <a:defRPr sz="1100" b="1">
-                <a:solidFill>
-                  <a:srgbClr val="E11D48"/>
-                </a:solidFill>
-              </a:defRPr>
-            </a:pPr>
-            <a:r>
-              <a:t>OWASP TOP 10 - A03:2021 (INJECTION)</a:t>
-            </a:r>
-          </a:p>
-          <a:p>
-            <a:pPr>
-              <a:defRPr sz="1900" b="1">
-                <a:solidFill>
-                  <a:srgbClr val="FFFFFF"/>
+              <a:defRPr sz="2100" b="1">
+                <a:solidFill>
+                  <a:srgbClr val="0F172A"/>
                 </a:solidFill>
               </a:defRPr>
             </a:pPr>
@@ -3359,7 +3516,7 @@
       </p:sp>
       <p:sp>
         <p:nvSpPr>
-          <p:cNvPr id="4" name="TextBox 3"/>
+          <p:cNvPr id="5" name="TextBox 4"/>
           <p:cNvSpPr txBox="1"/>
           <p:nvPr/>
         </p:nvSpPr>
@@ -3387,103 +3544,7 @@
               </a:defRPr>
             </a:pPr>
             <a:r>
-              <a:t>Nhóm WNC.G01 (HOU) • Môn Lập Trình Web Nâng Cao • ThS. Lê Hữu Dũng</a:t>
-            </a:r>
-          </a:p>
-        </p:txBody>
-      </p:sp>
-      <p:sp>
-        <p:nvSpPr>
-          <p:cNvPr id="5" name="TextBox 4"/>
-          <p:cNvSpPr txBox="1"/>
-          <p:nvPr/>
-        </p:nvSpPr>
-        <p:spPr>
-          <a:xfrm>
-            <a:off x="731520" y="1234440"/>
-            <a:ext cx="5120640" cy="4937760"/>
-          </a:xfrm>
-          <a:prstGeom prst="rect">
-            <a:avLst/>
-          </a:prstGeom>
-          <a:noFill/>
-        </p:spPr>
-        <p:txBody>
-          <a:bodyPr wrap="square">
-            <a:spAutoFit/>
-          </a:bodyPr>
-          <a:lstStyle/>
-          <a:p>
-            <a:pPr>
-              <a:defRPr sz="1600" b="1">
-                <a:solidFill>
-                  <a:srgbClr val="E11D48"/>
-                </a:solidFill>
-              </a:defRPr>
-            </a:pPr>
-            <a:r>
-              <a:t>Nguyên Nhân Cốt Lõi</a:t>
-            </a:r>
-          </a:p>
-          <a:p>
-            <a:pPr>
-              <a:spcBef>
-                <a:spcPts val="800"/>
-              </a:spcBef>
-              <a:defRPr sz="1300">
-                <a:solidFill>
-                  <a:srgbClr val="1E293B"/>
-                </a:solidFill>
-              </a:defRPr>
-            </a:pPr>
-            <a:r>
-              <a:t>• Không phân tách giữa DỮ LIỆU (Data) và CÂU LỆNH (Code).</a:t>
-            </a:r>
-            <a:br/>
-            <a:r>
-              <a:t>• Ghép chuỗi trực tiếp từ Request vào câu lệnh SQL khiến hệ CSDL không phân biệt được đâu là dữ liệu của user và đâu là cấu trúc lệnh của lập trình viên.</a:t>
-            </a:r>
-            <a:br/>
-            <a:r>
-              <a:t>• Kẻ tấn công lợi dụng các ký tự điều khiển (', --, /*, ;) để 'thoát' khỏi ngữ cảnh dữ liệu và ép SQL Server thực thi logic của hacker.</a:t>
-            </a:r>
-          </a:p>
-          <a:p>
-            <a:pPr>
-              <a:spcBef>
-                <a:spcPts val="1600"/>
-              </a:spcBef>
-              <a:defRPr sz="1600" b="1">
-                <a:solidFill>
-                  <a:srgbClr val="2563EB"/>
-                </a:solidFill>
-              </a:defRPr>
-            </a:pPr>
-            <a:r>
-              <a:t>Phân Loại Theo Chuẩn OWASP WSTG</a:t>
-            </a:r>
-          </a:p>
-          <a:p>
-            <a:pPr>
-              <a:spcBef>
-                <a:spcPts val="600"/>
-              </a:spcBef>
-              <a:defRPr sz="1250">
-                <a:solidFill>
-                  <a:srgbClr val="1E293B"/>
-                </a:solidFill>
-              </a:defRPr>
-            </a:pPr>
-            <a:r>
-              <a:t>1. In-band SQLi (Khai thác trực diện): Error-based, Union-based.</a:t>
-            </a:r>
-            <a:br/>
-            <a:r>
-              <a:t>2. Inferential SQLi (Blind SQLi / Mù): Boolean-based, Time-based.</a:t>
-            </a:r>
-            <a:br/>
-            <a:r>
-              <a:t>3. Out-of-band SQLi: Kích hoạt DNS/HTTP request từ CSDL.</a:t>
+              <a:t>Nhóm WNC.G01 • Trường Đại học Mở Hà Nội (HOU) • GVHD: ThS. Lê Hữu Dũng</a:t>
             </a:r>
           </a:p>
         </p:txBody>
@@ -3496,8 +3557,8 @@
         </p:nvSpPr>
         <p:spPr>
           <a:xfrm>
-            <a:off x="6217920" y="1234440"/>
-            <a:ext cx="5212080" cy="4937760"/>
+            <a:off x="731520" y="1325880"/>
+            <a:ext cx="5120640" cy="4846320"/>
           </a:xfrm>
           <a:prstGeom prst="roundRect">
             <a:avLst/>
@@ -3541,8 +3602,8 @@
         </p:nvSpPr>
         <p:spPr>
           <a:xfrm>
-            <a:off x="6400800" y="1371600"/>
-            <a:ext cx="4846320" cy="4572000"/>
+            <a:off x="914400" y="1463040"/>
+            <a:ext cx="4754880" cy="4572000"/>
           </a:xfrm>
           <a:prstGeom prst="rect">
             <a:avLst/>
@@ -3556,14 +3617,14 @@
           <a:lstStyle/>
           <a:p>
             <a:pPr>
-              <a:defRPr sz="1400" b="1">
-                <a:solidFill>
-                  <a:srgbClr val="E11D48"/>
-                </a:solidFill>
-              </a:defRPr>
-            </a:pPr>
-            <a:r>
-              <a:t>Đoạn Code Gây Lỗi Cụ Thể (C# / ASP.NET Core)</a:t>
+              <a:defRPr sz="1600" b="1">
+                <a:solidFill>
+                  <a:srgbClr val="BE123C"/>
+                </a:solidFill>
+              </a:defRPr>
+            </a:pPr>
+            <a:r>
+              <a:t>Nguyên Nhân Cốt Lõi</a:t>
             </a:r>
           </a:p>
           <a:p>
@@ -3571,55 +3632,196 @@
               <a:spcBef>
                 <a:spcPts val="800"/>
               </a:spcBef>
-              <a:defRPr sz="1100">
-                <a:solidFill>
-                  <a:srgbClr val="B91C1C"/>
-                </a:solidFill>
-                <a:latin typeface="Courier New"/>
-              </a:defRPr>
-            </a:pPr>
-            <a:r>
-              <a:t>// Nối chuỗi trực tiếp từ Request:</a:t>
-            </a:r>
-            <a:br/>
-            <a:r>
-              <a:t>string query = $"SELECT * FROM Accounts " +</a:t>
-            </a:r>
-            <a:br/>
-            <a:r>
-              <a:t>               $"WHERE Username = '{user}' " +</a:t>
-            </a:r>
-            <a:br/>
-            <a:r>
-              <a:t>               $"AND Password = '{pass}'";</a:t>
-            </a:r>
-            <a:br/>
-            <a:br/>
-            <a:r>
-              <a:t>var users = _context.Accounts</a:t>
-            </a:r>
-            <a:br/>
-            <a:r>
-              <a:t>                    .FromSqlRaw(query)</a:t>
-            </a:r>
-            <a:br/>
-            <a:r>
-              <a:t>                    .ToList();</a:t>
+              <a:defRPr sz="1250">
+                <a:solidFill>
+                  <a:srgbClr val="334155"/>
+                </a:solidFill>
+              </a:defRPr>
+            </a:pPr>
+            <a:r>
+              <a:t>• Không phân tách giữa DỮ LIỆU (Data) và CÂU LỆNH (Code).</a:t>
+            </a:r>
+            <a:br/>
+            <a:r>
+              <a:t>• Ứng dụng nối chuỗi trực tiếp từ người dùng vào câu SQL khiến CSDL không phân biệt được đâu là dữ liệu, đâu là lệnh điều khiển.</a:t>
+            </a:r>
+            <a:br/>
+            <a:r>
+              <a:t>• Hacker dùng các ký tự đặc biệt (', --, ;) để bẻ gãy cấu trúc logic của câu lệnh.</a:t>
             </a:r>
           </a:p>
           <a:p>
             <a:pPr>
               <a:spcBef>
-                <a:spcPts val="1400"/>
+                <a:spcPts val="1600"/>
+              </a:spcBef>
+              <a:defRPr sz="1500" b="1">
+                <a:solidFill>
+                  <a:srgbClr val="1D4ED8"/>
+                </a:solidFill>
+              </a:defRPr>
+            </a:pPr>
+            <a:r>
+              <a:t>Phân Loại Theo Chuẩn OWASP WSTG</a:t>
+            </a:r>
+          </a:p>
+          <a:p>
+            <a:pPr>
+              <a:spcBef>
+                <a:spcPts val="600"/>
+              </a:spcBef>
+              <a:defRPr sz="1200">
+                <a:solidFill>
+                  <a:srgbClr val="334155"/>
+                </a:solidFill>
+              </a:defRPr>
+            </a:pPr>
+            <a:r>
+              <a:t>1. In-band SQLi: Khai thác trực diện qua Error hoặc UNION.</a:t>
+            </a:r>
+            <a:br/>
+            <a:r>
+              <a:t>2. Inferential SQLi (Blind): Suy luận mù qua Boolean hoặc Time delay.</a:t>
+            </a:r>
+            <a:br/>
+            <a:r>
+              <a:t>3. Out-of-band SQLi: Kích hoạt DNS/HTTP request từ CSDL.</a:t>
+            </a:r>
+          </a:p>
+        </p:txBody>
+      </p:sp>
+      <p:sp>
+        <p:nvSpPr>
+          <p:cNvPr id="8" name="Rounded Rectangle 7"/>
+          <p:cNvSpPr/>
+          <p:nvPr/>
+        </p:nvSpPr>
+        <p:spPr>
+          <a:xfrm>
+            <a:off x="6217920" y="1325880"/>
+            <a:ext cx="5212080" cy="4846320"/>
+          </a:xfrm>
+          <a:prstGeom prst="roundRect">
+            <a:avLst/>
+          </a:prstGeom>
+          <a:solidFill>
+            <a:srgbClr val="FFF1F2"/>
+          </a:solidFill>
+          <a:ln>
+            <a:solidFill>
+              <a:srgbClr val="FECDD3"/>
+            </a:solidFill>
+          </a:ln>
+        </p:spPr>
+        <p:style>
+          <a:lnRef idx="1">
+            <a:schemeClr val="accent1"/>
+          </a:lnRef>
+          <a:fillRef idx="3">
+            <a:schemeClr val="accent1"/>
+          </a:fillRef>
+          <a:effectRef idx="2">
+            <a:schemeClr val="accent1"/>
+          </a:effectRef>
+          <a:fontRef idx="minor">
+            <a:schemeClr val="lt1"/>
+          </a:fontRef>
+        </p:style>
+        <p:txBody>
+          <a:bodyPr rtlCol="0" anchor="ctr"/>
+          <a:lstStyle/>
+          <a:p>
+            <a:pPr algn="ctr"/>
+          </a:p>
+        </p:txBody>
+      </p:sp>
+      <p:sp>
+        <p:nvSpPr>
+          <p:cNvPr id="9" name="TextBox 8"/>
+          <p:cNvSpPr txBox="1"/>
+          <p:nvPr/>
+        </p:nvSpPr>
+        <p:spPr>
+          <a:xfrm>
+            <a:off x="6400800" y="1463040"/>
+            <a:ext cx="4846320" cy="4572000"/>
+          </a:xfrm>
+          <a:prstGeom prst="rect">
+            <a:avLst/>
+          </a:prstGeom>
+          <a:noFill/>
+        </p:spPr>
+        <p:txBody>
+          <a:bodyPr wrap="square">
+            <a:spAutoFit/>
+          </a:bodyPr>
+          <a:lstStyle/>
+          <a:p>
+            <a:pPr>
+              <a:defRPr sz="1500" b="1">
+                <a:solidFill>
+                  <a:srgbClr val="BE123C"/>
+                </a:solidFill>
+              </a:defRPr>
+            </a:pPr>
+            <a:r>
+              <a:t>Mã Nguồn C# Gây Lỗi (Cố Tình Ghép Chuỗi)</a:t>
+            </a:r>
+          </a:p>
+          <a:p>
+            <a:pPr>
+              <a:spcBef>
+                <a:spcPts val="1000"/>
+              </a:spcBef>
+              <a:defRPr sz="1100">
+                <a:solidFill>
+                  <a:srgbClr val="9F1239"/>
+                </a:solidFill>
+                <a:latin typeface="Courier New"/>
+              </a:defRPr>
+            </a:pPr>
+            <a:r>
+              <a:t>// Nối chuỗi trực tiếp từ Request:</a:t>
+            </a:r>
+            <a:br/>
+            <a:r>
+              <a:t>string query = $"SELECT * FROM Accounts " +</a:t>
+            </a:r>
+            <a:br/>
+            <a:r>
+              <a:t>               $"WHERE Username = '{user}' " +</a:t>
+            </a:r>
+            <a:br/>
+            <a:r>
+              <a:t>               $"AND Password = '{pass}'";</a:t>
+            </a:r>
+            <a:br/>
+            <a:br/>
+            <a:r>
+              <a:t>var users = _context.Accounts</a:t>
+            </a:r>
+            <a:br/>
+            <a:r>
+              <a:t>                    .FromSqlRaw(query)</a:t>
+            </a:r>
+            <a:br/>
+            <a:r>
+              <a:t>                    .ToList();</a:t>
+            </a:r>
+          </a:p>
+          <a:p>
+            <a:pPr>
+              <a:spcBef>
+                <a:spcPts val="1600"/>
               </a:spcBef>
               <a:defRPr sz="1300" b="1">
                 <a:solidFill>
-                  <a:srgbClr val="1E293B"/>
-                </a:solidFill>
-              </a:defRPr>
-            </a:pPr>
-            <a:r>
-              <a:t>⚠️ Điểm mù nguy hiểm:</a:t>
+                  <a:srgbClr val="0F172A"/>
+                </a:solidFill>
+              </a:defRPr>
+            </a:pPr>
+            <a:r>
+              <a:t>⚠️ Điểm mù chết người:</a:t>
             </a:r>
           </a:p>
           <a:p>
@@ -3629,12 +3831,12 @@
               </a:spcBef>
               <a:defRPr sz="1200">
                 <a:solidFill>
-                  <a:srgbClr val="64748B"/>
-                </a:solidFill>
-              </a:defRPr>
-            </a:pPr>
-            <a:r>
-              <a:t>Lập trình viên mặc định tin rằng '{user}' chỉ là chuỗi thông thường. Khi hacker truyền vào ký tự nháy đơn ('), toàn bộ cấu trúc cú pháp của câu lệnh bị bẻ gãy.</a:t>
+                  <a:srgbClr val="334155"/>
+                </a:solidFill>
+              </a:defRPr>
+            </a:pPr>
+            <a:r>
+              <a:t>Lập trình viên tin tưởng input '{user}' là vô hại. Dấu nháy đơn (') của hacker lập tức đóng sớm chuỗi dữ liệu, biến phần còn lại thành câu lệnh SQL có chủ đích.</a:t>
             </a:r>
           </a:p>
         </p:txBody>
@@ -3666,13 +3868,13 @@
         <p:spPr>
           <a:xfrm>
             <a:off x="0" y="0"/>
-            <a:ext cx="12191695" cy="1051560"/>
+            <a:ext cx="12191695" cy="73152"/>
           </a:xfrm>
           <a:prstGeom prst="rect">
             <a:avLst/>
           </a:prstGeom>
           <a:solidFill>
-            <a:srgbClr val="0F172A"/>
+            <a:srgbClr val="1D4ED8"/>
           </a:solidFill>
           <a:ln>
             <a:noFill/>
@@ -3702,14 +3904,68 @@
       </p:sp>
       <p:sp>
         <p:nvSpPr>
-          <p:cNvPr id="3" name="TextBox 2"/>
+          <p:cNvPr id="3" name="Rounded Rectangle 2"/>
+          <p:cNvSpPr/>
+          <p:nvPr/>
+        </p:nvSpPr>
+        <p:spPr>
+          <a:xfrm>
+            <a:off x="731520" y="320040"/>
+            <a:ext cx="3474720" cy="347472"/>
+          </a:xfrm>
+          <a:prstGeom prst="roundRect">
+            <a:avLst/>
+          </a:prstGeom>
+          <a:solidFill>
+            <a:srgbClr val="EFF6FF"/>
+          </a:solidFill>
+          <a:ln>
+            <a:solidFill>
+              <a:srgbClr val="BFDBFE"/>
+            </a:solidFill>
+          </a:ln>
+        </p:spPr>
+        <p:style>
+          <a:lnRef idx="1">
+            <a:schemeClr val="accent1"/>
+          </a:lnRef>
+          <a:fillRef idx="3">
+            <a:schemeClr val="accent1"/>
+          </a:fillRef>
+          <a:effectRef idx="2">
+            <a:schemeClr val="accent1"/>
+          </a:effectRef>
+          <a:fontRef idx="minor">
+            <a:schemeClr val="lt1"/>
+          </a:fontRef>
+        </p:style>
+        <p:txBody>
+          <a:bodyPr rtlCol="0" anchor="ctr" wrap="none"/>
+          <a:lstStyle/>
+          <a:p>
+            <a:pPr algn="ctr">
+              <a:defRPr sz="1000" b="1">
+                <a:solidFill>
+                  <a:srgbClr val="1D4ED8"/>
+                </a:solidFill>
+              </a:defRPr>
+            </a:pPr>
+            <a:r>
+              <a:t>OWASP TOP 10 • A03:2021 (INJECTION)</a:t>
+            </a:r>
+          </a:p>
+        </p:txBody>
+      </p:sp>
+      <p:sp>
+        <p:nvSpPr>
+          <p:cNvPr id="4" name="TextBox 3"/>
           <p:cNvSpPr txBox="1"/>
           <p:nvPr/>
         </p:nvSpPr>
         <p:spPr>
           <a:xfrm>
-            <a:off x="731520" y="109728"/>
-            <a:ext cx="10698480" cy="274320"/>
+            <a:off x="731520" y="685800"/>
+            <a:ext cx="10698480" cy="548640"/>
           </a:xfrm>
           <a:prstGeom prst="rect">
             <a:avLst/>
@@ -3723,21 +3979,9 @@
           <a:lstStyle/>
           <a:p>
             <a:pPr>
-              <a:defRPr sz="1100" b="1">
-                <a:solidFill>
-                  <a:srgbClr val="E11D48"/>
-                </a:solidFill>
-              </a:defRPr>
-            </a:pPr>
-            <a:r>
-              <a:t>OWASP TOP 10 - A03:2021 (INJECTION)</a:t>
-            </a:r>
-          </a:p>
-          <a:p>
-            <a:pPr>
-              <a:defRPr sz="1900" b="1">
-                <a:solidFill>
-                  <a:srgbClr val="FFFFFF"/>
+              <a:defRPr sz="2100" b="1">
+                <a:solidFill>
+                  <a:srgbClr val="0F172A"/>
                 </a:solidFill>
               </a:defRPr>
             </a:pPr>
@@ -3749,7 +3993,7 @@
       </p:sp>
       <p:sp>
         <p:nvSpPr>
-          <p:cNvPr id="4" name="TextBox 3"/>
+          <p:cNvPr id="5" name="TextBox 4"/>
           <p:cNvSpPr txBox="1"/>
           <p:nvPr/>
         </p:nvSpPr>
@@ -3777,21 +4021,21 @@
               </a:defRPr>
             </a:pPr>
             <a:r>
-              <a:t>Nhóm WNC.G01 (HOU) • Môn Lập Trình Web Nâng Cao • ThS. Lê Hữu Dũng</a:t>
-            </a:r>
-          </a:p>
-        </p:txBody>
-      </p:sp>
-      <p:sp>
-        <p:nvSpPr>
-          <p:cNvPr id="5" name="Rounded Rectangle 4"/>
+              <a:t>Nhóm WNC.G01 • Trường Đại học Mở Hà Nội (HOU) • GVHD: ThS. Lê Hữu Dũng</a:t>
+            </a:r>
+          </a:p>
+        </p:txBody>
+      </p:sp>
+      <p:sp>
+        <p:nvSpPr>
+          <p:cNvPr id="6" name="Rounded Rectangle 5"/>
           <p:cNvSpPr/>
           <p:nvPr/>
         </p:nvSpPr>
         <p:spPr>
           <a:xfrm>
-            <a:off x="731520" y="1280160"/>
-            <a:ext cx="3291840" cy="4846320"/>
+            <a:off x="731520" y="1325880"/>
+            <a:ext cx="3328416" cy="4846320"/>
           </a:xfrm>
           <a:prstGeom prst="roundRect">
             <a:avLst/>
@@ -3801,7 +4045,7 @@
           </a:solidFill>
           <a:ln>
             <a:solidFill>
-              <a:srgbClr val="E11D48"/>
+              <a:srgbClr val="FECDD3"/>
             </a:solidFill>
           </a:ln>
         </p:spPr>
@@ -3829,14 +4073,14 @@
       </p:sp>
       <p:sp>
         <p:nvSpPr>
-          <p:cNvPr id="6" name="TextBox 5"/>
+          <p:cNvPr id="7" name="TextBox 6"/>
           <p:cNvSpPr txBox="1"/>
           <p:nvPr/>
         </p:nvSpPr>
         <p:spPr>
           <a:xfrm>
-            <a:off x="868680" y="1463040"/>
-            <a:ext cx="3017520" cy="4480560"/>
+            <a:off x="868680" y="1508760"/>
+            <a:ext cx="3054096" cy="4480560"/>
           </a:xfrm>
           <a:prstGeom prst="rect">
             <a:avLst/>
@@ -3852,7 +4096,7 @@
             <a:pPr>
               <a:defRPr sz="1400" b="1">
                 <a:solidFill>
-                  <a:srgbClr val="E11D48"/>
+                  <a:srgbClr val="BE123C"/>
                 </a:solidFill>
               </a:defRPr>
             </a:pPr>
@@ -3871,7 +4115,7 @@
               </a:spcBef>
               <a:defRPr sz="1200">
                 <a:solidFill>
-                  <a:srgbClr val="1E293B"/>
+                  <a:srgbClr val="334155"/>
                 </a:solidFill>
               </a:defRPr>
             </a:pPr>
@@ -3884,21 +4128,21 @@
             </a:r>
             <a:br/>
             <a:r>
-              <a:t>• Chiếm đoạt phiên làm việc, thay đổi phân quyền và khóa tài khoản người dùng khác.</a:t>
-            </a:r>
-          </a:p>
-        </p:txBody>
-      </p:sp>
-      <p:sp>
-        <p:nvSpPr>
-          <p:cNvPr id="7" name="Rounded Rectangle 6"/>
+              <a:t>• Chiếm đoạt phiên làm việc, đổi quyền hạn và kiểm soát toàn bộ hệ thống.</a:t>
+            </a:r>
+          </a:p>
+        </p:txBody>
+      </p:sp>
+      <p:sp>
+        <p:nvSpPr>
+          <p:cNvPr id="8" name="Rounded Rectangle 7"/>
           <p:cNvSpPr/>
           <p:nvPr/>
         </p:nvSpPr>
         <p:spPr>
           <a:xfrm>
-            <a:off x="4389120" y="1280160"/>
-            <a:ext cx="3291840" cy="4846320"/>
+            <a:off x="4416552" y="1325880"/>
+            <a:ext cx="3328416" cy="4846320"/>
           </a:xfrm>
           <a:prstGeom prst="roundRect">
             <a:avLst/>
@@ -3908,7 +4152,7 @@
           </a:solidFill>
           <a:ln>
             <a:solidFill>
-              <a:srgbClr val="D97706"/>
+              <a:srgbClr val="FEF08A"/>
             </a:solidFill>
           </a:ln>
         </p:spPr>
@@ -3936,14 +4180,14 @@
       </p:sp>
       <p:sp>
         <p:nvSpPr>
-          <p:cNvPr id="8" name="TextBox 7"/>
+          <p:cNvPr id="9" name="TextBox 8"/>
           <p:cNvSpPr txBox="1"/>
           <p:nvPr/>
         </p:nvSpPr>
         <p:spPr>
           <a:xfrm>
-            <a:off x="4526280" y="1463040"/>
-            <a:ext cx="3017520" cy="4480560"/>
+            <a:off x="4553712" y="1508760"/>
+            <a:ext cx="3054096" cy="4480560"/>
           </a:xfrm>
           <a:prstGeom prst="rect">
             <a:avLst/>
@@ -3959,7 +4203,7 @@
             <a:pPr>
               <a:defRPr sz="1400" b="1">
                 <a:solidFill>
-                  <a:srgbClr val="D97706"/>
+                  <a:srgbClr val="B45309"/>
                 </a:solidFill>
               </a:defRPr>
             </a:pPr>
@@ -3978,7 +4222,7 @@
               </a:spcBef>
               <a:defRPr sz="1200">
                 <a:solidFill>
-                  <a:srgbClr val="1E293B"/>
+                  <a:srgbClr val="334155"/>
                 </a:solidFill>
               </a:defRPr>
             </a:pPr>
@@ -3987,25 +4231,25 @@
             </a:r>
             <a:br/>
             <a:r>
-              <a:t>• Rò rỉ mật khẩu và ghi chú bảo mật cá nhân (Secret Notes).</a:t>
-            </a:r>
-            <a:br/>
-            <a:r>
-              <a:t>• Vi phạm nghiêm trọng luật an ninh mạng, làm sụp đổ hoàn toàn uy tín nền tảng.</a:t>
-            </a:r>
-          </a:p>
-        </p:txBody>
-      </p:sp>
-      <p:sp>
-        <p:nvSpPr>
-          <p:cNvPr id="9" name="Rounded Rectangle 8"/>
+              <a:t>• Rò rỉ mật khẩu và bệnh án cá nhân (Secret Notes).</a:t>
+            </a:r>
+            <a:br/>
+            <a:r>
+              <a:t>• Vi phạm nghiêm trọng an ninh dữ liệu, phá vỡ uy tín của nền tảng tư vấn trực tuyến.</a:t>
+            </a:r>
+          </a:p>
+        </p:txBody>
+      </p:sp>
+      <p:sp>
+        <p:nvSpPr>
+          <p:cNvPr id="10" name="Rounded Rectangle 9"/>
           <p:cNvSpPr/>
           <p:nvPr/>
         </p:nvSpPr>
         <p:spPr>
           <a:xfrm>
-            <a:off x="8046720" y="1280160"/>
-            <a:ext cx="3291840" cy="4846320"/>
+            <a:off x="8101584" y="1325880"/>
+            <a:ext cx="3328416" cy="4846320"/>
           </a:xfrm>
           <a:prstGeom prst="roundRect">
             <a:avLst/>
@@ -4015,7 +4259,7 @@
           </a:solidFill>
           <a:ln>
             <a:solidFill>
-              <a:srgbClr val="0F172A"/>
+              <a:srgbClr val="BFDBFE"/>
             </a:solidFill>
           </a:ln>
         </p:spPr>
@@ -4043,14 +4287,14 @@
       </p:sp>
       <p:sp>
         <p:nvSpPr>
-          <p:cNvPr id="10" name="TextBox 9"/>
+          <p:cNvPr id="11" name="TextBox 10"/>
           <p:cNvSpPr txBox="1"/>
           <p:nvPr/>
         </p:nvSpPr>
         <p:spPr>
           <a:xfrm>
-            <a:off x="8183880" y="1463040"/>
-            <a:ext cx="3017520" cy="4480560"/>
+            <a:off x="8238744" y="1508760"/>
+            <a:ext cx="3054096" cy="4480560"/>
           </a:xfrm>
           <a:prstGeom prst="rect">
             <a:avLst/>
@@ -4066,7 +4310,7 @@
             <a:pPr>
               <a:defRPr sz="1400" b="1">
                 <a:solidFill>
-                  <a:srgbClr val="0F172A"/>
+                  <a:srgbClr val="1D4ED8"/>
                 </a:solidFill>
               </a:defRPr>
             </a:pPr>
@@ -4085,20 +4329,20 @@
               </a:spcBef>
               <a:defRPr sz="1200">
                 <a:solidFill>
-                  <a:srgbClr val="1E293B"/>
-                </a:solidFill>
-              </a:defRPr>
-            </a:pPr>
-            <a:r>
-              <a:t>• Xóa sổ dữ liệu với lệnh DROP TABLE hoặc TRUNCATE.</a:t>
-            </a:r>
-            <a:br/>
-            <a:r>
-              <a:t>• Sửa đổi dữ liệu, giả mạo giao dịch tài chính.</a:t>
-            </a:r>
-            <a:br/>
-            <a:r>
-              <a:t>• Có thể kích hoạt quyền thực thi lệnh hệ điều hành (xp_cmdshell) nếu CSDL cấu hình lỏng lẻo.</a:t>
+                  <a:srgbClr val="334155"/>
+                </a:solidFill>
+              </a:defRPr>
+            </a:pPr>
+            <a:r>
+              <a:t>• Xóa sạch CSDL với lệnh DROP TABLE hoặc TRUNCATE.</a:t>
+            </a:r>
+            <a:br/>
+            <a:r>
+              <a:t>• Giả mạo số dư tiền trong tài khoản.</a:t>
+            </a:r>
+            <a:br/>
+            <a:r>
+              <a:t>• Trong các CSDL cấu hình lỏng lẻo, hacker có thể bật xp_cmdshell để chiếm quyền điều khiển cả máy chủ hệ điều hành.</a:t>
             </a:r>
           </a:p>
         </p:txBody>
@@ -4130,13 +4374,13 @@
         <p:spPr>
           <a:xfrm>
             <a:off x="0" y="0"/>
-            <a:ext cx="12191695" cy="1051560"/>
+            <a:ext cx="12191695" cy="73152"/>
           </a:xfrm>
           <a:prstGeom prst="rect">
             <a:avLst/>
           </a:prstGeom>
           <a:solidFill>
-            <a:srgbClr val="0F172A"/>
+            <a:srgbClr val="1D4ED8"/>
           </a:solidFill>
           <a:ln>
             <a:noFill/>
@@ -4166,14 +4410,68 @@
       </p:sp>
       <p:sp>
         <p:nvSpPr>
-          <p:cNvPr id="3" name="TextBox 2"/>
+          <p:cNvPr id="3" name="Rounded Rectangle 2"/>
+          <p:cNvSpPr/>
+          <p:nvPr/>
+        </p:nvSpPr>
+        <p:spPr>
+          <a:xfrm>
+            <a:off x="731520" y="320040"/>
+            <a:ext cx="3474720" cy="347472"/>
+          </a:xfrm>
+          <a:prstGeom prst="roundRect">
+            <a:avLst/>
+          </a:prstGeom>
+          <a:solidFill>
+            <a:srgbClr val="EFF6FF"/>
+          </a:solidFill>
+          <a:ln>
+            <a:solidFill>
+              <a:srgbClr val="BFDBFE"/>
+            </a:solidFill>
+          </a:ln>
+        </p:spPr>
+        <p:style>
+          <a:lnRef idx="1">
+            <a:schemeClr val="accent1"/>
+          </a:lnRef>
+          <a:fillRef idx="3">
+            <a:schemeClr val="accent1"/>
+          </a:fillRef>
+          <a:effectRef idx="2">
+            <a:schemeClr val="accent1"/>
+          </a:effectRef>
+          <a:fontRef idx="minor">
+            <a:schemeClr val="lt1"/>
+          </a:fontRef>
+        </p:style>
+        <p:txBody>
+          <a:bodyPr rtlCol="0" anchor="ctr" wrap="none"/>
+          <a:lstStyle/>
+          <a:p>
+            <a:pPr algn="ctr">
+              <a:defRPr sz="1000" b="1">
+                <a:solidFill>
+                  <a:srgbClr val="1D4ED8"/>
+                </a:solidFill>
+              </a:defRPr>
+            </a:pPr>
+            <a:r>
+              <a:t>OWASP TOP 10 • A03:2021 (INJECTION)</a:t>
+            </a:r>
+          </a:p>
+        </p:txBody>
+      </p:sp>
+      <p:sp>
+        <p:nvSpPr>
+          <p:cNvPr id="4" name="TextBox 3"/>
           <p:cNvSpPr txBox="1"/>
           <p:nvPr/>
         </p:nvSpPr>
         <p:spPr>
           <a:xfrm>
-            <a:off x="731520" y="109728"/>
-            <a:ext cx="10698480" cy="274320"/>
+            <a:off x="731520" y="685800"/>
+            <a:ext cx="10698480" cy="548640"/>
           </a:xfrm>
           <a:prstGeom prst="rect">
             <a:avLst/>
@@ -4187,21 +4485,9 @@
           <a:lstStyle/>
           <a:p>
             <a:pPr>
-              <a:defRPr sz="1100" b="1">
-                <a:solidFill>
-                  <a:srgbClr val="E11D48"/>
-                </a:solidFill>
-              </a:defRPr>
-            </a:pPr>
-            <a:r>
-              <a:t>OWASP TOP 10 - A03:2021 (INJECTION)</a:t>
-            </a:r>
-          </a:p>
-          <a:p>
-            <a:pPr>
-              <a:defRPr sz="1900" b="1">
-                <a:solidFill>
-                  <a:srgbClr val="FFFFFF"/>
+              <a:defRPr sz="2100" b="1">
+                <a:solidFill>
+                  <a:srgbClr val="0F172A"/>
                 </a:solidFill>
               </a:defRPr>
             </a:pPr>
@@ -4213,7 +4499,7 @@
       </p:sp>
       <p:sp>
         <p:nvSpPr>
-          <p:cNvPr id="4" name="TextBox 3"/>
+          <p:cNvPr id="5" name="TextBox 4"/>
           <p:cNvSpPr txBox="1"/>
           <p:nvPr/>
         </p:nvSpPr>
@@ -4241,21 +4527,66 @@
               </a:defRPr>
             </a:pPr>
             <a:r>
-              <a:t>Nhóm WNC.G01 (HOU) • Môn Lập Trình Web Nâng Cao • ThS. Lê Hữu Dũng</a:t>
-            </a:r>
-          </a:p>
-        </p:txBody>
-      </p:sp>
-      <p:sp>
-        <p:nvSpPr>
-          <p:cNvPr id="5" name="TextBox 4"/>
+              <a:t>Nhóm WNC.G01 • Trường Đại học Mở Hà Nội (HOU) • GVHD: ThS. Lê Hữu Dũng</a:t>
+            </a:r>
+          </a:p>
+        </p:txBody>
+      </p:sp>
+      <p:sp>
+        <p:nvSpPr>
+          <p:cNvPr id="6" name="Rounded Rectangle 5"/>
+          <p:cNvSpPr/>
+          <p:nvPr/>
+        </p:nvSpPr>
+        <p:spPr>
+          <a:xfrm>
+            <a:off x="731520" y="1325880"/>
+            <a:ext cx="10728655" cy="4846320"/>
+          </a:xfrm>
+          <a:prstGeom prst="roundRect">
+            <a:avLst/>
+          </a:prstGeom>
+          <a:solidFill>
+            <a:srgbClr val="F8FAFC"/>
+          </a:solidFill>
+          <a:ln>
+            <a:solidFill>
+              <a:srgbClr val="E2E8F0"/>
+            </a:solidFill>
+          </a:ln>
+        </p:spPr>
+        <p:style>
+          <a:lnRef idx="1">
+            <a:schemeClr val="accent1"/>
+          </a:lnRef>
+          <a:fillRef idx="3">
+            <a:schemeClr val="accent1"/>
+          </a:fillRef>
+          <a:effectRef idx="2">
+            <a:schemeClr val="accent1"/>
+          </a:effectRef>
+          <a:fontRef idx="minor">
+            <a:schemeClr val="lt1"/>
+          </a:fontRef>
+        </p:style>
+        <p:txBody>
+          <a:bodyPr rtlCol="0" anchor="ctr"/>
+          <a:lstStyle/>
+          <a:p>
+            <a:pPr algn="ctr"/>
+          </a:p>
+        </p:txBody>
+      </p:sp>
+      <p:sp>
+        <p:nvSpPr>
+          <p:cNvPr id="7" name="TextBox 6"/>
           <p:cNvSpPr txBox="1"/>
           <p:nvPr/>
         </p:nvSpPr>
         <p:spPr>
           <a:xfrm>
-            <a:off x="731520" y="1234440"/>
-            <a:ext cx="10698480" cy="4937760"/>
+            <a:off x="1005840" y="1463040"/>
+            <a:ext cx="10149840" cy="4572000"/>
           </a:xfrm>
           <a:prstGeom prst="rect">
             <a:avLst/>
@@ -4269,14 +4600,14 @@
           <a:lstStyle/>
           <a:p>
             <a:pPr>
-              <a:defRPr sz="1600" b="1">
-                <a:solidFill>
-                  <a:srgbClr val="E11D48"/>
-                </a:solidFill>
-              </a:defRPr>
-            </a:pPr>
-            <a:r>
-              <a:t>Kịch bản: Vượt qua xác thực đăng nhập (Authentication Bypass)</a:t>
+              <a:defRPr sz="1500" b="1">
+                <a:solidFill>
+                  <a:srgbClr val="BE123C"/>
+                </a:solidFill>
+              </a:defRPr>
+            </a:pPr>
+            <a:r>
+              <a:t>Mục tiêu khai thác: Vượt qua xác thực đăng nhập (Authentication Bypass)</a:t>
             </a:r>
           </a:p>
           <a:p>
@@ -4286,7 +4617,7 @@
               </a:spcBef>
               <a:defRPr sz="1300" b="1">
                 <a:solidFill>
-                  <a:srgbClr val="2563EB"/>
+                  <a:srgbClr val="1D4ED8"/>
                 </a:solidFill>
                 <a:latin typeface="Courier New"/>
               </a:defRPr>
@@ -4296,7 +4627,38 @@
             </a:r>
             <a:br/>
             <a:r>
-              <a:t>Mật khẩu đưa vào Password: (Nhập bất kỳ hoặc để trống)</a:t>
+              <a:t>Mật khẩu đưa vào Password: (Nhập bất kỳ hoặc bỏ trống)</a:t>
+            </a:r>
+          </a:p>
+          <a:p>
+            <a:pPr>
+              <a:spcBef>
+                <a:spcPts val="1200"/>
+              </a:spcBef>
+              <a:defRPr sz="1400" b="1">
+                <a:solidFill>
+                  <a:srgbClr val="0F172A"/>
+                </a:solidFill>
+              </a:defRPr>
+            </a:pPr>
+            <a:r>
+              <a:t>Câu truy vấn thực tế được SQL Server phân tích &amp; thông dịch:</a:t>
+            </a:r>
+          </a:p>
+          <a:p>
+            <a:pPr>
+              <a:spcBef>
+                <a:spcPts val="400"/>
+              </a:spcBef>
+              <a:defRPr sz="1350" b="1">
+                <a:solidFill>
+                  <a:srgbClr val="BE123C"/>
+                </a:solidFill>
+                <a:latin typeface="Courier New"/>
+              </a:defRPr>
+            </a:pPr>
+            <a:r>
+              <a:t>SELECT * FROM Accounts WHERE Username = '' OR '1'='1' --' AND Password = 'xyz'</a:t>
             </a:r>
           </a:p>
           <a:p>
@@ -4304,45 +4666,14 @@
               <a:spcBef>
                 <a:spcPts val="1400"/>
               </a:spcBef>
-              <a:defRPr sz="1500" b="1">
-                <a:solidFill>
-                  <a:srgbClr val="1E293B"/>
-                </a:solidFill>
-              </a:defRPr>
-            </a:pPr>
-            <a:r>
-              <a:t>Cấu trúc câu truy vấn được SQL Server phân tích cú pháp:</a:t>
-            </a:r>
-          </a:p>
-          <a:p>
-            <a:pPr>
-              <a:spcBef>
-                <a:spcPts val="600"/>
-              </a:spcBef>
-              <a:defRPr sz="1350" b="1">
-                <a:solidFill>
-                  <a:srgbClr val="E11D48"/>
-                </a:solidFill>
-                <a:latin typeface="Courier New"/>
-              </a:defRPr>
-            </a:pPr>
-            <a:r>
-              <a:t>SELECT * FROM Accounts WHERE Username = '' OR '1'='1' --' AND Password = 'xyz'</a:t>
-            </a:r>
-          </a:p>
-          <a:p>
-            <a:pPr>
-              <a:spcBef>
-                <a:spcPts val="1400"/>
-              </a:spcBef>
-              <a:defRPr sz="1500" b="1">
-                <a:solidFill>
-                  <a:srgbClr val="1E293B"/>
-                </a:solidFill>
-              </a:defRPr>
-            </a:pPr>
-            <a:r>
-              <a:t>3 Thành Phần Cốt Lõi Của Chuỗi Khai Thác:</a:t>
+              <a:defRPr sz="1400" b="1">
+                <a:solidFill>
+                  <a:srgbClr val="0F172A"/>
+                </a:solidFill>
+              </a:defRPr>
+            </a:pPr>
+            <a:r>
+              <a:t>Giải Phẫu 3 Thành Phần Của Payload:</a:t>
             </a:r>
           </a:p>
           <a:p>
@@ -4352,20 +4683,20 @@
               </a:spcBef>
               <a:defRPr sz="1250">
                 <a:solidFill>
-                  <a:srgbClr val="1E293B"/>
-                </a:solidFill>
-              </a:defRPr>
-            </a:pPr>
-            <a:r>
-              <a:t>1. Dấu nháy đơn (') : Đóng sớm chuỗi ký tự hợp lệ của trường Username, đưa ngữ cảnh về câu lệnh SQL.</a:t>
-            </a:r>
-            <a:br/>
-            <a:r>
-              <a:t>2. Mệnh đề OR '1'='1' : Mệnh đề chân lý logic. Vì '1'='1' luôn đúng, mệnh đề WHERE trả về TRUE cho toàn bộ bản ghi trong bảng.</a:t>
-            </a:r>
-            <a:br/>
-            <a:r>
-              <a:t>3. Ký tự chú thích (--) : Biến toàn bộ đoạn kiểm tra mật khẩu phía sau thành chú thích vô hiệu lực.</a:t>
+                  <a:srgbClr val="334155"/>
+                </a:solidFill>
+              </a:defRPr>
+            </a:pPr>
+            <a:r>
+              <a:t>1. Dấu nháy đơn (') : Đóng sớm chuỗi ký tự hợp lệ của Username, đưa ngữ cảnh trở lại câu lệnh SQL.</a:t>
+            </a:r>
+            <a:br/>
+            <a:r>
+              <a:t>2. Mệnh đề OR '1'='1' : Biểu thức logic chân lý (luôn luôn TRUE cho mọi dòng trong bảng Accounts).</a:t>
+            </a:r>
+            <a:br/>
+            <a:r>
+              <a:t>3. Ký tự chú thích (--) : Vô hiệu hóa hoàn toàn phần kiểm tra mật khẩu phía sau (AND Password = '...').</a:t>
             </a:r>
           </a:p>
         </p:txBody>
@@ -4397,13 +4728,13 @@
         <p:spPr>
           <a:xfrm>
             <a:off x="0" y="0"/>
-            <a:ext cx="12191695" cy="1051560"/>
+            <a:ext cx="12191695" cy="73152"/>
           </a:xfrm>
           <a:prstGeom prst="rect">
             <a:avLst/>
           </a:prstGeom>
           <a:solidFill>
-            <a:srgbClr val="0F172A"/>
+            <a:srgbClr val="1D4ED8"/>
           </a:solidFill>
           <a:ln>
             <a:noFill/>
@@ -4433,14 +4764,68 @@
       </p:sp>
       <p:sp>
         <p:nvSpPr>
-          <p:cNvPr id="3" name="TextBox 2"/>
+          <p:cNvPr id="3" name="Rounded Rectangle 2"/>
+          <p:cNvSpPr/>
+          <p:nvPr/>
+        </p:nvSpPr>
+        <p:spPr>
+          <a:xfrm>
+            <a:off x="731520" y="320040"/>
+            <a:ext cx="3474720" cy="347472"/>
+          </a:xfrm>
+          <a:prstGeom prst="roundRect">
+            <a:avLst/>
+          </a:prstGeom>
+          <a:solidFill>
+            <a:srgbClr val="EFF6FF"/>
+          </a:solidFill>
+          <a:ln>
+            <a:solidFill>
+              <a:srgbClr val="BFDBFE"/>
+            </a:solidFill>
+          </a:ln>
+        </p:spPr>
+        <p:style>
+          <a:lnRef idx="1">
+            <a:schemeClr val="accent1"/>
+          </a:lnRef>
+          <a:fillRef idx="3">
+            <a:schemeClr val="accent1"/>
+          </a:fillRef>
+          <a:effectRef idx="2">
+            <a:schemeClr val="accent1"/>
+          </a:effectRef>
+          <a:fontRef idx="minor">
+            <a:schemeClr val="lt1"/>
+          </a:fontRef>
+        </p:style>
+        <p:txBody>
+          <a:bodyPr rtlCol="0" anchor="ctr" wrap="none"/>
+          <a:lstStyle/>
+          <a:p>
+            <a:pPr algn="ctr">
+              <a:defRPr sz="1000" b="1">
+                <a:solidFill>
+                  <a:srgbClr val="1D4ED8"/>
+                </a:solidFill>
+              </a:defRPr>
+            </a:pPr>
+            <a:r>
+              <a:t>OWASP TOP 10 • A03:2021 (INJECTION)</a:t>
+            </a:r>
+          </a:p>
+        </p:txBody>
+      </p:sp>
+      <p:sp>
+        <p:nvSpPr>
+          <p:cNvPr id="4" name="TextBox 3"/>
           <p:cNvSpPr txBox="1"/>
           <p:nvPr/>
         </p:nvSpPr>
         <p:spPr>
           <a:xfrm>
-            <a:off x="731520" y="109728"/>
-            <a:ext cx="10698480" cy="274320"/>
+            <a:off x="731520" y="685800"/>
+            <a:ext cx="10698480" cy="548640"/>
           </a:xfrm>
           <a:prstGeom prst="rect">
             <a:avLst/>
@@ -4454,21 +4839,9 @@
           <a:lstStyle/>
           <a:p>
             <a:pPr>
-              <a:defRPr sz="1100" b="1">
-                <a:solidFill>
-                  <a:srgbClr val="E11D48"/>
-                </a:solidFill>
-              </a:defRPr>
-            </a:pPr>
-            <a:r>
-              <a:t>OWASP TOP 10 - A03:2021 (INJECTION)</a:t>
-            </a:r>
-          </a:p>
-          <a:p>
-            <a:pPr>
-              <a:defRPr sz="1900" b="1">
-                <a:solidFill>
-                  <a:srgbClr val="FFFFFF"/>
+              <a:defRPr sz="2100" b="1">
+                <a:solidFill>
+                  <a:srgbClr val="0F172A"/>
                 </a:solidFill>
               </a:defRPr>
             </a:pPr>
@@ -4480,7 +4853,7 @@
       </p:sp>
       <p:sp>
         <p:nvSpPr>
-          <p:cNvPr id="4" name="TextBox 3"/>
+          <p:cNvPr id="5" name="TextBox 4"/>
           <p:cNvSpPr txBox="1"/>
           <p:nvPr/>
         </p:nvSpPr>
@@ -4508,21 +4881,21 @@
               </a:defRPr>
             </a:pPr>
             <a:r>
-              <a:t>Nhóm WNC.G01 (HOU) • Môn Lập Trình Web Nâng Cao • ThS. Lê Hữu Dũng</a:t>
-            </a:r>
-          </a:p>
-        </p:txBody>
-      </p:sp>
-      <p:sp>
-        <p:nvSpPr>
-          <p:cNvPr id="5" name="Rounded Rectangle 4"/>
+              <a:t>Nhóm WNC.G01 • Trường Đại học Mở Hà Nội (HOU) • GVHD: ThS. Lê Hữu Dũng</a:t>
+            </a:r>
+          </a:p>
+        </p:txBody>
+      </p:sp>
+      <p:sp>
+        <p:nvSpPr>
+          <p:cNvPr id="6" name="Rounded Rectangle 5"/>
           <p:cNvSpPr/>
           <p:nvPr/>
         </p:nvSpPr>
         <p:spPr>
           <a:xfrm>
-            <a:off x="731520" y="1234440"/>
-            <a:ext cx="5166360" cy="3931920"/>
+            <a:off x="731520" y="1325880"/>
+            <a:ext cx="5166360" cy="3840480"/>
           </a:xfrm>
           <a:prstGeom prst="roundRect">
             <a:avLst/>
@@ -4532,7 +4905,7 @@
           </a:solidFill>
           <a:ln>
             <a:solidFill>
-              <a:srgbClr val="E11D48"/>
+              <a:srgbClr val="FECDD3"/>
             </a:solidFill>
           </a:ln>
         </p:spPr>
@@ -4560,14 +4933,14 @@
       </p:sp>
       <p:sp>
         <p:nvSpPr>
-          <p:cNvPr id="6" name="TextBox 5"/>
+          <p:cNvPr id="7" name="TextBox 6"/>
           <p:cNvSpPr txBox="1"/>
           <p:nvPr/>
         </p:nvSpPr>
         <p:spPr>
           <a:xfrm>
-            <a:off x="868680" y="1325880"/>
-            <a:ext cx="4892040" cy="3657600"/>
+            <a:off x="914400" y="1463040"/>
+            <a:ext cx="4800600" cy="3566160"/>
           </a:xfrm>
           <a:prstGeom prst="rect">
             <a:avLst/>
@@ -4583,7 +4956,7 @@
             <a:pPr>
               <a:defRPr sz="1400" b="1">
                 <a:solidFill>
-                  <a:srgbClr val="E11D48"/>
+                  <a:srgbClr val="BE123C"/>
                 </a:solidFill>
               </a:defRPr>
             </a:pPr>
@@ -4598,12 +4971,12 @@
               </a:spcBef>
               <a:defRPr sz="1200">
                 <a:solidFill>
-                  <a:srgbClr val="1E293B"/>
-                </a:solidFill>
-              </a:defRPr>
-            </a:pPr>
-            <a:r>
-              <a:t>• Payload thử nghiệm: ' OR '1'='1' --</a:t>
+                  <a:srgbClr val="334155"/>
+                </a:solidFill>
+              </a:defRPr>
+            </a:pPr>
+            <a:r>
+              <a:t>• Input khai thác: ' OR '1'='1' --</a:t>
             </a:r>
             <a:br/>
             <a:r>
@@ -4615,7 +4988,7 @@
             </a:r>
             <a:br/>
             <a:r>
-              <a:t>• Cơ chế thông dịch: Điều kiện WHERE luôn TRUE.</a:t>
+              <a:t>• Cơ chế thông dịch: Mệnh đề WHERE luôn TRUE.</a:t>
             </a:r>
             <a:br/>
             <a:r>
@@ -4627,7 +5000,7 @@
             </a:r>
             <a:br/>
             <a:r>
-              <a:t>  - Rò rỉ toàn bộ 4 tài khoản trong CSDL (Admin, Specialist, Customer).</a:t>
+              <a:t>  - Rò rỉ toàn bộ 4 tài khoản CSDL (Admin, Chuyên gia, Khách hàng).</a:t>
             </a:r>
             <a:br/>
             <a:r>
@@ -4638,14 +5011,14 @@
       </p:sp>
       <p:sp>
         <p:nvSpPr>
-          <p:cNvPr id="7" name="Rounded Rectangle 6"/>
+          <p:cNvPr id="8" name="Rounded Rectangle 7"/>
           <p:cNvSpPr/>
           <p:nvPr/>
         </p:nvSpPr>
         <p:spPr>
           <a:xfrm>
-            <a:off x="6263640" y="1234440"/>
-            <a:ext cx="5166360" cy="3931920"/>
+            <a:off x="6263640" y="1325880"/>
+            <a:ext cx="5166360" cy="3840480"/>
           </a:xfrm>
           <a:prstGeom prst="roundRect">
             <a:avLst/>
@@ -4655,7 +5028,7 @@
           </a:solidFill>
           <a:ln>
             <a:solidFill>
-              <a:srgbClr val="10B981"/>
+              <a:srgbClr val="A7F3D0"/>
             </a:solidFill>
           </a:ln>
         </p:spPr>
@@ -4683,14 +5056,14 @@
       </p:sp>
       <p:sp>
         <p:nvSpPr>
-          <p:cNvPr id="8" name="TextBox 7"/>
+          <p:cNvPr id="9" name="TextBox 8"/>
           <p:cNvSpPr txBox="1"/>
           <p:nvPr/>
         </p:nvSpPr>
         <p:spPr>
           <a:xfrm>
-            <a:off x="6400800" y="1325880"/>
-            <a:ext cx="4892040" cy="3657600"/>
+            <a:off x="6446520" y="1463040"/>
+            <a:ext cx="4800600" cy="3566160"/>
           </a:xfrm>
           <a:prstGeom prst="rect">
             <a:avLst/>
@@ -4706,7 +5079,7 @@
             <a:pPr>
               <a:defRPr sz="1400" b="1">
                 <a:solidFill>
-                  <a:srgbClr val="10B981"/>
+                  <a:srgbClr val="047857"/>
                 </a:solidFill>
               </a:defRPr>
             </a:pPr>
@@ -4721,12 +5094,12 @@
               </a:spcBef>
               <a:defRPr sz="1200">
                 <a:solidFill>
-                  <a:srgbClr val="1E293B"/>
-                </a:solidFill>
-              </a:defRPr>
-            </a:pPr>
-            <a:r>
-              <a:t>• Cùng Payload thử nghiệm: ' OR '1'='1' --</a:t>
+                  <a:srgbClr val="334155"/>
+                </a:solidFill>
+              </a:defRPr>
+            </a:pPr>
+            <a:r>
+              <a:t>• Cùng Input khai thác: ' OR '1'='1' --</a:t>
             </a:r>
             <a:br/>
             <a:r>
@@ -4746,7 +5119,7 @@
             </a:r>
             <a:br/>
             <a:r>
-              <a:t>  - Toàn bộ chuỗi payload được coi là String Literal thuần túy.</a:t>
+              <a:t>  - Toàn bộ chuỗi payload được xem là văn bản (String Literal) thuần túy.</a:t>
             </a:r>
             <a:br/>
             <a:r>
@@ -4758,31 +5131,31 @@
             </a:r>
             <a:br/>
             <a:r>
-              <a:t>  - Báo lỗi 'Sai tài khoản/mật khẩu', bảo vệ an toàn 100%.</a:t>
-            </a:r>
-          </a:p>
-        </p:txBody>
-      </p:sp>
-      <p:sp>
-        <p:nvSpPr>
-          <p:cNvPr id="9" name="Rounded Rectangle 8"/>
+              <a:t>  - Báo 'Sai tài khoản/mật khẩu', bảo vệ an toàn 100%.</a:t>
+            </a:r>
+          </a:p>
+        </p:txBody>
+      </p:sp>
+      <p:sp>
+        <p:nvSpPr>
+          <p:cNvPr id="10" name="Rounded Rectangle 9"/>
           <p:cNvSpPr/>
           <p:nvPr/>
         </p:nvSpPr>
         <p:spPr>
           <a:xfrm>
             <a:off x="731520" y="5303520"/>
-            <a:ext cx="10698480" cy="914400"/>
+            <a:ext cx="10728655" cy="868680"/>
           </a:xfrm>
           <a:prstGeom prst="roundRect">
             <a:avLst/>
           </a:prstGeom>
           <a:solidFill>
-            <a:srgbClr val="1E293B"/>
+            <a:srgbClr val="EFF6FF"/>
           </a:solidFill>
           <a:ln>
             <a:solidFill>
-              <a:srgbClr val="2563EB"/>
+              <a:srgbClr val="BFDBFE"/>
             </a:solidFill>
           </a:ln>
         </p:spPr>
@@ -4810,14 +5183,14 @@
       </p:sp>
       <p:sp>
         <p:nvSpPr>
-          <p:cNvPr id="10" name="TextBox 9"/>
+          <p:cNvPr id="11" name="TextBox 10"/>
           <p:cNvSpPr txBox="1"/>
           <p:nvPr/>
         </p:nvSpPr>
         <p:spPr>
           <a:xfrm>
             <a:off x="914400" y="5349240"/>
-            <a:ext cx="10332720" cy="822960"/>
+            <a:ext cx="10332720" cy="777240"/>
           </a:xfrm>
           <a:prstGeom prst="rect">
             <a:avLst/>
@@ -4831,14 +5204,14 @@
           <a:lstStyle/>
           <a:p>
             <a:pPr>
-              <a:defRPr sz="1300" b="1">
-                <a:solidFill>
-                  <a:srgbClr val="38BDF8"/>
-                </a:solidFill>
-              </a:defRPr>
-            </a:pPr>
-            <a:r>
-              <a:t>💻 [LIVE DEMO TRÊN MÁY]: Chuyển sang Trình duyệt Web (http://localhost:5076) &amp; VS Code</a:t>
+              <a:defRPr sz="1250" b="1">
+                <a:solidFill>
+                  <a:srgbClr val="1D4ED8"/>
+                </a:solidFill>
+              </a:defRPr>
+            </a:pPr>
+            <a:r>
+              <a:t>💻 [LIVE DEMO TRÊN MÁY]: Chuyển sang Trình duyệt Web (http://localhost:5076)</a:t>
             </a:r>
           </a:p>
           <a:p>
@@ -4846,14 +5219,14 @@
               <a:spcBef>
                 <a:spcPts val="200"/>
               </a:spcBef>
-              <a:defRPr sz="1150">
-                <a:solidFill>
-                  <a:srgbClr val="FFFFFF"/>
-                </a:solidFill>
-              </a:defRPr>
-            </a:pPr>
-            <a:r>
-              <a:t>Trình diễn trực tiếp 3 bước: Bấm nạp payload → Kiểm tra kết quả trả về → Đối chiếu Log SQL Server.</a:t>
+              <a:defRPr sz="1100">
+                <a:solidFill>
+                  <a:srgbClr val="334155"/>
+                </a:solidFill>
+              </a:defRPr>
+            </a:pPr>
+            <a:r>
+              <a:t>Thao tác trực tiếp: Bấm nạp payload → Nhấn submit bên Đỏ (ra toàn bộ CSDL) → Nhấn submit bên Xanh (bị chặn an toàn).</a:t>
             </a:r>
           </a:p>
         </p:txBody>
@@ -4885,13 +5258,13 @@
         <p:spPr>
           <a:xfrm>
             <a:off x="0" y="0"/>
-            <a:ext cx="12191695" cy="1051560"/>
+            <a:ext cx="12191695" cy="73152"/>
           </a:xfrm>
           <a:prstGeom prst="rect">
             <a:avLst/>
           </a:prstGeom>
           <a:solidFill>
-            <a:srgbClr val="0F172A"/>
+            <a:srgbClr val="1D4ED8"/>
           </a:solidFill>
           <a:ln>
             <a:noFill/>
@@ -4921,14 +5294,68 @@
       </p:sp>
       <p:sp>
         <p:nvSpPr>
-          <p:cNvPr id="3" name="TextBox 2"/>
+          <p:cNvPr id="3" name="Rounded Rectangle 2"/>
+          <p:cNvSpPr/>
+          <p:nvPr/>
+        </p:nvSpPr>
+        <p:spPr>
+          <a:xfrm>
+            <a:off x="731520" y="320040"/>
+            <a:ext cx="3474720" cy="347472"/>
+          </a:xfrm>
+          <a:prstGeom prst="roundRect">
+            <a:avLst/>
+          </a:prstGeom>
+          <a:solidFill>
+            <a:srgbClr val="EFF6FF"/>
+          </a:solidFill>
+          <a:ln>
+            <a:solidFill>
+              <a:srgbClr val="BFDBFE"/>
+            </a:solidFill>
+          </a:ln>
+        </p:spPr>
+        <p:style>
+          <a:lnRef idx="1">
+            <a:schemeClr val="accent1"/>
+          </a:lnRef>
+          <a:fillRef idx="3">
+            <a:schemeClr val="accent1"/>
+          </a:fillRef>
+          <a:effectRef idx="2">
+            <a:schemeClr val="accent1"/>
+          </a:effectRef>
+          <a:fontRef idx="minor">
+            <a:schemeClr val="lt1"/>
+          </a:fontRef>
+        </p:style>
+        <p:txBody>
+          <a:bodyPr rtlCol="0" anchor="ctr" wrap="none"/>
+          <a:lstStyle/>
+          <a:p>
+            <a:pPr algn="ctr">
+              <a:defRPr sz="1000" b="1">
+                <a:solidFill>
+                  <a:srgbClr val="1D4ED8"/>
+                </a:solidFill>
+              </a:defRPr>
+            </a:pPr>
+            <a:r>
+              <a:t>OWASP TOP 10 • A03:2021 (INJECTION)</a:t>
+            </a:r>
+          </a:p>
+        </p:txBody>
+      </p:sp>
+      <p:sp>
+        <p:nvSpPr>
+          <p:cNvPr id="4" name="TextBox 3"/>
           <p:cNvSpPr txBox="1"/>
           <p:nvPr/>
         </p:nvSpPr>
         <p:spPr>
           <a:xfrm>
-            <a:off x="731520" y="109728"/>
-            <a:ext cx="10698480" cy="274320"/>
+            <a:off x="731520" y="685800"/>
+            <a:ext cx="10698480" cy="548640"/>
           </a:xfrm>
           <a:prstGeom prst="rect">
             <a:avLst/>
@@ -4942,21 +5369,9 @@
           <a:lstStyle/>
           <a:p>
             <a:pPr>
-              <a:defRPr sz="1100" b="1">
-                <a:solidFill>
-                  <a:srgbClr val="E11D48"/>
-                </a:solidFill>
-              </a:defRPr>
-            </a:pPr>
-            <a:r>
-              <a:t>OWASP TOP 10 - A03:2021 (INJECTION)</a:t>
-            </a:r>
-          </a:p>
-          <a:p>
-            <a:pPr>
-              <a:defRPr sz="1900" b="1">
-                <a:solidFill>
-                  <a:srgbClr val="FFFFFF"/>
+              <a:defRPr sz="2100" b="1">
+                <a:solidFill>
+                  <a:srgbClr val="0F172A"/>
                 </a:solidFill>
               </a:defRPr>
             </a:pPr>
@@ -4968,7 +5383,7 @@
       </p:sp>
       <p:sp>
         <p:nvSpPr>
-          <p:cNvPr id="4" name="TextBox 3"/>
+          <p:cNvPr id="5" name="TextBox 4"/>
           <p:cNvSpPr txBox="1"/>
           <p:nvPr/>
         </p:nvSpPr>
@@ -4996,21 +5411,21 @@
               </a:defRPr>
             </a:pPr>
             <a:r>
-              <a:t>Nhóm WNC.G01 (HOU) • Môn Lập Trình Web Nâng Cao • ThS. Lê Hữu Dũng</a:t>
-            </a:r>
-          </a:p>
-        </p:txBody>
-      </p:sp>
-      <p:sp>
-        <p:nvSpPr>
-          <p:cNvPr id="5" name="Rounded Rectangle 4"/>
+              <a:t>Nhóm WNC.G01 • Trường Đại học Mở Hà Nội (HOU) • GVHD: ThS. Lê Hữu Dũng</a:t>
+            </a:r>
+          </a:p>
+        </p:txBody>
+      </p:sp>
+      <p:sp>
+        <p:nvSpPr>
+          <p:cNvPr id="6" name="Rounded Rectangle 5"/>
           <p:cNvSpPr/>
           <p:nvPr/>
         </p:nvSpPr>
         <p:spPr>
           <a:xfrm>
-            <a:off x="731520" y="1234440"/>
-            <a:ext cx="5166360" cy="3931920"/>
+            <a:off x="731520" y="1325880"/>
+            <a:ext cx="5166360" cy="3840480"/>
           </a:xfrm>
           <a:prstGeom prst="roundRect">
             <a:avLst/>
@@ -5048,14 +5463,14 @@
       </p:sp>
       <p:sp>
         <p:nvSpPr>
-          <p:cNvPr id="6" name="TextBox 5"/>
+          <p:cNvPr id="7" name="TextBox 6"/>
           <p:cNvSpPr txBox="1"/>
           <p:nvPr/>
         </p:nvSpPr>
         <p:spPr>
           <a:xfrm>
-            <a:off x="914400" y="1371600"/>
-            <a:ext cx="4800600" cy="3657600"/>
+            <a:off x="914400" y="1463040"/>
+            <a:ext cx="4800600" cy="3566160"/>
           </a:xfrm>
           <a:prstGeom prst="rect">
             <a:avLst/>
@@ -5071,7 +5486,7 @@
             <a:pPr>
               <a:defRPr sz="1400" b="1">
                 <a:solidFill>
-                  <a:srgbClr val="2563EB"/>
+                  <a:srgbClr val="1D4ED8"/>
                 </a:solidFill>
               </a:defRPr>
             </a:pPr>
@@ -5086,7 +5501,7 @@
               </a:spcBef>
               <a:defRPr sz="1000">
                 <a:solidFill>
-                  <a:srgbClr val="1E293B"/>
+                  <a:srgbClr val="0F172A"/>
                 </a:solidFill>
                 <a:latin typeface="Courier New"/>
               </a:defRPr>
@@ -5135,26 +5550,26 @@
               </a:spcBef>
               <a:defRPr sz="1150">
                 <a:solidFill>
-                  <a:srgbClr val="64748B"/>
-                </a:solidFill>
-              </a:defRPr>
-            </a:pPr>
-            <a:r>
-              <a:t>📌 Ý nghĩa: Chứng minh lỗ hổng nằm hoàn toàn ở logic C# Backend, kẻ tấn công có thể dùng script tự động quét và khai thác mà không cần mở trình duyệt.</a:t>
-            </a:r>
-          </a:p>
-        </p:txBody>
-      </p:sp>
-      <p:sp>
-        <p:nvSpPr>
-          <p:cNvPr id="7" name="Rounded Rectangle 6"/>
+                  <a:srgbClr val="334155"/>
+                </a:solidFill>
+              </a:defRPr>
+            </a:pPr>
+            <a:r>
+              <a:t>📌 Ý nghĩa: Chứng minh lỗ hổng nằm ở logic C# Backend, kẻ tấn công dùng script tự động quét và khai thác mà không cần mở web.</a:t>
+            </a:r>
+          </a:p>
+        </p:txBody>
+      </p:sp>
+      <p:sp>
+        <p:nvSpPr>
+          <p:cNvPr id="8" name="Rounded Rectangle 7"/>
           <p:cNvSpPr/>
           <p:nvPr/>
         </p:nvSpPr>
         <p:spPr>
           <a:xfrm>
-            <a:off x="6263640" y="1234440"/>
-            <a:ext cx="5166360" cy="3931920"/>
+            <a:off x="6263640" y="1325880"/>
+            <a:ext cx="5166360" cy="3840480"/>
           </a:xfrm>
           <a:prstGeom prst="roundRect">
             <a:avLst/>
@@ -5192,14 +5607,14 @@
       </p:sp>
       <p:sp>
         <p:nvSpPr>
-          <p:cNvPr id="8" name="TextBox 7"/>
+          <p:cNvPr id="9" name="TextBox 8"/>
           <p:cNvSpPr txBox="1"/>
           <p:nvPr/>
         </p:nvSpPr>
         <p:spPr>
           <a:xfrm>
-            <a:off x="6400800" y="1371600"/>
-            <a:ext cx="4800600" cy="3657600"/>
+            <a:off x="6446520" y="1463040"/>
+            <a:ext cx="4800600" cy="3566160"/>
           </a:xfrm>
           <a:prstGeom prst="rect">
             <a:avLst/>
@@ -5215,12 +5630,12 @@
             <a:pPr>
               <a:defRPr sz="1400" b="1">
                 <a:solidFill>
-                  <a:srgbClr val="10B981"/>
-                </a:solidFill>
-              </a:defRPr>
-            </a:pPr>
-            <a:r>
-              <a:t>Minh Chứng Tầng CSDL (SQL Server 2025)</a:t>
+                  <a:srgbClr val="047857"/>
+                </a:solidFill>
+              </a:defRPr>
+            </a:pPr>
+            <a:r>
+              <a:t>Minh Chứng Tầng CSDL (SQL Server 2025 Thật)</a:t>
             </a:r>
           </a:p>
           <a:p>
@@ -5230,7 +5645,7 @@
               </a:spcBef>
               <a:defRPr sz="1000">
                 <a:solidFill>
-                  <a:srgbClr val="1E293B"/>
+                  <a:srgbClr val="0F172A"/>
                 </a:solidFill>
                 <a:latin typeface="Courier New"/>
               </a:defRPr>
@@ -5275,7 +5690,7 @@
               </a:spcBef>
               <a:defRPr sz="1150">
                 <a:solidFill>
-                  <a:srgbClr val="64748B"/>
+                  <a:srgbClr val="334155"/>
                 </a:solidFill>
               </a:defRPr>
             </a:pPr>
@@ -5287,24 +5702,24 @@
       </p:sp>
       <p:sp>
         <p:nvSpPr>
-          <p:cNvPr id="9" name="Rounded Rectangle 8"/>
+          <p:cNvPr id="10" name="Rounded Rectangle 9"/>
           <p:cNvSpPr/>
           <p:nvPr/>
         </p:nvSpPr>
         <p:spPr>
           <a:xfrm>
             <a:off x="731520" y="5303520"/>
-            <a:ext cx="10698480" cy="914400"/>
+            <a:ext cx="10728655" cy="868680"/>
           </a:xfrm>
           <a:prstGeom prst="roundRect">
             <a:avLst/>
           </a:prstGeom>
           <a:solidFill>
-            <a:srgbClr val="1E293B"/>
+            <a:srgbClr val="ECFDF5"/>
           </a:solidFill>
           <a:ln>
             <a:solidFill>
-              <a:srgbClr val="10B981"/>
+              <a:srgbClr val="A7F3D0"/>
             </a:solidFill>
           </a:ln>
         </p:spPr>
@@ -5332,14 +5747,14 @@
       </p:sp>
       <p:sp>
         <p:nvSpPr>
-          <p:cNvPr id="10" name="TextBox 9"/>
+          <p:cNvPr id="11" name="TextBox 10"/>
           <p:cNvSpPr txBox="1"/>
           <p:nvPr/>
         </p:nvSpPr>
         <p:spPr>
           <a:xfrm>
             <a:off x="914400" y="5349240"/>
-            <a:ext cx="10332720" cy="822960"/>
+            <a:ext cx="10332720" cy="777240"/>
           </a:xfrm>
           <a:prstGeom prst="rect">
             <a:avLst/>
@@ -5353,9 +5768,9 @@
           <a:lstStyle/>
           <a:p>
             <a:pPr>
-              <a:defRPr sz="1300" b="1">
-                <a:solidFill>
-                  <a:srgbClr val="4ADE80"/>
+              <a:defRPr sz="1250" b="1">
+                <a:solidFill>
+                  <a:srgbClr val="047857"/>
                 </a:solidFill>
               </a:defRPr>
             </a:pPr>
@@ -5368,9 +5783,9 @@
               <a:spcBef>
                 <a:spcPts val="200"/>
               </a:spcBef>
-              <a:defRPr sz="1150">
-                <a:solidFill>
-                  <a:srgbClr val="FFFFFF"/>
+              <a:defRPr sz="1100">
+                <a:solidFill>
+                  <a:srgbClr val="334155"/>
                 </a:solidFill>
               </a:defRPr>
             </a:pPr>
@@ -5407,13 +5822,13 @@
         <p:spPr>
           <a:xfrm>
             <a:off x="0" y="0"/>
-            <a:ext cx="12191695" cy="1051560"/>
+            <a:ext cx="12191695" cy="73152"/>
           </a:xfrm>
           <a:prstGeom prst="rect">
             <a:avLst/>
           </a:prstGeom>
           <a:solidFill>
-            <a:srgbClr val="0F172A"/>
+            <a:srgbClr val="1D4ED8"/>
           </a:solidFill>
           <a:ln>
             <a:noFill/>
@@ -5443,14 +5858,68 @@
       </p:sp>
       <p:sp>
         <p:nvSpPr>
-          <p:cNvPr id="3" name="TextBox 2"/>
+          <p:cNvPr id="3" name="Rounded Rectangle 2"/>
+          <p:cNvSpPr/>
+          <p:nvPr/>
+        </p:nvSpPr>
+        <p:spPr>
+          <a:xfrm>
+            <a:off x="731520" y="320040"/>
+            <a:ext cx="3474720" cy="347472"/>
+          </a:xfrm>
+          <a:prstGeom prst="roundRect">
+            <a:avLst/>
+          </a:prstGeom>
+          <a:solidFill>
+            <a:srgbClr val="EFF6FF"/>
+          </a:solidFill>
+          <a:ln>
+            <a:solidFill>
+              <a:srgbClr val="BFDBFE"/>
+            </a:solidFill>
+          </a:ln>
+        </p:spPr>
+        <p:style>
+          <a:lnRef idx="1">
+            <a:schemeClr val="accent1"/>
+          </a:lnRef>
+          <a:fillRef idx="3">
+            <a:schemeClr val="accent1"/>
+          </a:fillRef>
+          <a:effectRef idx="2">
+            <a:schemeClr val="accent1"/>
+          </a:effectRef>
+          <a:fontRef idx="minor">
+            <a:schemeClr val="lt1"/>
+          </a:fontRef>
+        </p:style>
+        <p:txBody>
+          <a:bodyPr rtlCol="0" anchor="ctr" wrap="none"/>
+          <a:lstStyle/>
+          <a:p>
+            <a:pPr algn="ctr">
+              <a:defRPr sz="1000" b="1">
+                <a:solidFill>
+                  <a:srgbClr val="1D4ED8"/>
+                </a:solidFill>
+              </a:defRPr>
+            </a:pPr>
+            <a:r>
+              <a:t>OWASP TOP 10 • A03:2021 (INJECTION)</a:t>
+            </a:r>
+          </a:p>
+        </p:txBody>
+      </p:sp>
+      <p:sp>
+        <p:nvSpPr>
+          <p:cNvPr id="4" name="TextBox 3"/>
           <p:cNvSpPr txBox="1"/>
           <p:nvPr/>
         </p:nvSpPr>
         <p:spPr>
           <a:xfrm>
-            <a:off x="731520" y="109728"/>
-            <a:ext cx="10698480" cy="274320"/>
+            <a:off x="731520" y="685800"/>
+            <a:ext cx="10698480" cy="548640"/>
           </a:xfrm>
           <a:prstGeom prst="rect">
             <a:avLst/>
@@ -5464,21 +5933,9 @@
           <a:lstStyle/>
           <a:p>
             <a:pPr>
-              <a:defRPr sz="1100" b="1">
-                <a:solidFill>
-                  <a:srgbClr val="E11D48"/>
-                </a:solidFill>
-              </a:defRPr>
-            </a:pPr>
-            <a:r>
-              <a:t>OWASP TOP 10 - A03:2021 (INJECTION)</a:t>
-            </a:r>
-          </a:p>
-          <a:p>
-            <a:pPr>
-              <a:defRPr sz="1900" b="1">
-                <a:solidFill>
-                  <a:srgbClr val="FFFFFF"/>
+              <a:defRPr sz="2100" b="1">
+                <a:solidFill>
+                  <a:srgbClr val="0F172A"/>
                 </a:solidFill>
               </a:defRPr>
             </a:pPr>
@@ -5490,7 +5947,7 @@
       </p:sp>
       <p:sp>
         <p:nvSpPr>
-          <p:cNvPr id="4" name="TextBox 3"/>
+          <p:cNvPr id="5" name="TextBox 4"/>
           <p:cNvSpPr txBox="1"/>
           <p:nvPr/>
         </p:nvSpPr>
@@ -5518,21 +5975,176 @@
               </a:defRPr>
             </a:pPr>
             <a:r>
-              <a:t>Nhóm WNC.G01 (HOU) • Môn Lập Trình Web Nâng Cao • ThS. Lê Hữu Dũng</a:t>
-            </a:r>
-          </a:p>
-        </p:txBody>
-      </p:sp>
-      <p:sp>
-        <p:nvSpPr>
-          <p:cNvPr id="5" name="Rounded Rectangle 4"/>
+              <a:t>Nhóm WNC.G01 • Trường Đại học Mở Hà Nội (HOU) • GVHD: ThS. Lê Hữu Dũng</a:t>
+            </a:r>
+          </a:p>
+        </p:txBody>
+      </p:sp>
+      <p:sp>
+        <p:nvSpPr>
+          <p:cNvPr id="6" name="Rounded Rectangle 5"/>
           <p:cNvSpPr/>
           <p:nvPr/>
         </p:nvSpPr>
         <p:spPr>
           <a:xfrm>
-            <a:off x="731520" y="1234440"/>
-            <a:ext cx="5212080" cy="4937760"/>
+            <a:off x="731520" y="1325880"/>
+            <a:ext cx="5120640" cy="4846320"/>
+          </a:xfrm>
+          <a:prstGeom prst="roundRect">
+            <a:avLst/>
+          </a:prstGeom>
+          <a:solidFill>
+            <a:srgbClr val="ECFDF5"/>
+          </a:solidFill>
+          <a:ln>
+            <a:solidFill>
+              <a:srgbClr val="A7F3D0"/>
+            </a:solidFill>
+          </a:ln>
+        </p:spPr>
+        <p:style>
+          <a:lnRef idx="1">
+            <a:schemeClr val="accent1"/>
+          </a:lnRef>
+          <a:fillRef idx="3">
+            <a:schemeClr val="accent1"/>
+          </a:fillRef>
+          <a:effectRef idx="2">
+            <a:schemeClr val="accent1"/>
+          </a:effectRef>
+          <a:fontRef idx="minor">
+            <a:schemeClr val="lt1"/>
+          </a:fontRef>
+        </p:style>
+        <p:txBody>
+          <a:bodyPr rtlCol="0" anchor="ctr"/>
+          <a:lstStyle/>
+          <a:p>
+            <a:pPr algn="ctr"/>
+          </a:p>
+        </p:txBody>
+      </p:sp>
+      <p:sp>
+        <p:nvSpPr>
+          <p:cNvPr id="7" name="TextBox 6"/>
+          <p:cNvSpPr txBox="1"/>
+          <p:nvPr/>
+        </p:nvSpPr>
+        <p:spPr>
+          <a:xfrm>
+            <a:off x="914400" y="1463040"/>
+            <a:ext cx="4754880" cy="4572000"/>
+          </a:xfrm>
+          <a:prstGeom prst="rect">
+            <a:avLst/>
+          </a:prstGeom>
+          <a:noFill/>
+        </p:spPr>
+        <p:txBody>
+          <a:bodyPr wrap="square">
+            <a:spAutoFit/>
+          </a:bodyPr>
+          <a:lstStyle/>
+          <a:p>
+            <a:pPr>
+              <a:defRPr sz="1500" b="1">
+                <a:solidFill>
+                  <a:srgbClr val="047857"/>
+                </a:solidFill>
+              </a:defRPr>
+            </a:pPr>
+            <a:r>
+              <a:t>Cách Viết Code Chuẩn Hóa Với EF Core</a:t>
+            </a:r>
+          </a:p>
+          <a:p>
+            <a:pPr>
+              <a:spcBef>
+                <a:spcPts val="800"/>
+              </a:spcBef>
+              <a:defRPr sz="1000">
+                <a:solidFill>
+                  <a:srgbClr val="065F46"/>
+                </a:solidFill>
+                <a:latin typeface="Courier New"/>
+              </a:defRPr>
+            </a:pPr>
+            <a:r>
+              <a:t>// Dùng LINQ Parameterized (KHUYÊN DÙNG):</a:t>
+            </a:r>
+            <a:br/>
+            <a:r>
+              <a:t>var account = _context.Accounts</a:t>
+            </a:r>
+            <a:br/>
+            <a:r>
+              <a:t>    .FirstOrDefault(a =&gt; a.Username == user </a:t>
+            </a:r>
+            <a:br/>
+            <a:r>
+              <a:t>                      &amp;&amp; a.Password == pass);</a:t>
+            </a:r>
+            <a:br/>
+            <a:br/>
+            <a:r>
+              <a:t>// Hoặc dùng FromSqlInterpolated nếu viết SQL thuần:</a:t>
+            </a:r>
+            <a:br/>
+            <a:r>
+              <a:t>var account = _context.Accounts</a:t>
+            </a:r>
+            <a:br/>
+            <a:r>
+              <a:t>    .FromSqlInterpolated($"SELECT * FROM Accounts WHERE Username={user} AND Password={pass}")</a:t>
+            </a:r>
+            <a:br/>
+            <a:r>
+              <a:t>    .FirstOrDefault();</a:t>
+            </a:r>
+          </a:p>
+          <a:p>
+            <a:pPr>
+              <a:spcBef>
+                <a:spcPts val="1200"/>
+              </a:spcBef>
+              <a:defRPr sz="1300" b="1">
+                <a:solidFill>
+                  <a:srgbClr val="0F172A"/>
+                </a:solidFill>
+              </a:defRPr>
+            </a:pPr>
+            <a:r>
+              <a:t>Tại sao cách này an toàn tuyệt đối?</a:t>
+            </a:r>
+          </a:p>
+          <a:p>
+            <a:pPr>
+              <a:spcBef>
+                <a:spcPts val="400"/>
+              </a:spcBef>
+              <a:defRPr sz="1200">
+                <a:solidFill>
+                  <a:srgbClr val="334155"/>
+                </a:solidFill>
+              </a:defRPr>
+            </a:pPr>
+            <a:r>
+              <a:t>SQL Server biên dịch cấu trúc lệnh TRƯỚC khi gán dữ liệu. Biến @p0 nhận toàn bộ payload như một chuỗi chữ bình thường, vô hiệu hóa hoàn toàn ý đồ chèn lệnh.</a:t>
+            </a:r>
+          </a:p>
+        </p:txBody>
+      </p:sp>
+      <p:sp>
+        <p:nvSpPr>
+          <p:cNvPr id="8" name="Rounded Rectangle 7"/>
+          <p:cNvSpPr/>
+          <p:nvPr/>
+        </p:nvSpPr>
+        <p:spPr>
+          <a:xfrm>
+            <a:off x="6217920" y="1325880"/>
+            <a:ext cx="5212080" cy="4846320"/>
           </a:xfrm>
           <a:prstGeom prst="roundRect">
             <a:avLst/>
@@ -5542,7 +6154,7 @@
           </a:solidFill>
           <a:ln>
             <a:solidFill>
-              <a:srgbClr val="10B981"/>
+              <a:srgbClr val="E2E8F0"/>
             </a:solidFill>
           </a:ln>
         </p:spPr>
@@ -5570,13 +6182,13 @@
       </p:sp>
       <p:sp>
         <p:nvSpPr>
-          <p:cNvPr id="6" name="TextBox 5"/>
+          <p:cNvPr id="9" name="TextBox 8"/>
           <p:cNvSpPr txBox="1"/>
           <p:nvPr/>
         </p:nvSpPr>
         <p:spPr>
           <a:xfrm>
-            <a:off x="914400" y="1371600"/>
+            <a:off x="6400800" y="1463040"/>
             <a:ext cx="4846320" cy="4572000"/>
           </a:xfrm>
           <a:prstGeom prst="rect">
@@ -5591,119 +6203,9 @@
           <a:lstStyle/>
           <a:p>
             <a:pPr>
-              <a:defRPr sz="1400" b="1">
-                <a:solidFill>
-                  <a:srgbClr val="10B981"/>
-                </a:solidFill>
-              </a:defRPr>
-            </a:pPr>
-            <a:r>
-              <a:t>Cách Viết Code Chuẩn Hóa Với EF Core</a:t>
-            </a:r>
-          </a:p>
-          <a:p>
-            <a:pPr>
-              <a:spcBef>
-                <a:spcPts val="800"/>
-              </a:spcBef>
-              <a:defRPr sz="1000">
-                <a:solidFill>
-                  <a:srgbClr val="166534"/>
-                </a:solidFill>
-                <a:latin typeface="Courier New"/>
-              </a:defRPr>
-            </a:pPr>
-            <a:r>
-              <a:t>// Dùng LINQ Parameterized (KHUYÊN DÙNG):</a:t>
-            </a:r>
-            <a:br/>
-            <a:r>
-              <a:t>var account = _context.Accounts</a:t>
-            </a:r>
-            <a:br/>
-            <a:r>
-              <a:t>    .FirstOrDefault(a =&gt; a.Username == user </a:t>
-            </a:r>
-            <a:br/>
-            <a:r>
-              <a:t>                      &amp;&amp; a.Password == pass);</a:t>
-            </a:r>
-            <a:br/>
-            <a:br/>
-            <a:r>
-              <a:t>// Hoặc dùng FromSqlInterpolated nếu viết SQL thuần:</a:t>
-            </a:r>
-            <a:br/>
-            <a:r>
-              <a:t>var account = _context.Accounts</a:t>
-            </a:r>
-            <a:br/>
-            <a:r>
-              <a:t>    .FromSqlInterpolated($"SELECT * FROM Accounts WHERE Username={user} AND Password={pass}")</a:t>
-            </a:r>
-            <a:br/>
-            <a:r>
-              <a:t>    .FirstOrDefault();</a:t>
-            </a:r>
-          </a:p>
-          <a:p>
-            <a:pPr>
-              <a:spcBef>
-                <a:spcPts val="1200"/>
-              </a:spcBef>
-              <a:defRPr sz="1200" b="1">
-                <a:solidFill>
-                  <a:srgbClr val="1E293B"/>
-                </a:solidFill>
-              </a:defRPr>
-            </a:pPr>
-            <a:r>
-              <a:t>Tại sao cách này an toàn tuyệt đối?</a:t>
-            </a:r>
-          </a:p>
-          <a:p>
-            <a:pPr>
-              <a:spcBef>
-                <a:spcPts val="400"/>
-              </a:spcBef>
-              <a:defRPr sz="1150">
-                <a:solidFill>
-                  <a:srgbClr val="64748B"/>
-                </a:solidFill>
-              </a:defRPr>
-            </a:pPr>
-            <a:r>
-              <a:t>SQL Server biên dịch cấu trúc lệnh TRƯỚC khi gán dữ liệu. Biến @p0 nhận toàn bộ payload như một chuỗi chữ bình thường, vô hiệu hóa hoàn toàn ý đồ chèn lệnh.</a:t>
-            </a:r>
-          </a:p>
-        </p:txBody>
-      </p:sp>
-      <p:sp>
-        <p:nvSpPr>
-          <p:cNvPr id="7" name="TextBox 6"/>
-          <p:cNvSpPr txBox="1"/>
-          <p:nvPr/>
-        </p:nvSpPr>
-        <p:spPr>
-          <a:xfrm>
-            <a:off x="6309360" y="1234440"/>
-            <a:ext cx="5120640" cy="4937760"/>
-          </a:xfrm>
-          <a:prstGeom prst="rect">
-            <a:avLst/>
-          </a:prstGeom>
-          <a:noFill/>
-        </p:spPr>
-        <p:txBody>
-          <a:bodyPr wrap="square">
-            <a:spAutoFit/>
-          </a:bodyPr>
-          <a:lstStyle/>
-          <a:p>
-            <a:pPr>
               <a:defRPr sz="1500" b="1">
                 <a:solidFill>
-                  <a:srgbClr val="2563EB"/>
+                  <a:srgbClr val="1D4ED8"/>
                 </a:solidFill>
               </a:defRPr>
             </a:pPr>
@@ -5718,7 +6220,7 @@
               </a:spcBef>
               <a:defRPr sz="1200">
                 <a:solidFill>
-                  <a:srgbClr val="1E293B"/>
+                  <a:srgbClr val="334155"/>
                 </a:solidFill>
               </a:defRPr>
             </a:pPr>
@@ -5737,7 +6239,7 @@
               </a:spcBef>
               <a:defRPr sz="1200">
                 <a:solidFill>
-                  <a:srgbClr val="1E293B"/>
+                  <a:srgbClr val="334155"/>
                 </a:solidFill>
               </a:defRPr>
             </a:pPr>
@@ -5756,7 +6258,7 @@
               </a:spcBef>
               <a:defRPr sz="1200">
                 <a:solidFill>
-                  <a:srgbClr val="1E293B"/>
+                  <a:srgbClr val="334155"/>
                 </a:solidFill>
               </a:defRPr>
             </a:pPr>
@@ -5775,7 +6277,7 @@
               </a:spcBef>
               <a:defRPr sz="1200">
                 <a:solidFill>
-                  <a:srgbClr val="1E293B"/>
+                  <a:srgbClr val="334155"/>
                 </a:solidFill>
               </a:defRPr>
             </a:pPr>
@@ -5816,13 +6318,13 @@
         <p:spPr>
           <a:xfrm>
             <a:off x="0" y="0"/>
-            <a:ext cx="12191695" cy="1051560"/>
+            <a:ext cx="12191695" cy="73152"/>
           </a:xfrm>
           <a:prstGeom prst="rect">
             <a:avLst/>
           </a:prstGeom>
           <a:solidFill>
-            <a:srgbClr val="0F172A"/>
+            <a:srgbClr val="1D4ED8"/>
           </a:solidFill>
           <a:ln>
             <a:noFill/>
@@ -5852,14 +6354,68 @@
       </p:sp>
       <p:sp>
         <p:nvSpPr>
-          <p:cNvPr id="3" name="TextBox 2"/>
+          <p:cNvPr id="3" name="Rounded Rectangle 2"/>
+          <p:cNvSpPr/>
+          <p:nvPr/>
+        </p:nvSpPr>
+        <p:spPr>
+          <a:xfrm>
+            <a:off x="731520" y="320040"/>
+            <a:ext cx="3474720" cy="347472"/>
+          </a:xfrm>
+          <a:prstGeom prst="roundRect">
+            <a:avLst/>
+          </a:prstGeom>
+          <a:solidFill>
+            <a:srgbClr val="EFF6FF"/>
+          </a:solidFill>
+          <a:ln>
+            <a:solidFill>
+              <a:srgbClr val="BFDBFE"/>
+            </a:solidFill>
+          </a:ln>
+        </p:spPr>
+        <p:style>
+          <a:lnRef idx="1">
+            <a:schemeClr val="accent1"/>
+          </a:lnRef>
+          <a:fillRef idx="3">
+            <a:schemeClr val="accent1"/>
+          </a:fillRef>
+          <a:effectRef idx="2">
+            <a:schemeClr val="accent1"/>
+          </a:effectRef>
+          <a:fontRef idx="minor">
+            <a:schemeClr val="lt1"/>
+          </a:fontRef>
+        </p:style>
+        <p:txBody>
+          <a:bodyPr rtlCol="0" anchor="ctr" wrap="none"/>
+          <a:lstStyle/>
+          <a:p>
+            <a:pPr algn="ctr">
+              <a:defRPr sz="1000" b="1">
+                <a:solidFill>
+                  <a:srgbClr val="1D4ED8"/>
+                </a:solidFill>
+              </a:defRPr>
+            </a:pPr>
+            <a:r>
+              <a:t>OWASP TOP 10 • A03:2021 (INJECTION)</a:t>
+            </a:r>
+          </a:p>
+        </p:txBody>
+      </p:sp>
+      <p:sp>
+        <p:nvSpPr>
+          <p:cNvPr id="4" name="TextBox 3"/>
           <p:cNvSpPr txBox="1"/>
           <p:nvPr/>
         </p:nvSpPr>
         <p:spPr>
           <a:xfrm>
-            <a:off x="731520" y="109728"/>
-            <a:ext cx="10698480" cy="274320"/>
+            <a:off x="731520" y="685800"/>
+            <a:ext cx="10698480" cy="548640"/>
           </a:xfrm>
           <a:prstGeom prst="rect">
             <a:avLst/>
@@ -5873,21 +6429,9 @@
           <a:lstStyle/>
           <a:p>
             <a:pPr>
-              <a:defRPr sz="1100" b="1">
-                <a:solidFill>
-                  <a:srgbClr val="E11D48"/>
-                </a:solidFill>
-              </a:defRPr>
-            </a:pPr>
-            <a:r>
-              <a:t>OWASP TOP 10 - A03:2021 (INJECTION)</a:t>
-            </a:r>
-          </a:p>
-          <a:p>
-            <a:pPr>
-              <a:defRPr sz="1900" b="1">
-                <a:solidFill>
-                  <a:srgbClr val="FFFFFF"/>
+              <a:defRPr sz="2100" b="1">
+                <a:solidFill>
+                  <a:srgbClr val="0F172A"/>
                 </a:solidFill>
               </a:defRPr>
             </a:pPr>
@@ -5899,7 +6443,7 @@
       </p:sp>
       <p:sp>
         <p:nvSpPr>
-          <p:cNvPr id="4" name="TextBox 3"/>
+          <p:cNvPr id="5" name="TextBox 4"/>
           <p:cNvSpPr txBox="1"/>
           <p:nvPr/>
         </p:nvSpPr>
@@ -5927,21 +6471,66 @@
               </a:defRPr>
             </a:pPr>
             <a:r>
-              <a:t>Nhóm WNC.G01 (HOU) • Môn Lập Trình Web Nâng Cao • ThS. Lê Hữu Dũng</a:t>
-            </a:r>
-          </a:p>
-        </p:txBody>
-      </p:sp>
-      <p:sp>
-        <p:nvSpPr>
-          <p:cNvPr id="5" name="TextBox 4"/>
+              <a:t>Nhóm WNC.G01 • Trường Đại học Mở Hà Nội (HOU) • GVHD: ThS. Lê Hữu Dũng</a:t>
+            </a:r>
+          </a:p>
+        </p:txBody>
+      </p:sp>
+      <p:sp>
+        <p:nvSpPr>
+          <p:cNvPr id="6" name="Rounded Rectangle 5"/>
+          <p:cNvSpPr/>
+          <p:nvPr/>
+        </p:nvSpPr>
+        <p:spPr>
+          <a:xfrm>
+            <a:off x="731520" y="1325880"/>
+            <a:ext cx="10728655" cy="4846320"/>
+          </a:xfrm>
+          <a:prstGeom prst="roundRect">
+            <a:avLst/>
+          </a:prstGeom>
+          <a:solidFill>
+            <a:srgbClr val="F8FAFC"/>
+          </a:solidFill>
+          <a:ln>
+            <a:solidFill>
+              <a:srgbClr val="E2E8F0"/>
+            </a:solidFill>
+          </a:ln>
+        </p:spPr>
+        <p:style>
+          <a:lnRef idx="1">
+            <a:schemeClr val="accent1"/>
+          </a:lnRef>
+          <a:fillRef idx="3">
+            <a:schemeClr val="accent1"/>
+          </a:fillRef>
+          <a:effectRef idx="2">
+            <a:schemeClr val="accent1"/>
+          </a:effectRef>
+          <a:fontRef idx="minor">
+            <a:schemeClr val="lt1"/>
+          </a:fontRef>
+        </p:style>
+        <p:txBody>
+          <a:bodyPr rtlCol="0" anchor="ctr"/>
+          <a:lstStyle/>
+          <a:p>
+            <a:pPr algn="ctr"/>
+          </a:p>
+        </p:txBody>
+      </p:sp>
+      <p:sp>
+        <p:nvSpPr>
+          <p:cNvPr id="7" name="TextBox 6"/>
           <p:cNvSpPr txBox="1"/>
           <p:nvPr/>
         </p:nvSpPr>
         <p:spPr>
           <a:xfrm>
-            <a:off x="914400" y="1371600"/>
-            <a:ext cx="10362895" cy="4572000"/>
+            <a:off x="1005840" y="1508760"/>
+            <a:ext cx="10149840" cy="4389120"/>
           </a:xfrm>
           <a:prstGeom prst="rect">
             <a:avLst/>
@@ -5955,14 +6544,14 @@
           <a:lstStyle/>
           <a:p>
             <a:pPr>
-              <a:defRPr sz="1700" b="1">
-                <a:solidFill>
-                  <a:srgbClr val="E11D48"/>
-                </a:solidFill>
-              </a:defRPr>
-            </a:pPr>
-            <a:r>
-              <a:t>BÀI HỌC VÀ CAM KẾT CHUẨN AN TOÀN CHO ĐỀ TÀI BTL (WNC.G01):</a:t>
+              <a:defRPr sz="1600" b="1">
+                <a:solidFill>
+                  <a:srgbClr val="BE123C"/>
+                </a:solidFill>
+              </a:defRPr>
+            </a:pPr>
+            <a:r>
+              <a:t>CAM KẾT CHUẨN AN TOÀN CHO ĐỀ TÀI BTL (WNC.G01):</a:t>
             </a:r>
           </a:p>
           <a:p>
@@ -5970,9 +6559,9 @@
               <a:spcBef>
                 <a:spcPts val="1200"/>
               </a:spcBef>
-              <a:defRPr sz="1350">
-                <a:solidFill>
-                  <a:srgbClr val="1E293B"/>
+              <a:defRPr sz="1300">
+                <a:solidFill>
+                  <a:srgbClr val="334155"/>
                 </a:solidFill>
               </a:defRPr>
             </a:pPr>
@@ -5985,9 +6574,9 @@
               <a:spcBef>
                 <a:spcPts val="1000"/>
               </a:spcBef>
-              <a:defRPr sz="1350">
-                <a:solidFill>
-                  <a:srgbClr val="1E293B"/>
+              <a:defRPr sz="1300">
+                <a:solidFill>
+                  <a:srgbClr val="334155"/>
                 </a:solidFill>
               </a:defRPr>
             </a:pPr>
@@ -6000,9 +6589,9 @@
               <a:spcBef>
                 <a:spcPts val="1000"/>
               </a:spcBef>
-              <a:defRPr sz="1350">
-                <a:solidFill>
-                  <a:srgbClr val="1E293B"/>
+              <a:defRPr sz="1300">
+                <a:solidFill>
+                  <a:srgbClr val="334155"/>
                 </a:solidFill>
               </a:defRPr>
             </a:pPr>
@@ -6015,9 +6604,9 @@
               <a:spcBef>
                 <a:spcPts val="2200"/>
               </a:spcBef>
-              <a:defRPr sz="1550" b="1">
-                <a:solidFill>
-                  <a:srgbClr val="2563EB"/>
+              <a:defRPr sz="1500" b="1">
+                <a:solidFill>
+                  <a:srgbClr val="1D4ED8"/>
                 </a:solidFill>
               </a:defRPr>
             </a:pPr>

</xml_diff>